<commit_message>
Align GPR report style with project progress template
</commit_message>
<xml_diff>
--- a/GPR算法报告_2026-03-02.pptx
+++ b/GPR算法报告_2026-03-02.pptx
@@ -3281,7 +3281,7 @@
       </p:grpSpPr>
       <p:sp>
         <p:nvSpPr>
-          <p:cNvPr id="4" name="矩形 3"/>
+          <p:cNvPr id="2" name="矩形 1"/>
           <p:cNvSpPr/>
           <p:nvPr/>
         </p:nvSpPr>
@@ -3329,14 +3329,14 @@
       </p:sp>
       <p:sp>
         <p:nvSpPr>
-          <p:cNvPr id="2" name="矩形 1"/>
+          <p:cNvPr id="6" name="矩形 5"/>
           <p:cNvSpPr/>
           <p:nvPr/>
         </p:nvSpPr>
         <p:spPr>
           <a:xfrm>
-            <a:off x="-1" y="2863273"/>
-            <a:ext cx="12192001" cy="820641"/>
+            <a:off x="0" y="3145810"/>
+            <a:ext cx="12192000" cy="511511"/>
           </a:xfrm>
           <a:prstGeom prst="rect">
             <a:avLst/>
@@ -3375,7 +3375,7 @@
       </p:sp>
       <p:sp>
         <p:nvSpPr>
-          <p:cNvPr id="5" name="等腰三角形 4"/>
+          <p:cNvPr id="3" name="等腰三角形 2"/>
           <p:cNvSpPr/>
           <p:nvPr/>
         </p:nvSpPr>
@@ -3421,46 +3421,64 @@
           </a:p>
         </p:txBody>
       </p:sp>
-      <p:pic>
-        <p:nvPicPr>
-          <p:cNvPr id="14" name="图片 13"/>
-          <p:cNvPicPr>
-            <a:picLocks noChangeAspect="1"/>
-          </p:cNvPicPr>
-          <p:nvPr/>
-        </p:nvPicPr>
-        <p:blipFill>
-          <a:blip r:embed="rId1" cstate="print">
-            <a:extLst>
-              <a:ext uri="{28A0092B-C50C-407E-A947-70E740481C1C}">
-                <a14:useLocalDpi xmlns:a14="http://schemas.microsoft.com/office/drawing/2010/main" val="0"/>
-              </a:ext>
-            </a:extLst>
-          </a:blip>
-          <a:stretch>
-            <a:fillRect/>
-          </a:stretch>
-        </p:blipFill>
-        <p:spPr>
-          <a:xfrm>
-            <a:off x="3355138" y="-1224195"/>
-            <a:ext cx="5613803" cy="3969178"/>
-          </a:xfrm>
-          <a:prstGeom prst="rect">
-            <a:avLst/>
-          </a:prstGeom>
-        </p:spPr>
-      </p:pic>
-      <p:sp>
-        <p:nvSpPr>
-          <p:cNvPr id="15" name="文本框 14"/>
+      <p:sp>
+        <p:nvSpPr>
+          <p:cNvPr id="5" name="矩形: 圆角 4"/>
+          <p:cNvSpPr/>
+          <p:nvPr/>
+        </p:nvSpPr>
+        <p:spPr>
+          <a:xfrm>
+            <a:off x="3213510" y="1953928"/>
+            <a:ext cx="1146413" cy="1146413"/>
+          </a:xfrm>
+          <a:prstGeom prst="roundRect">
+            <a:avLst/>
+          </a:prstGeom>
+          <a:solidFill>
+            <a:schemeClr val="accent1">
+              <a:lumMod val="50000"/>
+            </a:schemeClr>
+          </a:solidFill>
+          <a:ln>
+            <a:noFill/>
+          </a:ln>
+        </p:spPr>
+        <p:style>
+          <a:lnRef idx="2">
+            <a:schemeClr val="accent1">
+              <a:shade val="15000"/>
+            </a:schemeClr>
+          </a:lnRef>
+          <a:fillRef idx="1">
+            <a:schemeClr val="accent1"/>
+          </a:fillRef>
+          <a:effectRef idx="0">
+            <a:schemeClr val="accent1"/>
+          </a:effectRef>
+          <a:fontRef idx="minor">
+            <a:schemeClr val="lt1"/>
+          </a:fontRef>
+        </p:style>
+        <p:txBody>
+          <a:bodyPr rtlCol="0" anchor="ctr"/>
+          <a:lstStyle/>
+          <a:p>
+            <a:pPr algn="ctr"/>
+            <a:endParaRPr lang="zh-CN" altLang="en-US"/>
+          </a:p>
+        </p:txBody>
+      </p:sp>
+      <p:sp>
+        <p:nvSpPr>
+          <p:cNvPr id="7" name="文本框 6"/>
           <p:cNvSpPr txBox="1"/>
           <p:nvPr/>
         </p:nvSpPr>
         <p:spPr>
           <a:xfrm>
-            <a:off x="1526058" y="2023995"/>
-            <a:ext cx="9139883" cy="1198880"/>
+            <a:off x="3213510" y="1953927"/>
+            <a:ext cx="1146413" cy="1107996"/>
           </a:xfrm>
           <a:prstGeom prst="rect">
             <a:avLst/>
@@ -3475,7 +3493,49 @@
           <a:p>
             <a:pPr algn="ctr"/>
             <a:r>
-              <a:rPr lang="zh-CN" altLang="en-US" sz="7200" b="1" dirty="0">
+              <a:rPr lang="en-US" altLang="zh-CN" sz="6600" dirty="0">
+                <a:solidFill>
+                  <a:schemeClr val="bg1"/>
+                </a:solidFill>
+                <a:latin typeface="黑体" panose="02010609060101010101" pitchFamily="49" charset="-122"/>
+                <a:ea typeface="黑体" panose="02010609060101010101" pitchFamily="49" charset="-122"/>
+              </a:rPr>
+              <a:t/>
+            </a:r>
+            <a:endParaRPr lang="zh-CN" altLang="en-US" sz="6600" dirty="0">
+              <a:solidFill>
+                <a:schemeClr val="bg1"/>
+              </a:solidFill>
+              <a:latin typeface="黑体" panose="02010609060101010101" pitchFamily="49" charset="-122"/>
+              <a:ea typeface="黑体" panose="02010609060101010101" pitchFamily="49" charset="-122"/>
+            </a:endParaRPr>
+          </a:p>
+        </p:txBody>
+      </p:sp>
+      <p:sp>
+        <p:nvSpPr>
+          <p:cNvPr id="8" name="文本框 7"/>
+          <p:cNvSpPr txBox="1"/>
+          <p:nvPr/>
+        </p:nvSpPr>
+        <p:spPr>
+          <a:xfrm>
+            <a:off x="4770090" y="1887378"/>
+            <a:ext cx="7014949" cy="1107996"/>
+          </a:xfrm>
+          <a:prstGeom prst="rect">
+            <a:avLst/>
+          </a:prstGeom>
+          <a:noFill/>
+        </p:spPr>
+        <p:txBody>
+          <a:bodyPr wrap="square" rtlCol="0">
+            <a:spAutoFit/>
+          </a:bodyPr>
+          <a:lstStyle/>
+          <a:p>
+            <a:r>
+              <a:rPr lang="zh-CN" altLang="en-US" sz="6600" dirty="0">
                 <a:solidFill>
                   <a:schemeClr val="accent1">
                     <a:lumMod val="50000"/>
@@ -3484,47 +3544,73 @@
                 <a:latin typeface="黑体" panose="02010609060101010101" pitchFamily="49" charset="-122"/>
                 <a:ea typeface="黑体" panose="02010609060101010101" pitchFamily="49" charset="-122"/>
               </a:rPr>
-              <a:t>探地雷达(GPR)</a:t>
-            </a:r>
-            <a:r>
-              <a:rPr lang="en-US" altLang="zh-CN" sz="7200" b="1" dirty="0">
+              <a:t>探地雷达(GPR)信号处理技术报告</a:t>
+            </a:r>
+          </a:p>
+        </p:txBody>
+      </p:sp>
+      <p:sp>
+        <p:nvSpPr>
+          <p:cNvPr id="9" name="文本框 8"/>
+          <p:cNvSpPr txBox="1"/>
+          <p:nvPr/>
+        </p:nvSpPr>
+        <p:spPr>
+          <a:xfrm>
+            <a:off x="4827883" y="2986066"/>
+            <a:ext cx="5105067" cy="830997"/>
+          </a:xfrm>
+          <a:prstGeom prst="rect">
+            <a:avLst/>
+          </a:prstGeom>
+          <a:noFill/>
+        </p:spPr>
+        <p:txBody>
+          <a:bodyPr wrap="square" rtlCol="0">
+            <a:spAutoFit/>
+          </a:bodyPr>
+          <a:lstStyle/>
+          <a:p>
+            <a:pPr algn="ctr"/>
+            <a:r>
+              <a:rPr lang="en-US" altLang="zh-CN" sz="2400" b="1" dirty="0">
                 <a:solidFill>
                   <a:schemeClr val="accent1">
                     <a:lumMod val="50000"/>
                   </a:schemeClr>
                 </a:solidFill>
-                <a:latin typeface="黑体" panose="02010609060101010101" pitchFamily="49" charset="-122"/>
-                <a:ea typeface="黑体" panose="02010609060101010101" pitchFamily="49" charset="-122"/>
+                <a:latin typeface="+mj-ea"/>
+                <a:ea typeface="+mj-ea"/>
               </a:rPr>
-              <a:t>信号处理</a:t>
-            </a:r>
-            <a:r>
-              <a:rPr lang="zh-CN" altLang="en-US" sz="7200" b="1" dirty="0">
-                <a:solidFill>
-                  <a:schemeClr val="accent1">
-                    <a:lumMod val="50000"/>
-                  </a:schemeClr>
-                </a:solidFill>
-                <a:latin typeface="黑体" panose="02010609060101010101" pitchFamily="49" charset="-122"/>
-                <a:ea typeface="黑体" panose="02010609060101010101" pitchFamily="49" charset="-122"/>
-              </a:rPr>
-              <a:t>技术报告</a:t>
-            </a:r>
-            <a:endParaRPr lang="zh-CN" altLang="en-US" sz="7200" b="1" dirty="0">
+              <a:t>GPR Signal Processing Technical Report</a:t>
+            </a:r>
+            <a:endParaRPr lang="zh-CN" altLang="en-US" sz="2400" b="1" dirty="0">
               <a:solidFill>
                 <a:schemeClr val="accent1">
                   <a:lumMod val="50000"/>
                 </a:schemeClr>
               </a:solidFill>
-              <a:latin typeface="黑体" panose="02010609060101010101" pitchFamily="49" charset="-122"/>
-              <a:ea typeface="黑体" panose="02010609060101010101" pitchFamily="49" charset="-122"/>
+              <a:latin typeface="+mj-ea"/>
+              <a:ea typeface="+mj-ea"/>
+            </a:endParaRPr>
+          </a:p>
+          <a:p>
+            <a:pPr algn="ctr"/>
+            <a:endParaRPr lang="zh-CN" altLang="en-US" sz="2400" b="1" dirty="0">
+              <a:solidFill>
+                <a:schemeClr val="accent1">
+                  <a:lumMod val="50000"/>
+                </a:schemeClr>
+              </a:solidFill>
+              <a:latin typeface="+mj-ea"/>
+              <a:ea typeface="+mj-ea"/>
             </a:endParaRPr>
           </a:p>
         </p:txBody>
       </p:sp>
       <p:pic>
         <p:nvPicPr>
-          <p:cNvPr id="8" name="图片 7"/>
+          <p:cNvPr id="10" name="图片 9"/>
           <p:cNvPicPr>
             <a:picLocks noChangeAspect="1"/>
           </p:cNvPicPr>
@@ -3544,8 +3630,8 @@
         </p:blipFill>
         <p:spPr>
           <a:xfrm>
-            <a:off x="-538695" y="2510234"/>
-            <a:ext cx="4106356" cy="5808507"/>
+            <a:off x="-199740" y="-736009"/>
+            <a:ext cx="3920726" cy="2772106"/>
           </a:xfrm>
           <a:prstGeom prst="rect">
             <a:avLst/>
@@ -3554,14 +3640,14 @@
       </p:pic>
       <p:pic>
         <p:nvPicPr>
-          <p:cNvPr id="9" name="图片 8"/>
+          <p:cNvPr id="18" name="图片 17"/>
           <p:cNvPicPr>
             <a:picLocks noChangeAspect="1"/>
           </p:cNvPicPr>
           <p:nvPr/>
         </p:nvPicPr>
         <p:blipFill>
-          <a:blip r:embed="rId2" cstate="print">
+          <a:blip r:embed="rId3">
             <a:extLst>
               <a:ext uri="{28A0092B-C50C-407E-A947-70E740481C1C}">
                 <a14:useLocalDpi xmlns:a14="http://schemas.microsoft.com/office/drawing/2010/main" val="0"/>
@@ -3574,85 +3660,8 @@
         </p:blipFill>
         <p:spPr>
           <a:xfrm>
-            <a:off x="8750326" y="2497567"/>
-            <a:ext cx="4106356" cy="5808507"/>
-          </a:xfrm>
-          <a:prstGeom prst="rect">
-            <a:avLst/>
-          </a:prstGeom>
-        </p:spPr>
-      </p:pic>
-      <p:sp>
-        <p:nvSpPr>
-          <p:cNvPr id="10" name="文本框 9"/>
-          <p:cNvSpPr txBox="1"/>
-          <p:nvPr/>
-        </p:nvSpPr>
-        <p:spPr>
-          <a:xfrm>
-            <a:off x="1910080" y="3273593"/>
-            <a:ext cx="8503920" cy="460375"/>
-          </a:xfrm>
-          <a:prstGeom prst="rect">
-            <a:avLst/>
-          </a:prstGeom>
-          <a:noFill/>
-        </p:spPr>
-        <p:txBody>
-          <a:bodyPr wrap="square" rtlCol="0">
-            <a:spAutoFit/>
-          </a:bodyPr>
-          <a:lstStyle/>
-          <a:p>
-            <a:pPr algn="ctr"/>
-            <a:r>
-              <a:rPr lang="en-US" altLang="zh-CN" sz="2400" b="1" dirty="0">
-                <a:solidFill>
-                  <a:schemeClr val="accent1">
-                    <a:lumMod val="50000"/>
-                  </a:schemeClr>
-                </a:solidFill>
-                <a:latin typeface="+mj-ea"/>
-                <a:ea typeface="+mj-ea"/>
-              </a:rPr>
-              <a:t>GPR Signal Processing Technical Report</a:t>
-            </a:r>
-            <a:endParaRPr lang="en-US" altLang="zh-CN" sz="2400" b="1" dirty="0">
-              <a:solidFill>
-                <a:schemeClr val="accent1">
-                  <a:lumMod val="50000"/>
-                </a:schemeClr>
-              </a:solidFill>
-              <a:latin typeface="+mj-ea"/>
-              <a:ea typeface="+mj-ea"/>
-            </a:endParaRPr>
-          </a:p>
-        </p:txBody>
-      </p:sp>
-      <p:pic>
-        <p:nvPicPr>
-          <p:cNvPr id="12" name="图片 11"/>
-          <p:cNvPicPr>
-            <a:picLocks noChangeAspect="1"/>
-          </p:cNvPicPr>
-          <p:nvPr/>
-        </p:nvPicPr>
-        <p:blipFill>
-          <a:blip r:embed="rId3" cstate="print">
-            <a:extLst>
-              <a:ext uri="{28A0092B-C50C-407E-A947-70E740481C1C}">
-                <a14:useLocalDpi xmlns:a14="http://schemas.microsoft.com/office/drawing/2010/main" val="0"/>
-              </a:ext>
-            </a:extLst>
-          </a:blip>
-          <a:stretch>
-            <a:fillRect/>
-          </a:stretch>
-        </p:blipFill>
-        <p:spPr>
-          <a:xfrm>
-            <a:off x="884087" y="4128820"/>
-            <a:ext cx="1297380" cy="917298"/>
+            <a:off x="-591998" y="-2131690"/>
+            <a:ext cx="6958694" cy="15014702"/>
           </a:xfrm>
           <a:prstGeom prst="rect">
             <a:avLst/>
@@ -3661,7 +3670,7 @@
       </p:pic>
       <p:pic>
         <p:nvPicPr>
-          <p:cNvPr id="17" name="图片 16"/>
+          <p:cNvPr id="20" name="图片 19"/>
           <p:cNvPicPr>
             <a:picLocks noChangeAspect="1"/>
           </p:cNvPicPr>
@@ -3675,14 +3684,13 @@
               </a:ext>
             </a:extLst>
           </a:blip>
-          <a:stretch>
-            <a:fillRect/>
-          </a:stretch>
+          <a:srcRect t="39915"/>
+          <a:stretch/>
         </p:blipFill>
         <p:spPr>
           <a:xfrm>
-            <a:off x="10298444" y="4196415"/>
-            <a:ext cx="1049120" cy="741768"/>
+            <a:off x="4312984" y="4833257"/>
+            <a:ext cx="6401043" cy="5440260"/>
           </a:xfrm>
           <a:prstGeom prst="rect">
             <a:avLst/>
@@ -3691,7 +3699,7 @@
       </p:pic>
       <p:pic>
         <p:nvPicPr>
-          <p:cNvPr id="6" name="图片 5"/>
+          <p:cNvPr id="22" name="图片 21"/>
           <p:cNvPicPr>
             <a:picLocks noChangeAspect="1"/>
           </p:cNvPicPr>
@@ -3711,68 +3719,8 @@
         </p:blipFill>
         <p:spPr>
           <a:xfrm>
-            <a:off x="2181466" y="5045466"/>
-            <a:ext cx="3379313" cy="2353017"/>
-          </a:xfrm>
-          <a:prstGeom prst="rect">
-            <a:avLst/>
-          </a:prstGeom>
-        </p:spPr>
-      </p:pic>
-      <p:pic>
-        <p:nvPicPr>
-          <p:cNvPr id="11" name="图片 10"/>
-          <p:cNvPicPr>
-            <a:picLocks noChangeAspect="1"/>
-          </p:cNvPicPr>
-          <p:nvPr/>
-        </p:nvPicPr>
-        <p:blipFill>
-          <a:blip r:embed="rId6" cstate="print">
-            <a:extLst>
-              <a:ext uri="{28A0092B-C50C-407E-A947-70E740481C1C}">
-                <a14:useLocalDpi xmlns:a14="http://schemas.microsoft.com/office/drawing/2010/main" val="0"/>
-              </a:ext>
-            </a:extLst>
-          </a:blip>
-          <a:stretch>
-            <a:fillRect/>
-          </a:stretch>
-        </p:blipFill>
-        <p:spPr>
-          <a:xfrm>
-            <a:off x="5333885" y="5021990"/>
-            <a:ext cx="2005365" cy="2836622"/>
-          </a:xfrm>
-          <a:prstGeom prst="rect">
-            <a:avLst/>
-          </a:prstGeom>
-        </p:spPr>
-      </p:pic>
-      <p:pic>
-        <p:nvPicPr>
-          <p:cNvPr id="13" name="图片 12"/>
-          <p:cNvPicPr>
-            <a:picLocks noChangeAspect="1"/>
-          </p:cNvPicPr>
-          <p:nvPr/>
-        </p:nvPicPr>
-        <p:blipFill>
-          <a:blip r:embed="rId7" cstate="print">
-            <a:extLst>
-              <a:ext uri="{28A0092B-C50C-407E-A947-70E740481C1C}">
-                <a14:useLocalDpi xmlns:a14="http://schemas.microsoft.com/office/drawing/2010/main" val="0"/>
-              </a:ext>
-            </a:extLst>
-          </a:blip>
-          <a:stretch>
-            <a:fillRect/>
-          </a:stretch>
-        </p:blipFill>
-        <p:spPr>
-          <a:xfrm>
-            <a:off x="6382139" y="5045465"/>
-            <a:ext cx="3473447" cy="2353017"/>
+            <a:off x="9752598" y="4172642"/>
+            <a:ext cx="2822398" cy="3992327"/>
           </a:xfrm>
           <a:prstGeom prst="rect">
             <a:avLst/>
@@ -4353,6 +4301,14 @@
 <file path=ppt/slides/slide2.xml><?xml version="1.0" encoding="utf-8"?>
 <p:sld xmlns:a="http://schemas.openxmlformats.org/drawingml/2006/main" xmlns:r="http://schemas.openxmlformats.org/officeDocument/2006/relationships" xmlns:p="http://schemas.openxmlformats.org/presentationml/2006/main">
   <p:cSld>
+    <p:bg>
+      <p:bgPr>
+        <a:solidFill>
+          <a:schemeClr val="bg1"/>
+        </a:solidFill>
+        <a:effectLst/>
+      </p:bgPr>
+    </p:bg>
     <p:spTree>
       <p:nvGrpSpPr>
         <p:cNvPr id="1" name=""/>
@@ -4369,559 +4325,14 @@
       </p:grpSpPr>
       <p:sp>
         <p:nvSpPr>
-          <p:cNvPr id="5" name="矩形 4"/>
-          <p:cNvSpPr/>
-          <p:nvPr/>
-        </p:nvSpPr>
-        <p:spPr>
-          <a:xfrm>
-            <a:off x="0" y="0"/>
-            <a:ext cx="12192000" cy="6858000"/>
-          </a:xfrm>
-          <a:prstGeom prst="rect">
-            <a:avLst/>
-          </a:prstGeom>
-          <a:solidFill>
-            <a:schemeClr val="accent1">
-              <a:lumMod val="50000"/>
-            </a:schemeClr>
-          </a:solidFill>
-          <a:ln>
-            <a:noFill/>
-          </a:ln>
-        </p:spPr>
-        <p:style>
-          <a:lnRef idx="2">
-            <a:schemeClr val="accent1">
-              <a:shade val="15000"/>
-            </a:schemeClr>
-          </a:lnRef>
-          <a:fillRef idx="1">
-            <a:schemeClr val="accent1"/>
-          </a:fillRef>
-          <a:effectRef idx="0">
-            <a:schemeClr val="accent1"/>
-          </a:effectRef>
-          <a:fontRef idx="minor">
-            <a:schemeClr val="lt1"/>
-          </a:fontRef>
-        </p:style>
-        <p:txBody>
-          <a:bodyPr rtlCol="0" anchor="ctr"/>
-          <a:lstStyle/>
-          <a:p>
-            <a:pPr algn="ctr"/>
-            <a:endParaRPr lang="zh-CN" altLang="en-US"/>
-          </a:p>
-        </p:txBody>
-      </p:sp>
-      <p:sp>
-        <p:nvSpPr>
-          <p:cNvPr id="28" name="椭圆 27"/>
-          <p:cNvSpPr/>
-          <p:nvPr/>
-        </p:nvSpPr>
-        <p:spPr>
-          <a:xfrm>
-            <a:off x="443842" y="1602149"/>
-            <a:ext cx="4013563" cy="3895891"/>
-          </a:xfrm>
-          <a:prstGeom prst="ellipse">
-            <a:avLst/>
-          </a:prstGeom>
-          <a:solidFill>
-            <a:schemeClr val="bg1"/>
-          </a:solidFill>
-          <a:ln>
-            <a:noFill/>
-          </a:ln>
-        </p:spPr>
-        <p:style>
-          <a:lnRef idx="2">
-            <a:schemeClr val="accent1">
-              <a:shade val="15000"/>
-            </a:schemeClr>
-          </a:lnRef>
-          <a:fillRef idx="1">
-            <a:schemeClr val="accent1"/>
-          </a:fillRef>
-          <a:effectRef idx="0">
-            <a:schemeClr val="accent1"/>
-          </a:effectRef>
-          <a:fontRef idx="minor">
-            <a:schemeClr val="lt1"/>
-          </a:fontRef>
-        </p:style>
-        <p:txBody>
-          <a:bodyPr rtlCol="0" anchor="ctr"/>
-          <a:lstStyle/>
-          <a:p>
-            <a:pPr algn="ctr"/>
-            <a:endParaRPr lang="zh-CN" altLang="en-US"/>
-          </a:p>
-        </p:txBody>
-      </p:sp>
-      <p:sp>
-        <p:nvSpPr>
-          <p:cNvPr id="29" name="椭圆 28"/>
-          <p:cNvSpPr/>
-          <p:nvPr/>
-        </p:nvSpPr>
-        <p:spPr>
-          <a:xfrm>
-            <a:off x="729177" y="1876352"/>
-            <a:ext cx="3442892" cy="3341951"/>
-          </a:xfrm>
-          <a:prstGeom prst="ellipse">
-            <a:avLst/>
-          </a:prstGeom>
-          <a:solidFill>
-            <a:schemeClr val="accent1">
-              <a:lumMod val="50000"/>
-            </a:schemeClr>
-          </a:solidFill>
-          <a:ln>
-            <a:noFill/>
-          </a:ln>
-        </p:spPr>
-        <p:style>
-          <a:lnRef idx="2">
-            <a:schemeClr val="accent1">
-              <a:shade val="15000"/>
-            </a:schemeClr>
-          </a:lnRef>
-          <a:fillRef idx="1">
-            <a:schemeClr val="accent1"/>
-          </a:fillRef>
-          <a:effectRef idx="0">
-            <a:schemeClr val="accent1"/>
-          </a:effectRef>
-          <a:fontRef idx="minor">
-            <a:schemeClr val="lt1"/>
-          </a:fontRef>
-        </p:style>
-        <p:txBody>
-          <a:bodyPr rtlCol="0" anchor="ctr"/>
-          <a:lstStyle/>
-          <a:p>
-            <a:pPr algn="ctr"/>
-            <a:endParaRPr lang="zh-CN" altLang="en-US"/>
-          </a:p>
-        </p:txBody>
-      </p:sp>
-      <p:sp>
-        <p:nvSpPr>
-          <p:cNvPr id="4" name="等腰三角形 3"/>
-          <p:cNvSpPr/>
-          <p:nvPr/>
-        </p:nvSpPr>
-        <p:spPr>
-          <a:xfrm rot="16200000">
-            <a:off x="23162" y="1616824"/>
-            <a:ext cx="10302766" cy="3604570"/>
-          </a:xfrm>
-          <a:prstGeom prst="triangle">
-            <a:avLst/>
-          </a:prstGeom>
-          <a:solidFill>
-            <a:schemeClr val="accent1">
-              <a:lumMod val="60000"/>
-              <a:lumOff val="40000"/>
-            </a:schemeClr>
-          </a:solidFill>
-          <a:ln>
-            <a:noFill/>
-          </a:ln>
-          <a:effectLst>
-            <a:innerShdw blurRad="63500" dist="50800" dir="13500000">
-              <a:prstClr val="black">
-                <a:alpha val="50000"/>
-              </a:prstClr>
-            </a:innerShdw>
-          </a:effectLst>
-        </p:spPr>
-        <p:style>
-          <a:lnRef idx="2">
-            <a:schemeClr val="accent1">
-              <a:shade val="15000"/>
-            </a:schemeClr>
-          </a:lnRef>
-          <a:fillRef idx="1">
-            <a:schemeClr val="accent1"/>
-          </a:fillRef>
-          <a:effectRef idx="0">
-            <a:schemeClr val="accent1"/>
-          </a:effectRef>
-          <a:fontRef idx="minor">
-            <a:schemeClr val="lt1"/>
-          </a:fontRef>
-        </p:style>
-        <p:txBody>
-          <a:bodyPr rtlCol="0" anchor="ctr"/>
-          <a:lstStyle/>
-          <a:p>
-            <a:pPr algn="ctr"/>
-            <a:endParaRPr lang="zh-CN" altLang="en-US" dirty="0"/>
-          </a:p>
-        </p:txBody>
-      </p:sp>
-      <p:sp>
-        <p:nvSpPr>
-          <p:cNvPr id="3" name="等腰三角形 2"/>
-          <p:cNvSpPr/>
-          <p:nvPr/>
-        </p:nvSpPr>
-        <p:spPr>
-          <a:xfrm rot="16200000">
-            <a:off x="676035" y="1606932"/>
-            <a:ext cx="10302766" cy="3604570"/>
-          </a:xfrm>
-          <a:prstGeom prst="triangle">
-            <a:avLst/>
-          </a:prstGeom>
-          <a:solidFill>
-            <a:schemeClr val="accent5">
-              <a:lumMod val="20000"/>
-              <a:lumOff val="80000"/>
-            </a:schemeClr>
-          </a:solidFill>
-          <a:ln>
-            <a:noFill/>
-          </a:ln>
-          <a:effectLst>
-            <a:innerShdw blurRad="63500" dist="50800" dir="13500000">
-              <a:prstClr val="black">
-                <a:alpha val="50000"/>
-              </a:prstClr>
-            </a:innerShdw>
-          </a:effectLst>
-        </p:spPr>
-        <p:style>
-          <a:lnRef idx="2">
-            <a:schemeClr val="accent1">
-              <a:shade val="15000"/>
-            </a:schemeClr>
-          </a:lnRef>
-          <a:fillRef idx="1">
-            <a:schemeClr val="accent1"/>
-          </a:fillRef>
-          <a:effectRef idx="0">
-            <a:schemeClr val="accent1"/>
-          </a:effectRef>
-          <a:fontRef idx="minor">
-            <a:schemeClr val="lt1"/>
-          </a:fontRef>
-        </p:style>
-        <p:txBody>
-          <a:bodyPr rtlCol="0" anchor="ctr"/>
-          <a:lstStyle/>
-          <a:p>
-            <a:pPr algn="ctr"/>
-            <a:endParaRPr lang="zh-CN" altLang="en-US" dirty="0"/>
-          </a:p>
-        </p:txBody>
-      </p:sp>
-      <p:sp>
-        <p:nvSpPr>
-          <p:cNvPr id="2" name="等腰三角形 1"/>
-          <p:cNvSpPr/>
-          <p:nvPr/>
-        </p:nvSpPr>
-        <p:spPr>
-          <a:xfrm rot="16200000">
-            <a:off x="1414460" y="1626715"/>
-            <a:ext cx="10302766" cy="3604570"/>
-          </a:xfrm>
-          <a:prstGeom prst="triangle">
-            <a:avLst/>
-          </a:prstGeom>
-          <a:solidFill>
-            <a:schemeClr val="bg1"/>
-          </a:solidFill>
-          <a:ln>
-            <a:noFill/>
-          </a:ln>
-          <a:effectLst>
-            <a:innerShdw blurRad="63500" dist="50800" dir="13500000">
-              <a:prstClr val="black">
-                <a:alpha val="50000"/>
-              </a:prstClr>
-            </a:innerShdw>
-          </a:effectLst>
-        </p:spPr>
-        <p:style>
-          <a:lnRef idx="2">
-            <a:schemeClr val="accent1">
-              <a:shade val="15000"/>
-            </a:schemeClr>
-          </a:lnRef>
-          <a:fillRef idx="1">
-            <a:schemeClr val="accent1"/>
-          </a:fillRef>
-          <a:effectRef idx="0">
-            <a:schemeClr val="accent1"/>
-          </a:effectRef>
-          <a:fontRef idx="minor">
-            <a:schemeClr val="lt1"/>
-          </a:fontRef>
-        </p:style>
-        <p:txBody>
-          <a:bodyPr rtlCol="0" anchor="ctr"/>
-          <a:lstStyle/>
-          <a:p>
-            <a:pPr algn="ctr"/>
-            <a:endParaRPr lang="zh-CN" altLang="en-US" dirty="0"/>
-          </a:p>
-        </p:txBody>
-      </p:sp>
-      <p:sp>
-        <p:nvSpPr>
-          <p:cNvPr id="7" name="矩形 6"/>
-          <p:cNvSpPr/>
-          <p:nvPr/>
-        </p:nvSpPr>
-        <p:spPr>
-          <a:xfrm>
-            <a:off x="7865195" y="0"/>
-            <a:ext cx="4326806" cy="6858000"/>
-          </a:xfrm>
-          <a:prstGeom prst="rect">
-            <a:avLst/>
-          </a:prstGeom>
-          <a:solidFill>
-            <a:schemeClr val="bg1"/>
-          </a:solidFill>
-          <a:ln>
-            <a:noFill/>
-          </a:ln>
-        </p:spPr>
-        <p:style>
-          <a:lnRef idx="2">
-            <a:schemeClr val="accent1">
-              <a:shade val="15000"/>
-            </a:schemeClr>
-          </a:lnRef>
-          <a:fillRef idx="1">
-            <a:schemeClr val="accent1"/>
-          </a:fillRef>
-          <a:effectRef idx="0">
-            <a:schemeClr val="accent1"/>
-          </a:effectRef>
-          <a:fontRef idx="minor">
-            <a:schemeClr val="lt1"/>
-          </a:fontRef>
-        </p:style>
-        <p:txBody>
-          <a:bodyPr rtlCol="0" anchor="ctr"/>
-          <a:lstStyle/>
-          <a:p>
-            <a:pPr algn="ctr"/>
-            <a:endParaRPr lang="zh-CN" altLang="en-US"/>
-          </a:p>
-        </p:txBody>
-      </p:sp>
-      <p:sp>
-        <p:nvSpPr>
-          <p:cNvPr id="11" name="椭圆 10"/>
-          <p:cNvSpPr/>
-          <p:nvPr/>
-        </p:nvSpPr>
-        <p:spPr>
-          <a:xfrm>
-            <a:off x="7022615" y="3744283"/>
-            <a:ext cx="913947" cy="887151"/>
-          </a:xfrm>
-          <a:prstGeom prst="ellipse">
-            <a:avLst/>
-          </a:prstGeom>
-          <a:solidFill>
-            <a:schemeClr val="accent1">
-              <a:lumMod val="50000"/>
-            </a:schemeClr>
-          </a:solidFill>
-          <a:ln>
-            <a:noFill/>
-          </a:ln>
-        </p:spPr>
-        <p:style>
-          <a:lnRef idx="2">
-            <a:schemeClr val="accent1">
-              <a:shade val="15000"/>
-            </a:schemeClr>
-          </a:lnRef>
-          <a:fillRef idx="1">
-            <a:schemeClr val="accent1"/>
-          </a:fillRef>
-          <a:effectRef idx="0">
-            <a:schemeClr val="accent1"/>
-          </a:effectRef>
-          <a:fontRef idx="minor">
-            <a:schemeClr val="lt1"/>
-          </a:fontRef>
-        </p:style>
-        <p:txBody>
-          <a:bodyPr rtlCol="0" anchor="ctr"/>
-          <a:lstStyle/>
-          <a:p>
-            <a:pPr algn="ctr"/>
-            <a:endParaRPr lang="zh-CN" altLang="en-US"/>
-          </a:p>
-        </p:txBody>
-      </p:sp>
-      <p:sp>
-        <p:nvSpPr>
-          <p:cNvPr id="12" name="椭圆 11"/>
-          <p:cNvSpPr/>
-          <p:nvPr/>
-        </p:nvSpPr>
-        <p:spPr>
-          <a:xfrm>
-            <a:off x="7022615" y="777169"/>
-            <a:ext cx="913947" cy="887151"/>
-          </a:xfrm>
-          <a:prstGeom prst="ellipse">
-            <a:avLst/>
-          </a:prstGeom>
-          <a:solidFill>
-            <a:schemeClr val="accent1">
-              <a:lumMod val="50000"/>
-            </a:schemeClr>
-          </a:solidFill>
-          <a:ln>
-            <a:noFill/>
-          </a:ln>
-        </p:spPr>
-        <p:style>
-          <a:lnRef idx="2">
-            <a:schemeClr val="accent1">
-              <a:shade val="15000"/>
-            </a:schemeClr>
-          </a:lnRef>
-          <a:fillRef idx="1">
-            <a:schemeClr val="accent1"/>
-          </a:fillRef>
-          <a:effectRef idx="0">
-            <a:schemeClr val="accent1"/>
-          </a:effectRef>
-          <a:fontRef idx="minor">
-            <a:schemeClr val="lt1"/>
-          </a:fontRef>
-        </p:style>
-        <p:txBody>
-          <a:bodyPr rtlCol="0" anchor="ctr"/>
-          <a:lstStyle/>
-          <a:p>
-            <a:pPr algn="ctr"/>
-            <a:endParaRPr lang="zh-CN" altLang="en-US"/>
-          </a:p>
-        </p:txBody>
-      </p:sp>
-      <p:sp>
-        <p:nvSpPr>
-          <p:cNvPr id="13" name="椭圆 12"/>
-          <p:cNvSpPr/>
-          <p:nvPr/>
-        </p:nvSpPr>
-        <p:spPr>
-          <a:xfrm>
-            <a:off x="7022615" y="2260726"/>
-            <a:ext cx="913947" cy="887151"/>
-          </a:xfrm>
-          <a:prstGeom prst="ellipse">
-            <a:avLst/>
-          </a:prstGeom>
-          <a:solidFill>
-            <a:schemeClr val="accent1">
-              <a:lumMod val="50000"/>
-            </a:schemeClr>
-          </a:solidFill>
-          <a:ln>
-            <a:noFill/>
-          </a:ln>
-        </p:spPr>
-        <p:style>
-          <a:lnRef idx="2">
-            <a:schemeClr val="accent1">
-              <a:shade val="15000"/>
-            </a:schemeClr>
-          </a:lnRef>
-          <a:fillRef idx="1">
-            <a:schemeClr val="accent1"/>
-          </a:fillRef>
-          <a:effectRef idx="0">
-            <a:schemeClr val="accent1"/>
-          </a:effectRef>
-          <a:fontRef idx="minor">
-            <a:schemeClr val="lt1"/>
-          </a:fontRef>
-        </p:style>
-        <p:txBody>
-          <a:bodyPr rtlCol="0" anchor="ctr"/>
-          <a:lstStyle/>
-          <a:p>
-            <a:pPr algn="ctr"/>
-            <a:endParaRPr lang="zh-CN" altLang="en-US" dirty="0"/>
-          </a:p>
-        </p:txBody>
-      </p:sp>
-      <p:sp>
-        <p:nvSpPr>
-          <p:cNvPr id="14" name="椭圆 13"/>
-          <p:cNvSpPr/>
-          <p:nvPr/>
-        </p:nvSpPr>
-        <p:spPr>
-          <a:xfrm>
-            <a:off x="7022615" y="5257422"/>
-            <a:ext cx="913947" cy="887151"/>
-          </a:xfrm>
-          <a:prstGeom prst="ellipse">
-            <a:avLst/>
-          </a:prstGeom>
-          <a:solidFill>
-            <a:schemeClr val="accent1">
-              <a:lumMod val="50000"/>
-            </a:schemeClr>
-          </a:solidFill>
-          <a:ln>
-            <a:noFill/>
-          </a:ln>
-        </p:spPr>
-        <p:style>
-          <a:lnRef idx="2">
-            <a:schemeClr val="accent1">
-              <a:shade val="15000"/>
-            </a:schemeClr>
-          </a:lnRef>
-          <a:fillRef idx="1">
-            <a:schemeClr val="accent1"/>
-          </a:fillRef>
-          <a:effectRef idx="0">
-            <a:schemeClr val="accent1"/>
-          </a:effectRef>
-          <a:fontRef idx="minor">
-            <a:schemeClr val="lt1"/>
-          </a:fontRef>
-        </p:style>
-        <p:txBody>
-          <a:bodyPr rtlCol="0" anchor="ctr"/>
-          <a:lstStyle/>
-          <a:p>
-            <a:pPr algn="ctr"/>
-            <a:endParaRPr lang="zh-CN" altLang="en-US"/>
-          </a:p>
-        </p:txBody>
-      </p:sp>
-      <p:sp>
-        <p:nvSpPr>
-          <p:cNvPr id="15" name="文本框 14"/>
+          <p:cNvPr id="40" name="文本框 39"/>
           <p:cNvSpPr txBox="1"/>
           <p:nvPr/>
         </p:nvSpPr>
         <p:spPr>
           <a:xfrm>
-            <a:off x="7184260" y="823006"/>
-            <a:ext cx="728286" cy="707886"/>
+            <a:off x="1429309" y="1908944"/>
+            <a:ext cx="4349262" cy="460375"/>
           </a:xfrm>
           <a:prstGeom prst="rect">
             <a:avLst/>
@@ -4935,178 +4346,7 @@
           <a:lstStyle/>
           <a:p>
             <a:r>
-              <a:rPr lang="en-US" altLang="zh-CN" sz="4000" dirty="0">
-                <a:solidFill>
-                  <a:schemeClr val="bg1"/>
-                </a:solidFill>
-                <a:latin typeface="黑体" panose="02010609060101010101" pitchFamily="49" charset="-122"/>
-                <a:ea typeface="黑体" panose="02010609060101010101" pitchFamily="49" charset="-122"/>
-              </a:rPr>
-              <a:t>01</a:t>
-            </a:r>
-            <a:endParaRPr lang="zh-CN" altLang="en-US" sz="4000" dirty="0">
-              <a:solidFill>
-                <a:schemeClr val="bg1"/>
-              </a:solidFill>
-              <a:latin typeface="黑体" panose="02010609060101010101" pitchFamily="49" charset="-122"/>
-              <a:ea typeface="黑体" panose="02010609060101010101" pitchFamily="49" charset="-122"/>
-            </a:endParaRPr>
-          </a:p>
-        </p:txBody>
-      </p:sp>
-      <p:sp>
-        <p:nvSpPr>
-          <p:cNvPr id="16" name="文本框 15"/>
-          <p:cNvSpPr txBox="1"/>
-          <p:nvPr/>
-        </p:nvSpPr>
-        <p:spPr>
-          <a:xfrm>
-            <a:off x="7127236" y="2322620"/>
-            <a:ext cx="737958" cy="707886"/>
-          </a:xfrm>
-          <a:prstGeom prst="rect">
-            <a:avLst/>
-          </a:prstGeom>
-          <a:noFill/>
-        </p:spPr>
-        <p:txBody>
-          <a:bodyPr wrap="square" rtlCol="0">
-            <a:spAutoFit/>
-          </a:bodyPr>
-          <a:lstStyle/>
-          <a:p>
-            <a:pPr algn="ctr"/>
-            <a:r>
-              <a:rPr lang="en-US" altLang="zh-CN" sz="4000" dirty="0">
-                <a:solidFill>
-                  <a:schemeClr val="bg1"/>
-                </a:solidFill>
-                <a:latin typeface="黑体" panose="02010609060101010101" pitchFamily="49" charset="-122"/>
-                <a:ea typeface="黑体" panose="02010609060101010101" pitchFamily="49" charset="-122"/>
-              </a:rPr>
-              <a:t>02</a:t>
-            </a:r>
-            <a:endParaRPr lang="zh-CN" altLang="en-US" sz="4000" dirty="0">
-              <a:solidFill>
-                <a:schemeClr val="bg1"/>
-              </a:solidFill>
-              <a:latin typeface="黑体" panose="02010609060101010101" pitchFamily="49" charset="-122"/>
-              <a:ea typeface="黑体" panose="02010609060101010101" pitchFamily="49" charset="-122"/>
-            </a:endParaRPr>
-          </a:p>
-        </p:txBody>
-      </p:sp>
-      <p:sp>
-        <p:nvSpPr>
-          <p:cNvPr id="17" name="文本框 16"/>
-          <p:cNvSpPr txBox="1"/>
-          <p:nvPr/>
-        </p:nvSpPr>
-        <p:spPr>
-          <a:xfrm>
-            <a:off x="7029140" y="3779941"/>
-            <a:ext cx="877634" cy="707886"/>
-          </a:xfrm>
-          <a:prstGeom prst="rect">
-            <a:avLst/>
-          </a:prstGeom>
-          <a:noFill/>
-        </p:spPr>
-        <p:txBody>
-          <a:bodyPr wrap="square" rtlCol="0">
-            <a:spAutoFit/>
-          </a:bodyPr>
-          <a:lstStyle/>
-          <a:p>
-            <a:pPr algn="ctr"/>
-            <a:r>
-              <a:rPr lang="en-US" altLang="zh-CN" sz="4000" dirty="0">
-                <a:solidFill>
-                  <a:schemeClr val="bg1"/>
-                </a:solidFill>
-                <a:latin typeface="黑体" panose="02010609060101010101" pitchFamily="49" charset="-122"/>
-                <a:ea typeface="黑体" panose="02010609060101010101" pitchFamily="49" charset="-122"/>
-              </a:rPr>
-              <a:t>03</a:t>
-            </a:r>
-            <a:endParaRPr lang="zh-CN" altLang="en-US" sz="4000" dirty="0">
-              <a:solidFill>
-                <a:schemeClr val="bg1"/>
-              </a:solidFill>
-              <a:latin typeface="黑体" panose="02010609060101010101" pitchFamily="49" charset="-122"/>
-              <a:ea typeface="黑体" panose="02010609060101010101" pitchFamily="49" charset="-122"/>
-            </a:endParaRPr>
-          </a:p>
-        </p:txBody>
-      </p:sp>
-      <p:sp>
-        <p:nvSpPr>
-          <p:cNvPr id="18" name="文本框 17"/>
-          <p:cNvSpPr txBox="1"/>
-          <p:nvPr/>
-        </p:nvSpPr>
-        <p:spPr>
-          <a:xfrm>
-            <a:off x="7030696" y="5306645"/>
-            <a:ext cx="913947" cy="707886"/>
-          </a:xfrm>
-          <a:prstGeom prst="rect">
-            <a:avLst/>
-          </a:prstGeom>
-          <a:noFill/>
-        </p:spPr>
-        <p:txBody>
-          <a:bodyPr wrap="square" rtlCol="0">
-            <a:spAutoFit/>
-          </a:bodyPr>
-          <a:lstStyle/>
-          <a:p>
-            <a:pPr algn="ctr"/>
-            <a:r>
-              <a:rPr lang="en-US" altLang="zh-CN" sz="4000" dirty="0">
-                <a:solidFill>
-                  <a:schemeClr val="bg1"/>
-                </a:solidFill>
-                <a:latin typeface="黑体" panose="02010609060101010101" pitchFamily="49" charset="-122"/>
-                <a:ea typeface="黑体" panose="02010609060101010101" pitchFamily="49" charset="-122"/>
-              </a:rPr>
-              <a:t>04</a:t>
-            </a:r>
-            <a:endParaRPr lang="zh-CN" altLang="en-US" sz="4000" dirty="0">
-              <a:solidFill>
-                <a:schemeClr val="bg1"/>
-              </a:solidFill>
-              <a:latin typeface="黑体" panose="02010609060101010101" pitchFamily="49" charset="-122"/>
-              <a:ea typeface="黑体" panose="02010609060101010101" pitchFamily="49" charset="-122"/>
-            </a:endParaRPr>
-          </a:p>
-        </p:txBody>
-      </p:sp>
-      <p:sp>
-        <p:nvSpPr>
-          <p:cNvPr id="19" name="文本框 18"/>
-          <p:cNvSpPr txBox="1"/>
-          <p:nvPr/>
-        </p:nvSpPr>
-        <p:spPr>
-          <a:xfrm>
-            <a:off x="8239011" y="812229"/>
-            <a:ext cx="4217158" cy="707886"/>
-          </a:xfrm>
-          <a:prstGeom prst="rect">
-            <a:avLst/>
-          </a:prstGeom>
-          <a:noFill/>
-        </p:spPr>
-        <p:txBody>
-          <a:bodyPr wrap="square" rtlCol="0">
-            <a:spAutoFit/>
-          </a:bodyPr>
-          <a:lstStyle/>
-          <a:p>
-            <a:r>
-              <a:rPr lang="zh-CN" altLang="en-US" sz="4000" dirty="0">
+              <a:rPr lang="zh-CN" altLang="en-US" sz="2400" dirty="0">
                 <a:solidFill>
                   <a:schemeClr val="accent1">
                     <a:lumMod val="50000"/>
@@ -5117,28 +4357,19 @@
               </a:rPr>
               <a:t>原始方法与问题</a:t>
             </a:r>
-            <a:endParaRPr lang="zh-CN" altLang="en-US" sz="4000" dirty="0">
-              <a:solidFill>
-                <a:schemeClr val="accent1">
-                  <a:lumMod val="50000"/>
-                </a:schemeClr>
-              </a:solidFill>
-              <a:latin typeface="黑体" panose="02010609060101010101" pitchFamily="49" charset="-122"/>
-              <a:ea typeface="黑体" panose="02010609060101010101" pitchFamily="49" charset="-122"/>
-            </a:endParaRPr>
-          </a:p>
-        </p:txBody>
-      </p:sp>
-      <p:sp>
-        <p:nvSpPr>
-          <p:cNvPr id="20" name="文本框 19"/>
+          </a:p>
+        </p:txBody>
+      </p:sp>
+      <p:sp>
+        <p:nvSpPr>
+          <p:cNvPr id="43" name="文本框 42"/>
           <p:cNvSpPr txBox="1"/>
           <p:nvPr/>
         </p:nvSpPr>
         <p:spPr>
           <a:xfrm>
-            <a:off x="8301517" y="2245280"/>
-            <a:ext cx="3411940" cy="707886"/>
+            <a:off x="1468755" y="2370455"/>
+            <a:ext cx="9497695" cy="645160"/>
           </a:xfrm>
           <a:prstGeom prst="rect">
             <a:avLst/>
@@ -5152,39 +4383,22 @@
           <a:lstStyle/>
           <a:p>
             <a:r>
-              <a:rPr lang="zh-CN" altLang="en-US" sz="4000" dirty="0">
-                <a:solidFill>
-                  <a:schemeClr val="accent1">
-                    <a:lumMod val="50000"/>
-                  </a:schemeClr>
-                </a:solidFill>
-                <a:latin typeface="黑体" panose="02010609060101010101" pitchFamily="49" charset="-122"/>
-                <a:ea typeface="黑体" panose="02010609060101010101" pitchFamily="49" charset="-122"/>
-              </a:rPr>
-              <a:t>文献调研与改进</a:t>
-            </a:r>
-            <a:endParaRPr lang="zh-CN" altLang="en-US" sz="4000" dirty="0">
-              <a:solidFill>
-                <a:schemeClr val="accent1">
-                  <a:lumMod val="50000"/>
-                </a:schemeClr>
-              </a:solidFill>
-              <a:latin typeface="黑体" panose="02010609060101010101" pitchFamily="49" charset="-122"/>
-              <a:ea typeface="黑体" panose="02010609060101010101" pitchFamily="49" charset="-122"/>
-            </a:endParaRPr>
-          </a:p>
-        </p:txBody>
-      </p:sp>
-      <p:sp>
-        <p:nvSpPr>
-          <p:cNvPr id="21" name="文本框 20"/>
+              <a:rPr lang="zh-CN" altLang="en-US" dirty="0"/>
+              <a:t>原始方法与问题</a:t>
+            </a:r>
+          </a:p>
+        </p:txBody>
+      </p:sp>
+      <p:sp>
+        <p:nvSpPr>
+          <p:cNvPr id="7" name="文本框 6"/>
           <p:cNvSpPr txBox="1"/>
           <p:nvPr/>
         </p:nvSpPr>
         <p:spPr>
           <a:xfrm>
-            <a:off x="8301517" y="3783310"/>
-            <a:ext cx="2970400" cy="707886"/>
+            <a:off x="1290320" y="1459847"/>
+            <a:ext cx="5628640" cy="584775"/>
           </a:xfrm>
           <a:prstGeom prst="rect">
             <a:avLst/>
@@ -5198,85 +4412,28 @@
           <a:lstStyle/>
           <a:p>
             <a:r>
-              <a:rPr lang="zh-CN" altLang="en-US" sz="4000" dirty="0">
+              <a:rPr lang="zh-CN" altLang="en-US" sz="3200" dirty="0">
                 <a:solidFill>
-                  <a:schemeClr val="accent1">
-                    <a:lumMod val="50000"/>
-                  </a:schemeClr>
-                </a:solidFill>
-                <a:latin typeface="黑体" panose="02010609060101010101" pitchFamily="49" charset="-122"/>
-                <a:ea typeface="黑体" panose="02010609060101010101" pitchFamily="49" charset="-122"/>
-              </a:rPr>
-              <a:t>消融指标对比</a:t>
-            </a:r>
-            <a:endParaRPr lang="zh-CN" altLang="en-US" sz="4000" dirty="0">
-              <a:solidFill>
-                <a:schemeClr val="accent1">
-                  <a:lumMod val="50000"/>
-                </a:schemeClr>
-              </a:solidFill>
-              <a:latin typeface="黑体" panose="02010609060101010101" pitchFamily="49" charset="-122"/>
-              <a:ea typeface="黑体" panose="02010609060101010101" pitchFamily="49" charset="-122"/>
-            </a:endParaRPr>
-          </a:p>
-        </p:txBody>
-      </p:sp>
-      <p:sp>
-        <p:nvSpPr>
-          <p:cNvPr id="22" name="文本框 21"/>
-          <p:cNvSpPr txBox="1"/>
-          <p:nvPr/>
-        </p:nvSpPr>
-        <p:spPr>
-          <a:xfrm>
-            <a:off x="8313835" y="5377693"/>
-            <a:ext cx="3524252" cy="707886"/>
-          </a:xfrm>
-          <a:prstGeom prst="rect">
-            <a:avLst/>
-          </a:prstGeom>
-          <a:noFill/>
-        </p:spPr>
-        <p:txBody>
-          <a:bodyPr wrap="square" rtlCol="0">
-            <a:spAutoFit/>
-          </a:bodyPr>
-          <a:lstStyle/>
-          <a:p>
-            <a:r>
-              <a:rPr lang="zh-CN" altLang="en-US" sz="4000" dirty="0">
-                <a:solidFill>
-                  <a:schemeClr val="accent1">
-                    <a:lumMod val="50000"/>
-                  </a:schemeClr>
+                  <a:schemeClr val="bg1"/>
                 </a:solidFill>
                 <a:latin typeface="黑体" panose="02010609060101010101" pitchFamily="49" charset="-122"/>
                 <a:ea typeface="黑体" panose="02010609060101010101" pitchFamily="49" charset="-122"/>
               </a:rPr>
               <a:t>结论与待解决</a:t>
             </a:r>
-            <a:endParaRPr lang="zh-CN" altLang="en-US" sz="4000" dirty="0">
-              <a:solidFill>
-                <a:schemeClr val="accent1">
-                  <a:lumMod val="50000"/>
-                </a:schemeClr>
-              </a:solidFill>
-              <a:latin typeface="黑体" panose="02010609060101010101" pitchFamily="49" charset="-122"/>
-              <a:ea typeface="黑体" panose="02010609060101010101" pitchFamily="49" charset="-122"/>
-            </a:endParaRPr>
           </a:p>
         </p:txBody>
       </p:sp>
       <p:pic>
         <p:nvPicPr>
-          <p:cNvPr id="25" name="图片 24"/>
+          <p:cNvPr id="21" name="图片 20"/>
           <p:cNvPicPr>
             <a:picLocks noChangeAspect="1"/>
           </p:cNvPicPr>
           <p:nvPr/>
         </p:nvPicPr>
         <p:blipFill>
-          <a:blip r:embed="rId1" cstate="print">
+          <a:blip r:embed="rId2" cstate="print">
             <a:extLst>
               <a:ext uri="{28A0092B-C50C-407E-A947-70E740481C1C}">
                 <a14:useLocalDpi xmlns:a14="http://schemas.microsoft.com/office/drawing/2010/main" val="0"/>
@@ -5289,24 +4446,294 @@
         </p:blipFill>
         <p:spPr>
           <a:xfrm>
-            <a:off x="-131559" y="-849874"/>
-            <a:ext cx="4161137" cy="2942086"/>
+            <a:off x="5009301" y="-83132"/>
+            <a:ext cx="1429499" cy="2022049"/>
           </a:xfrm>
           <a:prstGeom prst="rect">
             <a:avLst/>
           </a:prstGeom>
         </p:spPr>
       </p:pic>
-      <p:sp>
-        <p:nvSpPr>
-          <p:cNvPr id="27" name="文本框 26"/>
+      <p:pic>
+        <p:nvPicPr>
+          <p:cNvPr id="22" name="图片 21"/>
+          <p:cNvPicPr>
+            <a:picLocks noChangeAspect="1"/>
+          </p:cNvPicPr>
+          <p:nvPr/>
+        </p:nvPicPr>
+        <p:blipFill>
+          <a:blip r:embed="rId3" cstate="print">
+            <a:extLst>
+              <a:ext uri="{28A0092B-C50C-407E-A947-70E740481C1C}">
+                <a14:useLocalDpi xmlns:a14="http://schemas.microsoft.com/office/drawing/2010/main" val="0"/>
+              </a:ext>
+            </a:extLst>
+          </a:blip>
+          <a:stretch>
+            <a:fillRect/>
+          </a:stretch>
+        </p:blipFill>
+        <p:spPr>
+          <a:xfrm>
+            <a:off x="4074579" y="-101986"/>
+            <a:ext cx="1218069" cy="2177058"/>
+          </a:xfrm>
+          <a:prstGeom prst="rect">
+            <a:avLst/>
+          </a:prstGeom>
+        </p:spPr>
+      </p:pic>
+      <p:sp>
+        <p:nvSpPr>
+          <p:cNvPr id="25" name="箭头: 五边形 24"/>
+          <p:cNvSpPr/>
+          <p:nvPr/>
+        </p:nvSpPr>
+        <p:spPr>
+          <a:xfrm>
+            <a:off x="0" y="478074"/>
+            <a:ext cx="7266562" cy="642025"/>
+          </a:xfrm>
+          <a:prstGeom prst="homePlate">
+            <a:avLst/>
+          </a:prstGeom>
+          <a:solidFill>
+            <a:schemeClr val="accent1">
+              <a:lumMod val="50000"/>
+            </a:schemeClr>
+          </a:solidFill>
+          <a:ln>
+            <a:noFill/>
+          </a:ln>
+          <a:effectLst>
+            <a:outerShdw blurRad="50800" dist="38100" dir="2700000" algn="tl" rotWithShape="0">
+              <a:prstClr val="black">
+                <a:alpha val="40000"/>
+              </a:prstClr>
+            </a:outerShdw>
+          </a:effectLst>
+        </p:spPr>
+        <p:style>
+          <a:lnRef idx="2">
+            <a:schemeClr val="accent1">
+              <a:shade val="15000"/>
+            </a:schemeClr>
+          </a:lnRef>
+          <a:fillRef idx="1">
+            <a:schemeClr val="accent1"/>
+          </a:fillRef>
+          <a:effectRef idx="0">
+            <a:schemeClr val="accent1"/>
+          </a:effectRef>
+          <a:fontRef idx="minor">
+            <a:schemeClr val="lt1"/>
+          </a:fontRef>
+        </p:style>
+        <p:txBody>
+          <a:bodyPr rtlCol="0" anchor="ctr"/>
+          <a:lstStyle/>
+          <a:p>
+            <a:pPr algn="ctr"/>
+            <a:endParaRPr lang="zh-CN" altLang="en-US"/>
+          </a:p>
+        </p:txBody>
+      </p:sp>
+      <p:sp>
+        <p:nvSpPr>
+          <p:cNvPr id="26" name="箭头: V 形 25"/>
+          <p:cNvSpPr/>
+          <p:nvPr/>
+        </p:nvSpPr>
+        <p:spPr>
+          <a:xfrm>
+            <a:off x="7072641" y="478073"/>
+            <a:ext cx="523925" cy="642025"/>
+          </a:xfrm>
+          <a:prstGeom prst="chevron">
+            <a:avLst>
+              <a:gd name="adj" fmla="val 62487"/>
+            </a:avLst>
+          </a:prstGeom>
+          <a:solidFill>
+            <a:schemeClr val="accent1">
+              <a:lumMod val="75000"/>
+            </a:schemeClr>
+          </a:solidFill>
+          <a:ln>
+            <a:noFill/>
+          </a:ln>
+          <a:effectLst>
+            <a:outerShdw blurRad="50800" dist="38100" dir="2700000" algn="tl" rotWithShape="0">
+              <a:prstClr val="black">
+                <a:alpha val="40000"/>
+              </a:prstClr>
+            </a:outerShdw>
+          </a:effectLst>
+        </p:spPr>
+        <p:style>
+          <a:lnRef idx="2">
+            <a:schemeClr val="accent1">
+              <a:shade val="15000"/>
+            </a:schemeClr>
+          </a:lnRef>
+          <a:fillRef idx="1">
+            <a:schemeClr val="accent1"/>
+          </a:fillRef>
+          <a:effectRef idx="0">
+            <a:schemeClr val="accent1"/>
+          </a:effectRef>
+          <a:fontRef idx="minor">
+            <a:schemeClr val="lt1"/>
+          </a:fontRef>
+        </p:style>
+        <p:txBody>
+          <a:bodyPr rtlCol="0" anchor="ctr"/>
+          <a:lstStyle/>
+          <a:p>
+            <a:pPr algn="ctr"/>
+            <a:endParaRPr lang="zh-CN" altLang="en-US" dirty="0">
+              <a:solidFill>
+                <a:schemeClr val="tx1"/>
+              </a:solidFill>
+            </a:endParaRPr>
+          </a:p>
+        </p:txBody>
+      </p:sp>
+      <p:sp>
+        <p:nvSpPr>
+          <p:cNvPr id="27" name="箭头: V 形 26"/>
+          <p:cNvSpPr/>
+          <p:nvPr/>
+        </p:nvSpPr>
+        <p:spPr>
+          <a:xfrm>
+            <a:off x="7424379" y="478073"/>
+            <a:ext cx="427941" cy="642025"/>
+          </a:xfrm>
+          <a:prstGeom prst="chevron">
+            <a:avLst>
+              <a:gd name="adj" fmla="val 76041"/>
+            </a:avLst>
+          </a:prstGeom>
+          <a:solidFill>
+            <a:schemeClr val="accent1">
+              <a:lumMod val="60000"/>
+              <a:lumOff val="40000"/>
+            </a:schemeClr>
+          </a:solidFill>
+          <a:ln>
+            <a:noFill/>
+          </a:ln>
+          <a:effectLst>
+            <a:outerShdw blurRad="50800" dist="38100" dir="2700000" algn="tl" rotWithShape="0">
+              <a:prstClr val="black">
+                <a:alpha val="40000"/>
+              </a:prstClr>
+            </a:outerShdw>
+          </a:effectLst>
+        </p:spPr>
+        <p:style>
+          <a:lnRef idx="2">
+            <a:schemeClr val="accent1">
+              <a:shade val="15000"/>
+            </a:schemeClr>
+          </a:lnRef>
+          <a:fillRef idx="1">
+            <a:schemeClr val="accent1"/>
+          </a:fillRef>
+          <a:effectRef idx="0">
+            <a:schemeClr val="accent1"/>
+          </a:effectRef>
+          <a:fontRef idx="minor">
+            <a:schemeClr val="lt1"/>
+          </a:fontRef>
+        </p:style>
+        <p:txBody>
+          <a:bodyPr rtlCol="0" anchor="ctr"/>
+          <a:lstStyle/>
+          <a:p>
+            <a:pPr algn="ctr"/>
+            <a:endParaRPr lang="zh-CN" altLang="en-US" dirty="0">
+              <a:solidFill>
+                <a:schemeClr val="tx1"/>
+              </a:solidFill>
+            </a:endParaRPr>
+          </a:p>
+        </p:txBody>
+      </p:sp>
+      <p:sp>
+        <p:nvSpPr>
+          <p:cNvPr id="28" name="箭头: V 形 27"/>
+          <p:cNvSpPr/>
+          <p:nvPr/>
+        </p:nvSpPr>
+        <p:spPr>
+          <a:xfrm>
+            <a:off x="7755773" y="478073"/>
+            <a:ext cx="373468" cy="642025"/>
+          </a:xfrm>
+          <a:prstGeom prst="chevron">
+            <a:avLst>
+              <a:gd name="adj" fmla="val 85754"/>
+            </a:avLst>
+          </a:prstGeom>
+          <a:solidFill>
+            <a:schemeClr val="accent1">
+              <a:lumMod val="40000"/>
+              <a:lumOff val="60000"/>
+            </a:schemeClr>
+          </a:solidFill>
+          <a:ln>
+            <a:noFill/>
+          </a:ln>
+          <a:effectLst>
+            <a:outerShdw blurRad="50800" dist="38100" dir="2700000" algn="tl" rotWithShape="0">
+              <a:prstClr val="black">
+                <a:alpha val="40000"/>
+              </a:prstClr>
+            </a:outerShdw>
+          </a:effectLst>
+        </p:spPr>
+        <p:style>
+          <a:lnRef idx="2">
+            <a:schemeClr val="accent1">
+              <a:shade val="15000"/>
+            </a:schemeClr>
+          </a:lnRef>
+          <a:fillRef idx="1">
+            <a:schemeClr val="accent1"/>
+          </a:fillRef>
+          <a:effectRef idx="0">
+            <a:schemeClr val="accent1"/>
+          </a:effectRef>
+          <a:fontRef idx="minor">
+            <a:schemeClr val="lt1"/>
+          </a:fontRef>
+        </p:style>
+        <p:txBody>
+          <a:bodyPr rtlCol="0" anchor="ctr"/>
+          <a:lstStyle/>
+          <a:p>
+            <a:pPr algn="ctr"/>
+            <a:endParaRPr lang="zh-CN" altLang="en-US" dirty="0">
+              <a:solidFill>
+                <a:schemeClr val="tx1"/>
+              </a:solidFill>
+            </a:endParaRPr>
+          </a:p>
+        </p:txBody>
+      </p:sp>
+      <p:sp>
+        <p:nvSpPr>
+          <p:cNvPr id="29" name="文本框 28"/>
           <p:cNvSpPr txBox="1"/>
           <p:nvPr/>
         </p:nvSpPr>
         <p:spPr>
           <a:xfrm>
-            <a:off x="-770237" y="2461461"/>
-            <a:ext cx="6096000" cy="1446550"/>
+            <a:off x="752997" y="461745"/>
+            <a:ext cx="5393803" cy="645160"/>
           </a:xfrm>
           <a:prstGeom prst="rect">
             <a:avLst/>
@@ -5319,9 +4746,8 @@
           </a:bodyPr>
           <a:lstStyle/>
           <a:p>
-            <a:pPr algn="ctr"/>
-            <a:r>
-              <a:rPr lang="zh-CN" altLang="en-US" sz="8800" dirty="0">
+            <a:r>
+              <a:rPr lang="zh-CN" altLang="en-US" sz="3600" dirty="0">
                 <a:solidFill>
                   <a:schemeClr val="bg1"/>
                 </a:solidFill>
@@ -5330,26 +4756,75 @@
               </a:rPr>
               <a:t>报告目录</a:t>
             </a:r>
-            <a:endParaRPr lang="zh-CN" altLang="en-US" sz="8800" dirty="0">
-              <a:solidFill>
-                <a:schemeClr val="bg1"/>
-              </a:solidFill>
-              <a:latin typeface="黑体" panose="02010609060101010101" pitchFamily="49" charset="-122"/>
-              <a:ea typeface="黑体" panose="02010609060101010101" pitchFamily="49" charset="-122"/>
-            </a:endParaRPr>
-          </a:p>
-        </p:txBody>
-      </p:sp>
-      <p:sp>
-        <p:nvSpPr>
-          <p:cNvPr id="30" name="文本框 29"/>
+          </a:p>
+        </p:txBody>
+      </p:sp>
+      <p:sp>
+        <p:nvSpPr>
+          <p:cNvPr id="31" name="直角三角形 30"/>
+          <p:cNvSpPr/>
+          <p:nvPr/>
+        </p:nvSpPr>
+        <p:spPr>
+          <a:xfrm rot="10800000">
+            <a:off x="-27021" y="1120093"/>
+            <a:ext cx="629302" cy="425719"/>
+          </a:xfrm>
+          <a:prstGeom prst="rtTriangle">
+            <a:avLst/>
+          </a:prstGeom>
+          <a:solidFill>
+            <a:schemeClr val="accent1">
+              <a:lumMod val="75000"/>
+              <a:alpha val="65000"/>
+            </a:schemeClr>
+          </a:solidFill>
+          <a:ln>
+            <a:noFill/>
+          </a:ln>
+          <a:effectLst>
+            <a:outerShdw blurRad="50800" dist="38100" dir="2700000" algn="tl" rotWithShape="0">
+              <a:prstClr val="black">
+                <a:alpha val="40000"/>
+              </a:prstClr>
+            </a:outerShdw>
+          </a:effectLst>
+        </p:spPr>
+        <p:style>
+          <a:lnRef idx="2">
+            <a:schemeClr val="accent1">
+              <a:shade val="15000"/>
+            </a:schemeClr>
+          </a:lnRef>
+          <a:fillRef idx="1">
+            <a:schemeClr val="accent1"/>
+          </a:fillRef>
+          <a:effectRef idx="0">
+            <a:schemeClr val="accent1"/>
+          </a:effectRef>
+          <a:fontRef idx="minor">
+            <a:schemeClr val="lt1"/>
+          </a:fontRef>
+        </p:style>
+        <p:txBody>
+          <a:bodyPr rtlCol="0" anchor="ctr"/>
+          <a:lstStyle/>
+          <a:p>
+            <a:pPr algn="ctr"/>
+            <a:endParaRPr lang="zh-CN" altLang="en-US"/>
+          </a:p>
+        </p:txBody>
+      </p:sp>
+      <p:sp>
+        <p:nvSpPr>
+          <p:cNvPr id="33" name="文本框 32"/>
           <p:cNvSpPr txBox="1"/>
           <p:nvPr/>
         </p:nvSpPr>
         <p:spPr>
           <a:xfrm>
-            <a:off x="1293599" y="3917903"/>
-            <a:ext cx="2046683" cy="461665"/>
+            <a:off x="776057" y="1165950"/>
+            <a:ext cx="5544273" cy="398780"/>
           </a:xfrm>
           <a:prstGeom prst="rect">
             <a:avLst/>
@@ -5362,37 +4837,343 @@
           </a:bodyPr>
           <a:lstStyle/>
           <a:p>
+            <a:r>
+              <a:rPr lang="zh-CN" altLang="en-US" sz="2000" dirty="0">
+                <a:solidFill>
+                  <a:schemeClr val="tx1">
+                    <a:lumMod val="50000"/>
+                    <a:lumOff val="50000"/>
+                  </a:schemeClr>
+                </a:solidFill>
+                <a:latin typeface="黑体" panose="02010609060101010101" pitchFamily="49" charset="-122"/>
+                <a:ea typeface="黑体" panose="02010609060101010101" pitchFamily="49" charset="-122"/>
+              </a:rPr>
+              <a:t>结论与待解决</a:t>
+            </a:r>
+          </a:p>
+        </p:txBody>
+      </p:sp>
+      <p:pic>
+        <p:nvPicPr>
+          <p:cNvPr id="37" name="图片 36"/>
+          <p:cNvPicPr>
+            <a:picLocks noChangeAspect="1"/>
+          </p:cNvPicPr>
+          <p:nvPr/>
+        </p:nvPicPr>
+        <p:blipFill>
+          <a:blip r:embed="rId4" cstate="print">
+            <a:extLst>
+              <a:ext uri="{28A0092B-C50C-407E-A947-70E740481C1C}">
+                <a14:useLocalDpi xmlns:a14="http://schemas.microsoft.com/office/drawing/2010/main" val="0"/>
+              </a:ext>
+            </a:extLst>
+          </a:blip>
+          <a:stretch>
+            <a:fillRect/>
+          </a:stretch>
+        </p:blipFill>
+        <p:spPr>
+          <a:xfrm>
+            <a:off x="6216145" y="309262"/>
+            <a:ext cx="891058" cy="1260416"/>
+          </a:xfrm>
+          <a:prstGeom prst="rect">
+            <a:avLst/>
+          </a:prstGeom>
+        </p:spPr>
+      </p:pic>
+      <p:pic>
+        <p:nvPicPr>
+          <p:cNvPr id="46" name="图片 45"/>
+          <p:cNvPicPr>
+            <a:picLocks noChangeAspect="1"/>
+          </p:cNvPicPr>
+          <p:nvPr/>
+        </p:nvPicPr>
+        <p:blipFill>
+          <a:blip r:embed="rId5" cstate="print">
+            <a:extLst>
+              <a:ext uri="{28A0092B-C50C-407E-A947-70E740481C1C}">
+                <a14:useLocalDpi xmlns:a14="http://schemas.microsoft.com/office/drawing/2010/main" val="0"/>
+              </a:ext>
+            </a:extLst>
+          </a:blip>
+          <a:stretch>
+            <a:fillRect/>
+          </a:stretch>
+        </p:blipFill>
+        <p:spPr>
+          <a:xfrm>
+            <a:off x="-188196" y="166310"/>
+            <a:ext cx="1057173" cy="1495387"/>
+          </a:xfrm>
+          <a:prstGeom prst="rect">
+            <a:avLst/>
+          </a:prstGeom>
+        </p:spPr>
+      </p:pic>
+      <p:pic>
+        <p:nvPicPr>
+          <p:cNvPr id="9" name="图片 8"/>
+          <p:cNvPicPr>
+            <a:picLocks noChangeAspect="1"/>
+          </p:cNvPicPr>
+          <p:nvPr/>
+        </p:nvPicPr>
+        <p:blipFill>
+          <a:blip r:embed="rId2" cstate="print">
+            <a:extLst>
+              <a:ext uri="{28A0092B-C50C-407E-A947-70E740481C1C}">
+                <a14:useLocalDpi xmlns:a14="http://schemas.microsoft.com/office/drawing/2010/main" val="0"/>
+              </a:ext>
+            </a:extLst>
+          </a:blip>
+          <a:stretch>
+            <a:fillRect/>
+          </a:stretch>
+        </p:blipFill>
+        <p:spPr>
+          <a:xfrm>
+            <a:off x="5002289" y="-86698"/>
+            <a:ext cx="1429499" cy="2022049"/>
+          </a:xfrm>
+          <a:prstGeom prst="rect">
+            <a:avLst/>
+          </a:prstGeom>
+        </p:spPr>
+      </p:pic>
+      <p:pic>
+        <p:nvPicPr>
+          <p:cNvPr id="10" name="图片 9"/>
+          <p:cNvPicPr>
+            <a:picLocks noChangeAspect="1"/>
+          </p:cNvPicPr>
+          <p:nvPr/>
+        </p:nvPicPr>
+        <p:blipFill>
+          <a:blip r:embed="rId3" cstate="print">
+            <a:extLst>
+              <a:ext uri="{28A0092B-C50C-407E-A947-70E740481C1C}">
+                <a14:useLocalDpi xmlns:a14="http://schemas.microsoft.com/office/drawing/2010/main" val="0"/>
+              </a:ext>
+            </a:extLst>
+          </a:blip>
+          <a:stretch>
+            <a:fillRect/>
+          </a:stretch>
+        </p:blipFill>
+        <p:spPr>
+          <a:xfrm>
+            <a:off x="4067567" y="-105552"/>
+            <a:ext cx="1218069" cy="2177058"/>
+          </a:xfrm>
+          <a:prstGeom prst="rect">
+            <a:avLst/>
+          </a:prstGeom>
+        </p:spPr>
+      </p:pic>
+      <p:cxnSp>
+        <p:nvCxnSpPr>
+          <p:cNvPr id="14" name="直接连接符 13"/>
+          <p:cNvCxnSpPr/>
+          <p:nvPr/>
+        </p:nvCxnSpPr>
+        <p:spPr>
+          <a:xfrm>
+            <a:off x="1170264" y="3118908"/>
+            <a:ext cx="9505950" cy="4445"/>
+          </a:xfrm>
+          <a:prstGeom prst="line">
+            <a:avLst/>
+          </a:prstGeom>
+          <a:ln w="9525">
+            <a:solidFill>
+              <a:schemeClr val="tx1">
+                <a:lumMod val="50000"/>
+                <a:lumOff val="50000"/>
+              </a:schemeClr>
+            </a:solidFill>
+            <a:prstDash val="dashDot"/>
+          </a:ln>
+        </p:spPr>
+        <p:style>
+          <a:lnRef idx="1">
+            <a:schemeClr val="accent1"/>
+          </a:lnRef>
+          <a:fillRef idx="0">
+            <a:schemeClr val="accent1"/>
+          </a:fillRef>
+          <a:effectRef idx="0">
+            <a:schemeClr val="accent1"/>
+          </a:effectRef>
+          <a:fontRef idx="minor">
+            <a:schemeClr val="tx1"/>
+          </a:fontRef>
+        </p:style>
+      </p:cxnSp>
+      <p:sp>
+        <p:nvSpPr>
+          <p:cNvPr id="18" name="椭圆 17"/>
+          <p:cNvSpPr/>
+          <p:nvPr/>
+        </p:nvSpPr>
+        <p:spPr>
+          <a:xfrm>
+            <a:off x="10676131" y="3076963"/>
+            <a:ext cx="101968" cy="101968"/>
+          </a:xfrm>
+          <a:prstGeom prst="ellipse">
+            <a:avLst/>
+          </a:prstGeom>
+          <a:solidFill>
+            <a:schemeClr val="tx1">
+              <a:lumMod val="50000"/>
+              <a:lumOff val="50000"/>
+            </a:schemeClr>
+          </a:solidFill>
+          <a:ln>
+            <a:noFill/>
+          </a:ln>
+        </p:spPr>
+        <p:style>
+          <a:lnRef idx="2">
+            <a:schemeClr val="accent1">
+              <a:shade val="15000"/>
+            </a:schemeClr>
+          </a:lnRef>
+          <a:fillRef idx="1">
+            <a:schemeClr val="accent1"/>
+          </a:fillRef>
+          <a:effectRef idx="0">
+            <a:schemeClr val="accent1"/>
+          </a:effectRef>
+          <a:fontRef idx="minor">
+            <a:schemeClr val="lt1"/>
+          </a:fontRef>
+        </p:style>
+        <p:txBody>
+          <a:bodyPr rtlCol="0" anchor="ctr"/>
+          <a:lstStyle/>
+          <a:p>
             <a:pPr algn="ctr"/>
-            <a:r>
-              <a:rPr lang="en-US" altLang="zh-CN" sz="2400" b="1" dirty="0">
-                <a:solidFill>
-                  <a:schemeClr val="bg1"/>
-                </a:solidFill>
-                <a:latin typeface="+mj-ea"/>
-                <a:ea typeface="+mj-ea"/>
-              </a:rPr>
-              <a:t>CONTENTS</a:t>
-            </a:r>
-            <a:endParaRPr lang="zh-CN" altLang="en-US" sz="2400" b="1" dirty="0">
+            <a:endParaRPr lang="zh-CN" altLang="en-US"/>
+          </a:p>
+        </p:txBody>
+      </p:sp>
+      <p:sp>
+        <p:nvSpPr>
+          <p:cNvPr id="19" name="椭圆 18"/>
+          <p:cNvSpPr/>
+          <p:nvPr/>
+        </p:nvSpPr>
+        <p:spPr>
+          <a:xfrm>
+            <a:off x="1068296" y="3068574"/>
+            <a:ext cx="101968" cy="101968"/>
+          </a:xfrm>
+          <a:prstGeom prst="ellipse">
+            <a:avLst/>
+          </a:prstGeom>
+          <a:solidFill>
+            <a:schemeClr val="tx1">
+              <a:lumMod val="50000"/>
+              <a:lumOff val="50000"/>
+            </a:schemeClr>
+          </a:solidFill>
+          <a:ln>
+            <a:noFill/>
+          </a:ln>
+        </p:spPr>
+        <p:style>
+          <a:lnRef idx="2">
+            <a:schemeClr val="accent1">
+              <a:shade val="15000"/>
+            </a:schemeClr>
+          </a:lnRef>
+          <a:fillRef idx="1">
+            <a:schemeClr val="accent1"/>
+          </a:fillRef>
+          <a:effectRef idx="0">
+            <a:schemeClr val="accent1"/>
+          </a:effectRef>
+          <a:fontRef idx="minor">
+            <a:schemeClr val="lt1"/>
+          </a:fontRef>
+        </p:style>
+        <p:txBody>
+          <a:bodyPr rtlCol="0" anchor="ctr"/>
+          <a:lstStyle/>
+          <a:p>
+            <a:pPr algn="ctr"/>
+            <a:endParaRPr lang="zh-CN" altLang="en-US"/>
+          </a:p>
+        </p:txBody>
+      </p:sp>
+      <p:sp>
+        <p:nvSpPr>
+          <p:cNvPr id="20" name="箭头: V 形 19"/>
+          <p:cNvSpPr/>
+          <p:nvPr/>
+        </p:nvSpPr>
+        <p:spPr>
+          <a:xfrm rot="5400000">
+            <a:off x="907924" y="2298114"/>
+            <a:ext cx="357945" cy="604019"/>
+          </a:xfrm>
+          <a:prstGeom prst="chevron">
+            <a:avLst>
+              <a:gd name="adj" fmla="val 48413"/>
+            </a:avLst>
+          </a:prstGeom>
+          <a:solidFill>
+            <a:schemeClr val="accent1">
+              <a:lumMod val="50000"/>
+            </a:schemeClr>
+          </a:solidFill>
+          <a:ln>
+            <a:noFill/>
+          </a:ln>
+        </p:spPr>
+        <p:style>
+          <a:lnRef idx="2">
+            <a:schemeClr val="accent1">
+              <a:shade val="15000"/>
+            </a:schemeClr>
+          </a:lnRef>
+          <a:fillRef idx="1">
+            <a:schemeClr val="accent1"/>
+          </a:fillRef>
+          <a:effectRef idx="0">
+            <a:schemeClr val="accent1"/>
+          </a:effectRef>
+          <a:fontRef idx="minor">
+            <a:schemeClr val="lt1"/>
+          </a:fontRef>
+        </p:style>
+        <p:txBody>
+          <a:bodyPr rtlCol="0" anchor="ctr"/>
+          <a:lstStyle/>
+          <a:p>
+            <a:pPr algn="ctr"/>
+            <a:endParaRPr lang="zh-CN" altLang="en-US">
               <a:solidFill>
-                <a:schemeClr val="bg1"/>
+                <a:schemeClr val="tx1"/>
               </a:solidFill>
-              <a:latin typeface="+mj-ea"/>
-              <a:ea typeface="+mj-ea"/>
             </a:endParaRPr>
           </a:p>
         </p:txBody>
       </p:sp>
       <p:sp>
         <p:nvSpPr>
-          <p:cNvPr id="6" name="文本框 5"/>
+          <p:cNvPr id="24" name="文本框 23"/>
           <p:cNvSpPr txBox="1"/>
           <p:nvPr/>
         </p:nvSpPr>
         <p:spPr>
           <a:xfrm>
-            <a:off x="8313835" y="1454411"/>
-            <a:ext cx="3094694" cy="400110"/>
+            <a:off x="1429309" y="3512393"/>
+            <a:ext cx="4349262" cy="460375"/>
           </a:xfrm>
           <a:prstGeom prst="rect">
             <a:avLst/>
@@ -5406,23 +5187,213 @@
           <a:lstStyle/>
           <a:p>
             <a:r>
-              <a:rPr lang="en-US" altLang="zh-CN" sz="2000" dirty="0"/>
-              <a:t>Please entre a tile</a:t>
-            </a:r>
-            <a:endParaRPr lang="zh-CN" altLang="en-US" sz="2000" dirty="0"/>
-          </a:p>
-        </p:txBody>
-      </p:sp>
-      <p:sp>
-        <p:nvSpPr>
-          <p:cNvPr id="8" name="文本框 7"/>
+              <a:rPr lang="zh-CN" altLang="en-US" sz="2400" dirty="0">
+                <a:solidFill>
+                  <a:schemeClr val="accent1">
+                    <a:lumMod val="50000"/>
+                  </a:schemeClr>
+                </a:solidFill>
+                <a:latin typeface="黑体" panose="02010609060101010101" pitchFamily="49" charset="-122"/>
+                <a:ea typeface="黑体" panose="02010609060101010101" pitchFamily="49" charset="-122"/>
+              </a:rPr>
+              <a:t>文献调研与改进思路</a:t>
+            </a:r>
+          </a:p>
+        </p:txBody>
+      </p:sp>
+      <p:sp>
+        <p:nvSpPr>
+          <p:cNvPr id="48" name="椭圆 47"/>
+          <p:cNvSpPr/>
+          <p:nvPr/>
+        </p:nvSpPr>
+        <p:spPr>
+          <a:xfrm>
+            <a:off x="10675496" y="4672792"/>
+            <a:ext cx="101968" cy="101968"/>
+          </a:xfrm>
+          <a:prstGeom prst="ellipse">
+            <a:avLst/>
+          </a:prstGeom>
+          <a:solidFill>
+            <a:schemeClr val="tx1">
+              <a:lumMod val="50000"/>
+              <a:lumOff val="50000"/>
+            </a:schemeClr>
+          </a:solidFill>
+          <a:ln>
+            <a:noFill/>
+          </a:ln>
+        </p:spPr>
+        <p:style>
+          <a:lnRef idx="2">
+            <a:schemeClr val="accent1">
+              <a:shade val="15000"/>
+            </a:schemeClr>
+          </a:lnRef>
+          <a:fillRef idx="1">
+            <a:schemeClr val="accent1"/>
+          </a:fillRef>
+          <a:effectRef idx="0">
+            <a:schemeClr val="accent1"/>
+          </a:effectRef>
+          <a:fontRef idx="minor">
+            <a:schemeClr val="lt1"/>
+          </a:fontRef>
+        </p:style>
+        <p:txBody>
+          <a:bodyPr rtlCol="0" anchor="ctr"/>
+          <a:lstStyle/>
+          <a:p>
+            <a:pPr algn="ctr"/>
+            <a:endParaRPr lang="zh-CN" altLang="en-US"/>
+          </a:p>
+        </p:txBody>
+      </p:sp>
+      <p:sp>
+        <p:nvSpPr>
+          <p:cNvPr id="49" name="椭圆 48"/>
+          <p:cNvSpPr/>
+          <p:nvPr/>
+        </p:nvSpPr>
+        <p:spPr>
+          <a:xfrm>
+            <a:off x="1068296" y="4672023"/>
+            <a:ext cx="101968" cy="101968"/>
+          </a:xfrm>
+          <a:prstGeom prst="ellipse">
+            <a:avLst/>
+          </a:prstGeom>
+          <a:solidFill>
+            <a:schemeClr val="tx1">
+              <a:lumMod val="50000"/>
+              <a:lumOff val="50000"/>
+            </a:schemeClr>
+          </a:solidFill>
+          <a:ln>
+            <a:noFill/>
+          </a:ln>
+        </p:spPr>
+        <p:style>
+          <a:lnRef idx="2">
+            <a:schemeClr val="accent1">
+              <a:shade val="15000"/>
+            </a:schemeClr>
+          </a:lnRef>
+          <a:fillRef idx="1">
+            <a:schemeClr val="accent1"/>
+          </a:fillRef>
+          <a:effectRef idx="0">
+            <a:schemeClr val="accent1"/>
+          </a:effectRef>
+          <a:fontRef idx="minor">
+            <a:schemeClr val="lt1"/>
+          </a:fontRef>
+        </p:style>
+        <p:txBody>
+          <a:bodyPr rtlCol="0" anchor="ctr"/>
+          <a:lstStyle/>
+          <a:p>
+            <a:pPr algn="ctr"/>
+            <a:endParaRPr lang="zh-CN" altLang="en-US"/>
+          </a:p>
+        </p:txBody>
+      </p:sp>
+      <p:sp>
+        <p:nvSpPr>
+          <p:cNvPr id="50" name="箭头: V 形 49"/>
+          <p:cNvSpPr/>
+          <p:nvPr/>
+        </p:nvSpPr>
+        <p:spPr>
+          <a:xfrm rot="5400000">
+            <a:off x="907924" y="3901563"/>
+            <a:ext cx="357945" cy="604019"/>
+          </a:xfrm>
+          <a:prstGeom prst="chevron">
+            <a:avLst>
+              <a:gd name="adj" fmla="val 48413"/>
+            </a:avLst>
+          </a:prstGeom>
+          <a:solidFill>
+            <a:schemeClr val="accent1">
+              <a:lumMod val="40000"/>
+              <a:lumOff val="60000"/>
+            </a:schemeClr>
+          </a:solidFill>
+          <a:ln>
+            <a:noFill/>
+          </a:ln>
+        </p:spPr>
+        <p:style>
+          <a:lnRef idx="2">
+            <a:schemeClr val="accent1">
+              <a:shade val="15000"/>
+            </a:schemeClr>
+          </a:lnRef>
+          <a:fillRef idx="1">
+            <a:schemeClr val="accent1"/>
+          </a:fillRef>
+          <a:effectRef idx="0">
+            <a:schemeClr val="accent1"/>
+          </a:effectRef>
+          <a:fontRef idx="minor">
+            <a:schemeClr val="lt1"/>
+          </a:fontRef>
+        </p:style>
+        <p:txBody>
+          <a:bodyPr rtlCol="0" anchor="ctr"/>
+          <a:lstStyle/>
+          <a:p>
+            <a:pPr algn="ctr"/>
+            <a:endParaRPr lang="zh-CN" altLang="en-US">
+              <a:solidFill>
+                <a:schemeClr val="tx1"/>
+              </a:solidFill>
+            </a:endParaRPr>
+          </a:p>
+        </p:txBody>
+      </p:sp>
+      <p:pic>
+        <p:nvPicPr>
+          <p:cNvPr id="5" name="图片 4"/>
+          <p:cNvPicPr>
+            <a:picLocks noChangeAspect="1"/>
+          </p:cNvPicPr>
+          <p:nvPr/>
+        </p:nvPicPr>
+        <p:blipFill>
+          <a:blip r:embed="rId6" cstate="print">
+            <a:extLst>
+              <a:ext uri="{28A0092B-C50C-407E-A947-70E740481C1C}">
+                <a14:useLocalDpi xmlns:a14="http://schemas.microsoft.com/office/drawing/2010/main" val="0"/>
+              </a:ext>
+            </a:extLst>
+          </a:blip>
+          <a:stretch>
+            <a:fillRect/>
+          </a:stretch>
+        </p:blipFill>
+        <p:spPr>
+          <a:xfrm>
+            <a:off x="8719478" y="-499744"/>
+            <a:ext cx="3460702" cy="2446851"/>
+          </a:xfrm>
+          <a:prstGeom prst="rect">
+            <a:avLst/>
+          </a:prstGeom>
+        </p:spPr>
+      </p:pic>
+      <p:sp>
+        <p:nvSpPr>
+          <p:cNvPr id="3" name="文本框 2"/>
           <p:cNvSpPr txBox="1"/>
           <p:nvPr/>
         </p:nvSpPr>
         <p:spPr>
           <a:xfrm>
-            <a:off x="8372884" y="2874635"/>
-            <a:ext cx="3094694" cy="400110"/>
+            <a:off x="1578610" y="3873500"/>
+            <a:ext cx="9497695" cy="645160"/>
           </a:xfrm>
           <a:prstGeom prst="rect">
             <a:avLst/>
@@ -5436,23 +5407,24 @@
           <a:lstStyle/>
           <a:p>
             <a:r>
-              <a:rPr lang="en-US" altLang="zh-CN" sz="2000" dirty="0"/>
-              <a:t>Please entre a tile</a:t>
-            </a:r>
-            <a:endParaRPr lang="zh-CN" altLang="en-US" sz="2000" dirty="0"/>
-          </a:p>
-        </p:txBody>
-      </p:sp>
-      <p:sp>
-        <p:nvSpPr>
-          <p:cNvPr id="9" name="文本框 8"/>
+              <a:rPr lang="zh-CN" altLang="en-US" dirty="0">
+                <a:sym typeface="+mn-ea"/>
+              </a:rPr>
+              <a:t>文献调研与改进思路</a:t>
+            </a:r>
+          </a:p>
+        </p:txBody>
+      </p:sp>
+      <p:sp>
+        <p:nvSpPr>
+          <p:cNvPr id="8" name="文本框 7"/>
           <p:cNvSpPr txBox="1"/>
           <p:nvPr/>
         </p:nvSpPr>
         <p:spPr>
           <a:xfrm>
-            <a:off x="8460140" y="4487827"/>
-            <a:ext cx="3094694" cy="400110"/>
+            <a:off x="1429309" y="4988694"/>
+            <a:ext cx="4349262" cy="460375"/>
           </a:xfrm>
           <a:prstGeom prst="rect">
             <a:avLst/>
@@ -5466,23 +5438,30 @@
           <a:lstStyle/>
           <a:p>
             <a:r>
-              <a:rPr lang="en-US" altLang="zh-CN" sz="2000" dirty="0"/>
-              <a:t>Please entre a tile</a:t>
-            </a:r>
-            <a:endParaRPr lang="zh-CN" altLang="en-US" sz="2000" dirty="0"/>
-          </a:p>
-        </p:txBody>
-      </p:sp>
-      <p:sp>
-        <p:nvSpPr>
-          <p:cNvPr id="10" name="文本框 9"/>
+              <a:rPr lang="zh-CN" altLang="en-US" sz="2400" dirty="0">
+                <a:solidFill>
+                  <a:schemeClr val="accent1">
+                    <a:lumMod val="50000"/>
+                  </a:schemeClr>
+                </a:solidFill>
+                <a:latin typeface="黑体" panose="02010609060101010101" pitchFamily="49" charset="-122"/>
+                <a:ea typeface="黑体" panose="02010609060101010101" pitchFamily="49" charset="-122"/>
+              </a:rPr>
+              <a:t>消融指标对比</a:t>
+            </a:r>
+          </a:p>
+        </p:txBody>
+      </p:sp>
+      <p:sp>
+        <p:nvSpPr>
+          <p:cNvPr id="11" name="文本框 10"/>
           <p:cNvSpPr txBox="1"/>
           <p:nvPr/>
         </p:nvSpPr>
         <p:spPr>
           <a:xfrm>
-            <a:off x="8438732" y="6020516"/>
-            <a:ext cx="3094694" cy="400110"/>
+            <a:off x="1468755" y="5450205"/>
+            <a:ext cx="9497695" cy="368300"/>
           </a:xfrm>
           <a:prstGeom prst="rect">
             <a:avLst/>
@@ -5496,13 +5475,242 @@
           <a:lstStyle/>
           <a:p>
             <a:r>
-              <a:rPr lang="en-US" altLang="zh-CN" sz="2000" dirty="0"/>
-              <a:t>Please entre a tile</a:t>
-            </a:r>
-            <a:endParaRPr lang="zh-CN" altLang="en-US" sz="2000" dirty="0"/>
-          </a:p>
-        </p:txBody>
-      </p:sp>
+              <a:rPr lang="zh-CN" altLang="en-US" dirty="0"/>
+              <a:t>消融指标对比</a:t>
+            </a:r>
+          </a:p>
+        </p:txBody>
+      </p:sp>
+      <p:cxnSp>
+        <p:nvCxnSpPr>
+          <p:cNvPr id="12" name="直接连接符 11"/>
+          <p:cNvCxnSpPr/>
+          <p:nvPr/>
+        </p:nvCxnSpPr>
+        <p:spPr>
+          <a:xfrm>
+            <a:off x="1170264" y="6198658"/>
+            <a:ext cx="9505950" cy="4445"/>
+          </a:xfrm>
+          <a:prstGeom prst="line">
+            <a:avLst/>
+          </a:prstGeom>
+          <a:ln w="9525">
+            <a:solidFill>
+              <a:schemeClr val="tx1">
+                <a:lumMod val="50000"/>
+                <a:lumOff val="50000"/>
+              </a:schemeClr>
+            </a:solidFill>
+            <a:prstDash val="dashDot"/>
+          </a:ln>
+        </p:spPr>
+        <p:style>
+          <a:lnRef idx="1">
+            <a:schemeClr val="accent1"/>
+          </a:lnRef>
+          <a:fillRef idx="0">
+            <a:schemeClr val="accent1"/>
+          </a:fillRef>
+          <a:effectRef idx="0">
+            <a:schemeClr val="accent1"/>
+          </a:effectRef>
+          <a:fontRef idx="minor">
+            <a:schemeClr val="tx1"/>
+          </a:fontRef>
+        </p:style>
+      </p:cxnSp>
+      <p:sp>
+        <p:nvSpPr>
+          <p:cNvPr id="13" name="椭圆 12"/>
+          <p:cNvSpPr/>
+          <p:nvPr/>
+        </p:nvSpPr>
+        <p:spPr>
+          <a:xfrm>
+            <a:off x="10676131" y="6156713"/>
+            <a:ext cx="101968" cy="101968"/>
+          </a:xfrm>
+          <a:prstGeom prst="ellipse">
+            <a:avLst/>
+          </a:prstGeom>
+          <a:solidFill>
+            <a:schemeClr val="tx1">
+              <a:lumMod val="50000"/>
+              <a:lumOff val="50000"/>
+            </a:schemeClr>
+          </a:solidFill>
+          <a:ln>
+            <a:noFill/>
+          </a:ln>
+        </p:spPr>
+        <p:style>
+          <a:lnRef idx="2">
+            <a:schemeClr val="accent1">
+              <a:shade val="15000"/>
+            </a:schemeClr>
+          </a:lnRef>
+          <a:fillRef idx="1">
+            <a:schemeClr val="accent1"/>
+          </a:fillRef>
+          <a:effectRef idx="0">
+            <a:schemeClr val="accent1"/>
+          </a:effectRef>
+          <a:fontRef idx="minor">
+            <a:schemeClr val="lt1"/>
+          </a:fontRef>
+        </p:style>
+        <p:txBody>
+          <a:bodyPr rtlCol="0" anchor="ctr"/>
+          <a:lstStyle/>
+          <a:p>
+            <a:pPr algn="ctr"/>
+            <a:endParaRPr lang="zh-CN" altLang="en-US"/>
+          </a:p>
+        </p:txBody>
+      </p:sp>
+      <p:sp>
+        <p:nvSpPr>
+          <p:cNvPr id="15" name="椭圆 14"/>
+          <p:cNvSpPr/>
+          <p:nvPr/>
+        </p:nvSpPr>
+        <p:spPr>
+          <a:xfrm>
+            <a:off x="1068296" y="6148324"/>
+            <a:ext cx="101968" cy="101968"/>
+          </a:xfrm>
+          <a:prstGeom prst="ellipse">
+            <a:avLst/>
+          </a:prstGeom>
+          <a:solidFill>
+            <a:schemeClr val="tx1">
+              <a:lumMod val="50000"/>
+              <a:lumOff val="50000"/>
+            </a:schemeClr>
+          </a:solidFill>
+          <a:ln>
+            <a:noFill/>
+          </a:ln>
+        </p:spPr>
+        <p:style>
+          <a:lnRef idx="2">
+            <a:schemeClr val="accent1">
+              <a:shade val="15000"/>
+            </a:schemeClr>
+          </a:lnRef>
+          <a:fillRef idx="1">
+            <a:schemeClr val="accent1"/>
+          </a:fillRef>
+          <a:effectRef idx="0">
+            <a:schemeClr val="accent1"/>
+          </a:effectRef>
+          <a:fontRef idx="minor">
+            <a:schemeClr val="lt1"/>
+          </a:fontRef>
+        </p:style>
+        <p:txBody>
+          <a:bodyPr rtlCol="0" anchor="ctr"/>
+          <a:lstStyle/>
+          <a:p>
+            <a:pPr algn="ctr"/>
+            <a:endParaRPr lang="zh-CN" altLang="en-US"/>
+          </a:p>
+        </p:txBody>
+      </p:sp>
+      <p:sp>
+        <p:nvSpPr>
+          <p:cNvPr id="16" name="箭头: V 形 19"/>
+          <p:cNvSpPr/>
+          <p:nvPr/>
+        </p:nvSpPr>
+        <p:spPr>
+          <a:xfrm rot="5400000">
+            <a:off x="907924" y="5377864"/>
+            <a:ext cx="357945" cy="604019"/>
+          </a:xfrm>
+          <a:prstGeom prst="chevron">
+            <a:avLst>
+              <a:gd name="adj" fmla="val 48413"/>
+            </a:avLst>
+          </a:prstGeom>
+          <a:solidFill>
+            <a:schemeClr val="accent1">
+              <a:lumMod val="50000"/>
+            </a:schemeClr>
+          </a:solidFill>
+          <a:ln>
+            <a:noFill/>
+          </a:ln>
+        </p:spPr>
+        <p:style>
+          <a:lnRef idx="2">
+            <a:schemeClr val="accent1">
+              <a:shade val="15000"/>
+            </a:schemeClr>
+          </a:lnRef>
+          <a:fillRef idx="1">
+            <a:schemeClr val="accent1"/>
+          </a:fillRef>
+          <a:effectRef idx="0">
+            <a:schemeClr val="accent1"/>
+          </a:effectRef>
+          <a:fontRef idx="minor">
+            <a:schemeClr val="lt1"/>
+          </a:fontRef>
+        </p:style>
+        <p:txBody>
+          <a:bodyPr rtlCol="0" anchor="ctr"/>
+          <a:lstStyle/>
+          <a:p>
+            <a:pPr algn="ctr"/>
+            <a:endParaRPr lang="zh-CN" altLang="en-US">
+              <a:solidFill>
+                <a:schemeClr val="tx1"/>
+              </a:solidFill>
+            </a:endParaRPr>
+          </a:p>
+        </p:txBody>
+      </p:sp>
+      <p:cxnSp>
+        <p:nvCxnSpPr>
+          <p:cNvPr id="4" name="直接连接符 3"/>
+          <p:cNvCxnSpPr/>
+          <p:nvPr/>
+        </p:nvCxnSpPr>
+        <p:spPr>
+          <a:xfrm>
+            <a:off x="1169629" y="4733713"/>
+            <a:ext cx="9505950" cy="4445"/>
+          </a:xfrm>
+          <a:prstGeom prst="line">
+            <a:avLst/>
+          </a:prstGeom>
+          <a:ln w="9525">
+            <a:solidFill>
+              <a:schemeClr val="tx1">
+                <a:lumMod val="50000"/>
+                <a:lumOff val="50000"/>
+              </a:schemeClr>
+            </a:solidFill>
+            <a:prstDash val="dashDot"/>
+          </a:ln>
+        </p:spPr>
+        <p:style>
+          <a:lnRef idx="1">
+            <a:schemeClr val="accent1"/>
+          </a:lnRef>
+          <a:fillRef idx="0">
+            <a:schemeClr val="accent1"/>
+          </a:fillRef>
+          <a:effectRef idx="0">
+            <a:schemeClr val="accent1"/>
+          </a:effectRef>
+          <a:fontRef idx="minor">
+            <a:schemeClr val="tx1"/>
+          </a:fontRef>
+        </p:style>
+      </p:cxnSp>
     </p:spTree>
   </p:cSld>
   <p:clrMapOvr>

</xml_diff>

<commit_message>
Update GPR algorithm report PPT
</commit_message>
<xml_diff>
--- a/GPR算法报告_2026-03-02.pptx
+++ b/GPR算法报告_2026-03-02.pptx
@@ -12,7 +12,7 @@
     <p:sldId id="266" r:id="rId4"/>
     <p:sldId id="258" r:id="rId5"/>
     <p:sldId id="260" r:id="rId6"/>
-    <p:sldId id="265" r:id="rId11"/>
+    <p:sldId id="264" r:id="rId7"/>
     <p:sldId id="275" r:id="rId14"/>
   </p:sldIdLst>
   <p:sldSz cx="12192000" cy="6858000"/>
@@ -3281,7 +3281,7 @@
       </p:grpSpPr>
       <p:sp>
         <p:nvSpPr>
-          <p:cNvPr id="2" name="矩形 1"/>
+          <p:cNvPr id="4" name="矩形 3"/>
           <p:cNvSpPr/>
           <p:nvPr/>
         </p:nvSpPr>
@@ -3329,14 +3329,14 @@
       </p:sp>
       <p:sp>
         <p:nvSpPr>
-          <p:cNvPr id="6" name="矩形 5"/>
+          <p:cNvPr id="2" name="矩形 1"/>
           <p:cNvSpPr/>
           <p:nvPr/>
         </p:nvSpPr>
         <p:spPr>
           <a:xfrm>
-            <a:off x="0" y="3145810"/>
-            <a:ext cx="12192000" cy="511511"/>
+            <a:off x="-1" y="2863273"/>
+            <a:ext cx="12192001" cy="820641"/>
           </a:xfrm>
           <a:prstGeom prst="rect">
             <a:avLst/>
@@ -3375,7 +3375,7 @@
       </p:sp>
       <p:sp>
         <p:nvSpPr>
-          <p:cNvPr id="3" name="等腰三角形 2"/>
+          <p:cNvPr id="5" name="等腰三角形 4"/>
           <p:cNvSpPr/>
           <p:nvPr/>
         </p:nvSpPr>
@@ -3421,64 +3421,46 @@
           </a:p>
         </p:txBody>
       </p:sp>
-      <p:sp>
-        <p:nvSpPr>
-          <p:cNvPr id="5" name="矩形: 圆角 4"/>
-          <p:cNvSpPr/>
-          <p:nvPr/>
-        </p:nvSpPr>
-        <p:spPr>
-          <a:xfrm>
-            <a:off x="3213510" y="1953928"/>
-            <a:ext cx="1146413" cy="1146413"/>
-          </a:xfrm>
-          <a:prstGeom prst="roundRect">
-            <a:avLst/>
-          </a:prstGeom>
-          <a:solidFill>
-            <a:schemeClr val="accent1">
-              <a:lumMod val="50000"/>
-            </a:schemeClr>
-          </a:solidFill>
-          <a:ln>
-            <a:noFill/>
-          </a:ln>
-        </p:spPr>
-        <p:style>
-          <a:lnRef idx="2">
-            <a:schemeClr val="accent1">
-              <a:shade val="15000"/>
-            </a:schemeClr>
-          </a:lnRef>
-          <a:fillRef idx="1">
-            <a:schemeClr val="accent1"/>
-          </a:fillRef>
-          <a:effectRef idx="0">
-            <a:schemeClr val="accent1"/>
-          </a:effectRef>
-          <a:fontRef idx="minor">
-            <a:schemeClr val="lt1"/>
-          </a:fontRef>
-        </p:style>
-        <p:txBody>
-          <a:bodyPr rtlCol="0" anchor="ctr"/>
-          <a:lstStyle/>
-          <a:p>
-            <a:pPr algn="ctr"/>
-            <a:endParaRPr lang="zh-CN" altLang="en-US"/>
-          </a:p>
-        </p:txBody>
-      </p:sp>
-      <p:sp>
-        <p:nvSpPr>
-          <p:cNvPr id="7" name="文本框 6"/>
+      <p:pic>
+        <p:nvPicPr>
+          <p:cNvPr id="14" name="图片 13"/>
+          <p:cNvPicPr>
+            <a:picLocks noChangeAspect="1"/>
+          </p:cNvPicPr>
+          <p:nvPr/>
+        </p:nvPicPr>
+        <p:blipFill>
+          <a:blip r:embed="rId1" cstate="print">
+            <a:extLst>
+              <a:ext uri="{28A0092B-C50C-407E-A947-70E740481C1C}">
+                <a14:useLocalDpi xmlns:a14="http://schemas.microsoft.com/office/drawing/2010/main" val="0"/>
+              </a:ext>
+            </a:extLst>
+          </a:blip>
+          <a:stretch>
+            <a:fillRect/>
+          </a:stretch>
+        </p:blipFill>
+        <p:spPr>
+          <a:xfrm>
+            <a:off x="3355138" y="-1224195"/>
+            <a:ext cx="5613803" cy="3969178"/>
+          </a:xfrm>
+          <a:prstGeom prst="rect">
+            <a:avLst/>
+          </a:prstGeom>
+        </p:spPr>
+      </p:pic>
+      <p:sp>
+        <p:nvSpPr>
+          <p:cNvPr id="15" name="文本框 14"/>
           <p:cNvSpPr txBox="1"/>
           <p:nvPr/>
         </p:nvSpPr>
         <p:spPr>
           <a:xfrm>
-            <a:off x="3213510" y="1953927"/>
-            <a:ext cx="1146413" cy="1107996"/>
+            <a:off x="1526058" y="2023995"/>
+            <a:ext cx="9139883" cy="1198880"/>
           </a:xfrm>
           <a:prstGeom prst="rect">
             <a:avLst/>
@@ -3493,49 +3475,7 @@
           <a:p>
             <a:pPr algn="ctr"/>
             <a:r>
-              <a:rPr lang="en-US" altLang="zh-CN" sz="6600" dirty="0">
-                <a:solidFill>
-                  <a:schemeClr val="bg1"/>
-                </a:solidFill>
-                <a:latin typeface="黑体" panose="02010609060101010101" pitchFamily="49" charset="-122"/>
-                <a:ea typeface="黑体" panose="02010609060101010101" pitchFamily="49" charset="-122"/>
-              </a:rPr>
-              <a:t/>
-            </a:r>
-            <a:endParaRPr lang="zh-CN" altLang="en-US" sz="6600" dirty="0">
-              <a:solidFill>
-                <a:schemeClr val="bg1"/>
-              </a:solidFill>
-              <a:latin typeface="黑体" panose="02010609060101010101" pitchFamily="49" charset="-122"/>
-              <a:ea typeface="黑体" panose="02010609060101010101" pitchFamily="49" charset="-122"/>
-            </a:endParaRPr>
-          </a:p>
-        </p:txBody>
-      </p:sp>
-      <p:sp>
-        <p:nvSpPr>
-          <p:cNvPr id="8" name="文本框 7"/>
-          <p:cNvSpPr txBox="1"/>
-          <p:nvPr/>
-        </p:nvSpPr>
-        <p:spPr>
-          <a:xfrm>
-            <a:off x="4770090" y="1887378"/>
-            <a:ext cx="7014949" cy="1107996"/>
-          </a:xfrm>
-          <a:prstGeom prst="rect">
-            <a:avLst/>
-          </a:prstGeom>
-          <a:noFill/>
-        </p:spPr>
-        <p:txBody>
-          <a:bodyPr wrap="square" rtlCol="0">
-            <a:spAutoFit/>
-          </a:bodyPr>
-          <a:lstStyle/>
-          <a:p>
-            <a:r>
-              <a:rPr lang="zh-CN" altLang="en-US" sz="6600" dirty="0">
+              <a:rPr lang="zh-CN" altLang="en-US" sz="7200" b="1" dirty="0">
                 <a:solidFill>
                   <a:schemeClr val="accent1">
                     <a:lumMod val="50000"/>
@@ -3544,73 +3484,47 @@
                 <a:latin typeface="黑体" panose="02010609060101010101" pitchFamily="49" charset="-122"/>
                 <a:ea typeface="黑体" panose="02010609060101010101" pitchFamily="49" charset="-122"/>
               </a:rPr>
-              <a:t>探地雷达(GPR)信号处理技术报告</a:t>
-            </a:r>
-          </a:p>
-        </p:txBody>
-      </p:sp>
-      <p:sp>
-        <p:nvSpPr>
-          <p:cNvPr id="9" name="文本框 8"/>
-          <p:cNvSpPr txBox="1"/>
-          <p:nvPr/>
-        </p:nvSpPr>
-        <p:spPr>
-          <a:xfrm>
-            <a:off x="4827883" y="2986066"/>
-            <a:ext cx="5105067" cy="830997"/>
-          </a:xfrm>
-          <a:prstGeom prst="rect">
-            <a:avLst/>
-          </a:prstGeom>
-          <a:noFill/>
-        </p:spPr>
-        <p:txBody>
-          <a:bodyPr wrap="square" rtlCol="0">
-            <a:spAutoFit/>
-          </a:bodyPr>
-          <a:lstStyle/>
-          <a:p>
-            <a:pPr algn="ctr"/>
-            <a:r>
-              <a:rPr lang="en-US" altLang="zh-CN" sz="2400" b="1" dirty="0">
+              <a:t>探地雷达(GPR)</a:t>
+            </a:r>
+            <a:r>
+              <a:rPr lang="en-US" altLang="zh-CN" sz="7200" b="1" dirty="0">
                 <a:solidFill>
                   <a:schemeClr val="accent1">
                     <a:lumMod val="50000"/>
                   </a:schemeClr>
                 </a:solidFill>
-                <a:latin typeface="+mj-ea"/>
-                <a:ea typeface="+mj-ea"/>
+                <a:latin typeface="黑体" panose="02010609060101010101" pitchFamily="49" charset="-122"/>
+                <a:ea typeface="黑体" panose="02010609060101010101" pitchFamily="49" charset="-122"/>
               </a:rPr>
-              <a:t>GPR Signal Processing Technical Report</a:t>
-            </a:r>
-            <a:endParaRPr lang="zh-CN" altLang="en-US" sz="2400" b="1" dirty="0">
+              <a:t>信号处理</a:t>
+            </a:r>
+            <a:r>
+              <a:rPr lang="zh-CN" altLang="en-US" sz="7200" b="1" dirty="0">
+                <a:solidFill>
+                  <a:schemeClr val="accent1">
+                    <a:lumMod val="50000"/>
+                  </a:schemeClr>
+                </a:solidFill>
+                <a:latin typeface="黑体" panose="02010609060101010101" pitchFamily="49" charset="-122"/>
+                <a:ea typeface="黑体" panose="02010609060101010101" pitchFamily="49" charset="-122"/>
+              </a:rPr>
+              <a:t>技术报告</a:t>
+            </a:r>
+            <a:endParaRPr lang="zh-CN" altLang="en-US" sz="7200" b="1" dirty="0">
               <a:solidFill>
                 <a:schemeClr val="accent1">
                   <a:lumMod val="50000"/>
                 </a:schemeClr>
               </a:solidFill>
-              <a:latin typeface="+mj-ea"/>
-              <a:ea typeface="+mj-ea"/>
-            </a:endParaRPr>
-          </a:p>
-          <a:p>
-            <a:pPr algn="ctr"/>
-            <a:endParaRPr lang="zh-CN" altLang="en-US" sz="2400" b="1" dirty="0">
-              <a:solidFill>
-                <a:schemeClr val="accent1">
-                  <a:lumMod val="50000"/>
-                </a:schemeClr>
-              </a:solidFill>
-              <a:latin typeface="+mj-ea"/>
-              <a:ea typeface="+mj-ea"/>
+              <a:latin typeface="黑体" panose="02010609060101010101" pitchFamily="49" charset="-122"/>
+              <a:ea typeface="黑体" panose="02010609060101010101" pitchFamily="49" charset="-122"/>
             </a:endParaRPr>
           </a:p>
         </p:txBody>
       </p:sp>
       <p:pic>
         <p:nvPicPr>
-          <p:cNvPr id="10" name="图片 9"/>
+          <p:cNvPr id="8" name="图片 7"/>
           <p:cNvPicPr>
             <a:picLocks noChangeAspect="1"/>
           </p:cNvPicPr>
@@ -3630,8 +3544,8 @@
         </p:blipFill>
         <p:spPr>
           <a:xfrm>
-            <a:off x="-199740" y="-736009"/>
-            <a:ext cx="3920726" cy="2772106"/>
+            <a:off x="-538695" y="2510234"/>
+            <a:ext cx="4106356" cy="5808507"/>
           </a:xfrm>
           <a:prstGeom prst="rect">
             <a:avLst/>
@@ -3640,14 +3554,14 @@
       </p:pic>
       <p:pic>
         <p:nvPicPr>
-          <p:cNvPr id="18" name="图片 17"/>
+          <p:cNvPr id="9" name="图片 8"/>
           <p:cNvPicPr>
             <a:picLocks noChangeAspect="1"/>
           </p:cNvPicPr>
           <p:nvPr/>
         </p:nvPicPr>
         <p:blipFill>
-          <a:blip r:embed="rId3">
+          <a:blip r:embed="rId2" cstate="print">
             <a:extLst>
               <a:ext uri="{28A0092B-C50C-407E-A947-70E740481C1C}">
                 <a14:useLocalDpi xmlns:a14="http://schemas.microsoft.com/office/drawing/2010/main" val="0"/>
@@ -3660,8 +3574,85 @@
         </p:blipFill>
         <p:spPr>
           <a:xfrm>
-            <a:off x="-591998" y="-2131690"/>
-            <a:ext cx="6958694" cy="15014702"/>
+            <a:off x="8750326" y="2497567"/>
+            <a:ext cx="4106356" cy="5808507"/>
+          </a:xfrm>
+          <a:prstGeom prst="rect">
+            <a:avLst/>
+          </a:prstGeom>
+        </p:spPr>
+      </p:pic>
+      <p:sp>
+        <p:nvSpPr>
+          <p:cNvPr id="10" name="文本框 9"/>
+          <p:cNvSpPr txBox="1"/>
+          <p:nvPr/>
+        </p:nvSpPr>
+        <p:spPr>
+          <a:xfrm>
+            <a:off x="1910080" y="3273593"/>
+            <a:ext cx="8503920" cy="460375"/>
+          </a:xfrm>
+          <a:prstGeom prst="rect">
+            <a:avLst/>
+          </a:prstGeom>
+          <a:noFill/>
+        </p:spPr>
+        <p:txBody>
+          <a:bodyPr wrap="square" rtlCol="0">
+            <a:spAutoFit/>
+          </a:bodyPr>
+          <a:lstStyle/>
+          <a:p>
+            <a:pPr algn="ctr"/>
+            <a:r>
+              <a:rPr lang="en-US" altLang="zh-CN" sz="2400" b="1" dirty="0">
+                <a:solidFill>
+                  <a:schemeClr val="accent1">
+                    <a:lumMod val="50000"/>
+                  </a:schemeClr>
+                </a:solidFill>
+                <a:latin typeface="+mj-ea"/>
+                <a:ea typeface="+mj-ea"/>
+              </a:rPr>
+              <a:t>GPR Signal Processing Technical Report</a:t>
+            </a:r>
+            <a:endParaRPr lang="en-US" altLang="zh-CN" sz="2400" b="1" dirty="0">
+              <a:solidFill>
+                <a:schemeClr val="accent1">
+                  <a:lumMod val="50000"/>
+                </a:schemeClr>
+              </a:solidFill>
+              <a:latin typeface="+mj-ea"/>
+              <a:ea typeface="+mj-ea"/>
+            </a:endParaRPr>
+          </a:p>
+        </p:txBody>
+      </p:sp>
+      <p:pic>
+        <p:nvPicPr>
+          <p:cNvPr id="12" name="图片 11"/>
+          <p:cNvPicPr>
+            <a:picLocks noChangeAspect="1"/>
+          </p:cNvPicPr>
+          <p:nvPr/>
+        </p:nvPicPr>
+        <p:blipFill>
+          <a:blip r:embed="rId3" cstate="print">
+            <a:extLst>
+              <a:ext uri="{28A0092B-C50C-407E-A947-70E740481C1C}">
+                <a14:useLocalDpi xmlns:a14="http://schemas.microsoft.com/office/drawing/2010/main" val="0"/>
+              </a:ext>
+            </a:extLst>
+          </a:blip>
+          <a:stretch>
+            <a:fillRect/>
+          </a:stretch>
+        </p:blipFill>
+        <p:spPr>
+          <a:xfrm>
+            <a:off x="884087" y="4128820"/>
+            <a:ext cx="1297380" cy="917298"/>
           </a:xfrm>
           <a:prstGeom prst="rect">
             <a:avLst/>
@@ -3670,7 +3661,7 @@
       </p:pic>
       <p:pic>
         <p:nvPicPr>
-          <p:cNvPr id="20" name="图片 19"/>
+          <p:cNvPr id="17" name="图片 16"/>
           <p:cNvPicPr>
             <a:picLocks noChangeAspect="1"/>
           </p:cNvPicPr>
@@ -3684,13 +3675,14 @@
               </a:ext>
             </a:extLst>
           </a:blip>
-          <a:srcRect t="39915"/>
-          <a:stretch/>
+          <a:stretch>
+            <a:fillRect/>
+          </a:stretch>
         </p:blipFill>
         <p:spPr>
           <a:xfrm>
-            <a:off x="4312984" y="4833257"/>
-            <a:ext cx="6401043" cy="5440260"/>
+            <a:off x="10298444" y="4196415"/>
+            <a:ext cx="1049120" cy="741768"/>
           </a:xfrm>
           <a:prstGeom prst="rect">
             <a:avLst/>
@@ -3699,7 +3691,7 @@
       </p:pic>
       <p:pic>
         <p:nvPicPr>
-          <p:cNvPr id="22" name="图片 21"/>
+          <p:cNvPr id="6" name="图片 5"/>
           <p:cNvPicPr>
             <a:picLocks noChangeAspect="1"/>
           </p:cNvPicPr>
@@ -3719,8 +3711,68 @@
         </p:blipFill>
         <p:spPr>
           <a:xfrm>
-            <a:off x="9752598" y="4172642"/>
-            <a:ext cx="2822398" cy="3992327"/>
+            <a:off x="2181466" y="5045466"/>
+            <a:ext cx="3379313" cy="2353017"/>
+          </a:xfrm>
+          <a:prstGeom prst="rect">
+            <a:avLst/>
+          </a:prstGeom>
+        </p:spPr>
+      </p:pic>
+      <p:pic>
+        <p:nvPicPr>
+          <p:cNvPr id="11" name="图片 10"/>
+          <p:cNvPicPr>
+            <a:picLocks noChangeAspect="1"/>
+          </p:cNvPicPr>
+          <p:nvPr/>
+        </p:nvPicPr>
+        <p:blipFill>
+          <a:blip r:embed="rId6" cstate="print">
+            <a:extLst>
+              <a:ext uri="{28A0092B-C50C-407E-A947-70E740481C1C}">
+                <a14:useLocalDpi xmlns:a14="http://schemas.microsoft.com/office/drawing/2010/main" val="0"/>
+              </a:ext>
+            </a:extLst>
+          </a:blip>
+          <a:stretch>
+            <a:fillRect/>
+          </a:stretch>
+        </p:blipFill>
+        <p:spPr>
+          <a:xfrm>
+            <a:off x="5333885" y="5021990"/>
+            <a:ext cx="2005365" cy="2836622"/>
+          </a:xfrm>
+          <a:prstGeom prst="rect">
+            <a:avLst/>
+          </a:prstGeom>
+        </p:spPr>
+      </p:pic>
+      <p:pic>
+        <p:nvPicPr>
+          <p:cNvPr id="13" name="图片 12"/>
+          <p:cNvPicPr>
+            <a:picLocks noChangeAspect="1"/>
+          </p:cNvPicPr>
+          <p:nvPr/>
+        </p:nvPicPr>
+        <p:blipFill>
+          <a:blip r:embed="rId7" cstate="print">
+            <a:extLst>
+              <a:ext uri="{28A0092B-C50C-407E-A947-70E740481C1C}">
+                <a14:useLocalDpi xmlns:a14="http://schemas.microsoft.com/office/drawing/2010/main" val="0"/>
+              </a:ext>
+            </a:extLst>
+          </a:blip>
+          <a:stretch>
+            <a:fillRect/>
+          </a:stretch>
+        </p:blipFill>
+        <p:spPr>
+          <a:xfrm>
+            <a:off x="6382139" y="5045465"/>
+            <a:ext cx="3473447" cy="2353017"/>
           </a:xfrm>
           <a:prstGeom prst="rect">
             <a:avLst/>
@@ -4235,52 +4287,12 @@
           </a:bodyPr>
           <a:p>
             <a:r>
-              <a:rPr lang="en-US" altLang="zh-CN" sz="1600">
-                <a:solidFill>
-                  <a:srgbClr val="203864"/>
-                </a:solidFill>
-              </a:rPr>
-              <a:t>GPR报告</a:t>
-            </a:r>
-            <a:r>
               <a:rPr lang="zh-CN" altLang="en-US" sz="1600">
                 <a:solidFill>
                   <a:srgbClr val="203864"/>
                 </a:solidFill>
               </a:rPr>
-              <a:t>设计</a:t>
-            </a:r>
-            <a:r>
-              <a:rPr lang="en-US" altLang="zh-CN" sz="1600">
-                <a:solidFill>
-                  <a:srgbClr val="203864"/>
-                </a:solidFill>
-              </a:rPr>
-              <a:t xml:space="preserve"> </a:t>
-            </a:r>
-            <a:r>
-              <a:rPr lang="zh-CN" altLang="en-US" sz="1600">
-                <a:solidFill>
-                  <a:srgbClr val="203864"/>
-                </a:solidFill>
-              </a:rPr>
-              <a:t>：向映妮</a:t>
-            </a:r>
-            <a:r>
-              <a:rPr lang="en-US" altLang="zh-CN" sz="1600">
-                <a:solidFill>
-                  <a:srgbClr val="203864"/>
-                </a:solidFill>
-              </a:rPr>
-              <a:t xml:space="preserve">   </a:t>
-            </a:r>
-            <a:r>
-              <a:rPr lang="zh-CN" altLang="en-US" sz="1600">
-                <a:solidFill>
-                  <a:srgbClr val="203864"/>
-                </a:solidFill>
-              </a:rPr>
-              <a:t>指导老师：张艳</a:t>
+              <a:t>GPR算法报告 · 2026-03-02</a:t>
             </a:r>
             <a:endParaRPr lang="zh-CN" altLang="en-US" sz="1600">
               <a:solidFill>
@@ -4301,14 +4313,6 @@
 <file path=ppt/slides/slide2.xml><?xml version="1.0" encoding="utf-8"?>
 <p:sld xmlns:a="http://schemas.openxmlformats.org/drawingml/2006/main" xmlns:r="http://schemas.openxmlformats.org/officeDocument/2006/relationships" xmlns:p="http://schemas.openxmlformats.org/presentationml/2006/main">
   <p:cSld>
-    <p:bg>
-      <p:bgPr>
-        <a:solidFill>
-          <a:schemeClr val="bg1"/>
-        </a:solidFill>
-        <a:effectLst/>
-      </p:bgPr>
-    </p:bg>
     <p:spTree>
       <p:nvGrpSpPr>
         <p:cNvPr id="1" name=""/>
@@ -4325,14 +4329,559 @@
       </p:grpSpPr>
       <p:sp>
         <p:nvSpPr>
-          <p:cNvPr id="40" name="文本框 39"/>
+          <p:cNvPr id="5" name="矩形 4"/>
+          <p:cNvSpPr/>
+          <p:nvPr/>
+        </p:nvSpPr>
+        <p:spPr>
+          <a:xfrm>
+            <a:off x="0" y="0"/>
+            <a:ext cx="12192000" cy="6858000"/>
+          </a:xfrm>
+          <a:prstGeom prst="rect">
+            <a:avLst/>
+          </a:prstGeom>
+          <a:solidFill>
+            <a:schemeClr val="accent1">
+              <a:lumMod val="50000"/>
+            </a:schemeClr>
+          </a:solidFill>
+          <a:ln>
+            <a:noFill/>
+          </a:ln>
+        </p:spPr>
+        <p:style>
+          <a:lnRef idx="2">
+            <a:schemeClr val="accent1">
+              <a:shade val="15000"/>
+            </a:schemeClr>
+          </a:lnRef>
+          <a:fillRef idx="1">
+            <a:schemeClr val="accent1"/>
+          </a:fillRef>
+          <a:effectRef idx="0">
+            <a:schemeClr val="accent1"/>
+          </a:effectRef>
+          <a:fontRef idx="minor">
+            <a:schemeClr val="lt1"/>
+          </a:fontRef>
+        </p:style>
+        <p:txBody>
+          <a:bodyPr rtlCol="0" anchor="ctr"/>
+          <a:lstStyle/>
+          <a:p>
+            <a:pPr algn="ctr"/>
+            <a:endParaRPr lang="zh-CN" altLang="en-US"/>
+          </a:p>
+        </p:txBody>
+      </p:sp>
+      <p:sp>
+        <p:nvSpPr>
+          <p:cNvPr id="28" name="椭圆 27"/>
+          <p:cNvSpPr/>
+          <p:nvPr/>
+        </p:nvSpPr>
+        <p:spPr>
+          <a:xfrm>
+            <a:off x="443842" y="1602149"/>
+            <a:ext cx="4013563" cy="3895891"/>
+          </a:xfrm>
+          <a:prstGeom prst="ellipse">
+            <a:avLst/>
+          </a:prstGeom>
+          <a:solidFill>
+            <a:schemeClr val="bg1"/>
+          </a:solidFill>
+          <a:ln>
+            <a:noFill/>
+          </a:ln>
+        </p:spPr>
+        <p:style>
+          <a:lnRef idx="2">
+            <a:schemeClr val="accent1">
+              <a:shade val="15000"/>
+            </a:schemeClr>
+          </a:lnRef>
+          <a:fillRef idx="1">
+            <a:schemeClr val="accent1"/>
+          </a:fillRef>
+          <a:effectRef idx="0">
+            <a:schemeClr val="accent1"/>
+          </a:effectRef>
+          <a:fontRef idx="minor">
+            <a:schemeClr val="lt1"/>
+          </a:fontRef>
+        </p:style>
+        <p:txBody>
+          <a:bodyPr rtlCol="0" anchor="ctr"/>
+          <a:lstStyle/>
+          <a:p>
+            <a:pPr algn="ctr"/>
+            <a:endParaRPr lang="zh-CN" altLang="en-US"/>
+          </a:p>
+        </p:txBody>
+      </p:sp>
+      <p:sp>
+        <p:nvSpPr>
+          <p:cNvPr id="29" name="椭圆 28"/>
+          <p:cNvSpPr/>
+          <p:nvPr/>
+        </p:nvSpPr>
+        <p:spPr>
+          <a:xfrm>
+            <a:off x="729177" y="1876352"/>
+            <a:ext cx="3442892" cy="3341951"/>
+          </a:xfrm>
+          <a:prstGeom prst="ellipse">
+            <a:avLst/>
+          </a:prstGeom>
+          <a:solidFill>
+            <a:schemeClr val="accent1">
+              <a:lumMod val="50000"/>
+            </a:schemeClr>
+          </a:solidFill>
+          <a:ln>
+            <a:noFill/>
+          </a:ln>
+        </p:spPr>
+        <p:style>
+          <a:lnRef idx="2">
+            <a:schemeClr val="accent1">
+              <a:shade val="15000"/>
+            </a:schemeClr>
+          </a:lnRef>
+          <a:fillRef idx="1">
+            <a:schemeClr val="accent1"/>
+          </a:fillRef>
+          <a:effectRef idx="0">
+            <a:schemeClr val="accent1"/>
+          </a:effectRef>
+          <a:fontRef idx="minor">
+            <a:schemeClr val="lt1"/>
+          </a:fontRef>
+        </p:style>
+        <p:txBody>
+          <a:bodyPr rtlCol="0" anchor="ctr"/>
+          <a:lstStyle/>
+          <a:p>
+            <a:pPr algn="ctr"/>
+            <a:endParaRPr lang="zh-CN" altLang="en-US"/>
+          </a:p>
+        </p:txBody>
+      </p:sp>
+      <p:sp>
+        <p:nvSpPr>
+          <p:cNvPr id="4" name="等腰三角形 3"/>
+          <p:cNvSpPr/>
+          <p:nvPr/>
+        </p:nvSpPr>
+        <p:spPr>
+          <a:xfrm rot="16200000">
+            <a:off x="23162" y="1616824"/>
+            <a:ext cx="10302766" cy="3604570"/>
+          </a:xfrm>
+          <a:prstGeom prst="triangle">
+            <a:avLst/>
+          </a:prstGeom>
+          <a:solidFill>
+            <a:schemeClr val="accent1">
+              <a:lumMod val="60000"/>
+              <a:lumOff val="40000"/>
+            </a:schemeClr>
+          </a:solidFill>
+          <a:ln>
+            <a:noFill/>
+          </a:ln>
+          <a:effectLst>
+            <a:innerShdw blurRad="63500" dist="50800" dir="13500000">
+              <a:prstClr val="black">
+                <a:alpha val="50000"/>
+              </a:prstClr>
+            </a:innerShdw>
+          </a:effectLst>
+        </p:spPr>
+        <p:style>
+          <a:lnRef idx="2">
+            <a:schemeClr val="accent1">
+              <a:shade val="15000"/>
+            </a:schemeClr>
+          </a:lnRef>
+          <a:fillRef idx="1">
+            <a:schemeClr val="accent1"/>
+          </a:fillRef>
+          <a:effectRef idx="0">
+            <a:schemeClr val="accent1"/>
+          </a:effectRef>
+          <a:fontRef idx="minor">
+            <a:schemeClr val="lt1"/>
+          </a:fontRef>
+        </p:style>
+        <p:txBody>
+          <a:bodyPr rtlCol="0" anchor="ctr"/>
+          <a:lstStyle/>
+          <a:p>
+            <a:pPr algn="ctr"/>
+            <a:endParaRPr lang="zh-CN" altLang="en-US" dirty="0"/>
+          </a:p>
+        </p:txBody>
+      </p:sp>
+      <p:sp>
+        <p:nvSpPr>
+          <p:cNvPr id="3" name="等腰三角形 2"/>
+          <p:cNvSpPr/>
+          <p:nvPr/>
+        </p:nvSpPr>
+        <p:spPr>
+          <a:xfrm rot="16200000">
+            <a:off x="676035" y="1606932"/>
+            <a:ext cx="10302766" cy="3604570"/>
+          </a:xfrm>
+          <a:prstGeom prst="triangle">
+            <a:avLst/>
+          </a:prstGeom>
+          <a:solidFill>
+            <a:schemeClr val="accent5">
+              <a:lumMod val="20000"/>
+              <a:lumOff val="80000"/>
+            </a:schemeClr>
+          </a:solidFill>
+          <a:ln>
+            <a:noFill/>
+          </a:ln>
+          <a:effectLst>
+            <a:innerShdw blurRad="63500" dist="50800" dir="13500000">
+              <a:prstClr val="black">
+                <a:alpha val="50000"/>
+              </a:prstClr>
+            </a:innerShdw>
+          </a:effectLst>
+        </p:spPr>
+        <p:style>
+          <a:lnRef idx="2">
+            <a:schemeClr val="accent1">
+              <a:shade val="15000"/>
+            </a:schemeClr>
+          </a:lnRef>
+          <a:fillRef idx="1">
+            <a:schemeClr val="accent1"/>
+          </a:fillRef>
+          <a:effectRef idx="0">
+            <a:schemeClr val="accent1"/>
+          </a:effectRef>
+          <a:fontRef idx="minor">
+            <a:schemeClr val="lt1"/>
+          </a:fontRef>
+        </p:style>
+        <p:txBody>
+          <a:bodyPr rtlCol="0" anchor="ctr"/>
+          <a:lstStyle/>
+          <a:p>
+            <a:pPr algn="ctr"/>
+            <a:endParaRPr lang="zh-CN" altLang="en-US" dirty="0"/>
+          </a:p>
+        </p:txBody>
+      </p:sp>
+      <p:sp>
+        <p:nvSpPr>
+          <p:cNvPr id="2" name="等腰三角形 1"/>
+          <p:cNvSpPr/>
+          <p:nvPr/>
+        </p:nvSpPr>
+        <p:spPr>
+          <a:xfrm rot="16200000">
+            <a:off x="1414460" y="1626715"/>
+            <a:ext cx="10302766" cy="3604570"/>
+          </a:xfrm>
+          <a:prstGeom prst="triangle">
+            <a:avLst/>
+          </a:prstGeom>
+          <a:solidFill>
+            <a:schemeClr val="bg1"/>
+          </a:solidFill>
+          <a:ln>
+            <a:noFill/>
+          </a:ln>
+          <a:effectLst>
+            <a:innerShdw blurRad="63500" dist="50800" dir="13500000">
+              <a:prstClr val="black">
+                <a:alpha val="50000"/>
+              </a:prstClr>
+            </a:innerShdw>
+          </a:effectLst>
+        </p:spPr>
+        <p:style>
+          <a:lnRef idx="2">
+            <a:schemeClr val="accent1">
+              <a:shade val="15000"/>
+            </a:schemeClr>
+          </a:lnRef>
+          <a:fillRef idx="1">
+            <a:schemeClr val="accent1"/>
+          </a:fillRef>
+          <a:effectRef idx="0">
+            <a:schemeClr val="accent1"/>
+          </a:effectRef>
+          <a:fontRef idx="minor">
+            <a:schemeClr val="lt1"/>
+          </a:fontRef>
+        </p:style>
+        <p:txBody>
+          <a:bodyPr rtlCol="0" anchor="ctr"/>
+          <a:lstStyle/>
+          <a:p>
+            <a:pPr algn="ctr"/>
+            <a:endParaRPr lang="zh-CN" altLang="en-US" dirty="0"/>
+          </a:p>
+        </p:txBody>
+      </p:sp>
+      <p:sp>
+        <p:nvSpPr>
+          <p:cNvPr id="7" name="矩形 6"/>
+          <p:cNvSpPr/>
+          <p:nvPr/>
+        </p:nvSpPr>
+        <p:spPr>
+          <a:xfrm>
+            <a:off x="7865195" y="0"/>
+            <a:ext cx="4326806" cy="6858000"/>
+          </a:xfrm>
+          <a:prstGeom prst="rect">
+            <a:avLst/>
+          </a:prstGeom>
+          <a:solidFill>
+            <a:schemeClr val="bg1"/>
+          </a:solidFill>
+          <a:ln>
+            <a:noFill/>
+          </a:ln>
+        </p:spPr>
+        <p:style>
+          <a:lnRef idx="2">
+            <a:schemeClr val="accent1">
+              <a:shade val="15000"/>
+            </a:schemeClr>
+          </a:lnRef>
+          <a:fillRef idx="1">
+            <a:schemeClr val="accent1"/>
+          </a:fillRef>
+          <a:effectRef idx="0">
+            <a:schemeClr val="accent1"/>
+          </a:effectRef>
+          <a:fontRef idx="minor">
+            <a:schemeClr val="lt1"/>
+          </a:fontRef>
+        </p:style>
+        <p:txBody>
+          <a:bodyPr rtlCol="0" anchor="ctr"/>
+          <a:lstStyle/>
+          <a:p>
+            <a:pPr algn="ctr"/>
+            <a:endParaRPr lang="zh-CN" altLang="en-US"/>
+          </a:p>
+        </p:txBody>
+      </p:sp>
+      <p:sp>
+        <p:nvSpPr>
+          <p:cNvPr id="11" name="椭圆 10"/>
+          <p:cNvSpPr/>
+          <p:nvPr/>
+        </p:nvSpPr>
+        <p:spPr>
+          <a:xfrm>
+            <a:off x="7022615" y="3744283"/>
+            <a:ext cx="913947" cy="887151"/>
+          </a:xfrm>
+          <a:prstGeom prst="ellipse">
+            <a:avLst/>
+          </a:prstGeom>
+          <a:solidFill>
+            <a:schemeClr val="accent1">
+              <a:lumMod val="50000"/>
+            </a:schemeClr>
+          </a:solidFill>
+          <a:ln>
+            <a:noFill/>
+          </a:ln>
+        </p:spPr>
+        <p:style>
+          <a:lnRef idx="2">
+            <a:schemeClr val="accent1">
+              <a:shade val="15000"/>
+            </a:schemeClr>
+          </a:lnRef>
+          <a:fillRef idx="1">
+            <a:schemeClr val="accent1"/>
+          </a:fillRef>
+          <a:effectRef idx="0">
+            <a:schemeClr val="accent1"/>
+          </a:effectRef>
+          <a:fontRef idx="minor">
+            <a:schemeClr val="lt1"/>
+          </a:fontRef>
+        </p:style>
+        <p:txBody>
+          <a:bodyPr rtlCol="0" anchor="ctr"/>
+          <a:lstStyle/>
+          <a:p>
+            <a:pPr algn="ctr"/>
+            <a:endParaRPr lang="zh-CN" altLang="en-US"/>
+          </a:p>
+        </p:txBody>
+      </p:sp>
+      <p:sp>
+        <p:nvSpPr>
+          <p:cNvPr id="12" name="椭圆 11"/>
+          <p:cNvSpPr/>
+          <p:nvPr/>
+        </p:nvSpPr>
+        <p:spPr>
+          <a:xfrm>
+            <a:off x="7022615" y="777169"/>
+            <a:ext cx="913947" cy="887151"/>
+          </a:xfrm>
+          <a:prstGeom prst="ellipse">
+            <a:avLst/>
+          </a:prstGeom>
+          <a:solidFill>
+            <a:schemeClr val="accent1">
+              <a:lumMod val="50000"/>
+            </a:schemeClr>
+          </a:solidFill>
+          <a:ln>
+            <a:noFill/>
+          </a:ln>
+        </p:spPr>
+        <p:style>
+          <a:lnRef idx="2">
+            <a:schemeClr val="accent1">
+              <a:shade val="15000"/>
+            </a:schemeClr>
+          </a:lnRef>
+          <a:fillRef idx="1">
+            <a:schemeClr val="accent1"/>
+          </a:fillRef>
+          <a:effectRef idx="0">
+            <a:schemeClr val="accent1"/>
+          </a:effectRef>
+          <a:fontRef idx="minor">
+            <a:schemeClr val="lt1"/>
+          </a:fontRef>
+        </p:style>
+        <p:txBody>
+          <a:bodyPr rtlCol="0" anchor="ctr"/>
+          <a:lstStyle/>
+          <a:p>
+            <a:pPr algn="ctr"/>
+            <a:endParaRPr lang="zh-CN" altLang="en-US"/>
+          </a:p>
+        </p:txBody>
+      </p:sp>
+      <p:sp>
+        <p:nvSpPr>
+          <p:cNvPr id="13" name="椭圆 12"/>
+          <p:cNvSpPr/>
+          <p:nvPr/>
+        </p:nvSpPr>
+        <p:spPr>
+          <a:xfrm>
+            <a:off x="7022615" y="2260726"/>
+            <a:ext cx="913947" cy="887151"/>
+          </a:xfrm>
+          <a:prstGeom prst="ellipse">
+            <a:avLst/>
+          </a:prstGeom>
+          <a:solidFill>
+            <a:schemeClr val="accent1">
+              <a:lumMod val="50000"/>
+            </a:schemeClr>
+          </a:solidFill>
+          <a:ln>
+            <a:noFill/>
+          </a:ln>
+        </p:spPr>
+        <p:style>
+          <a:lnRef idx="2">
+            <a:schemeClr val="accent1">
+              <a:shade val="15000"/>
+            </a:schemeClr>
+          </a:lnRef>
+          <a:fillRef idx="1">
+            <a:schemeClr val="accent1"/>
+          </a:fillRef>
+          <a:effectRef idx="0">
+            <a:schemeClr val="accent1"/>
+          </a:effectRef>
+          <a:fontRef idx="minor">
+            <a:schemeClr val="lt1"/>
+          </a:fontRef>
+        </p:style>
+        <p:txBody>
+          <a:bodyPr rtlCol="0" anchor="ctr"/>
+          <a:lstStyle/>
+          <a:p>
+            <a:pPr algn="ctr"/>
+            <a:endParaRPr lang="zh-CN" altLang="en-US" dirty="0"/>
+          </a:p>
+        </p:txBody>
+      </p:sp>
+      <p:sp>
+        <p:nvSpPr>
+          <p:cNvPr id="14" name="椭圆 13"/>
+          <p:cNvSpPr/>
+          <p:nvPr/>
+        </p:nvSpPr>
+        <p:spPr>
+          <a:xfrm>
+            <a:off x="7022615" y="5257422"/>
+            <a:ext cx="913947" cy="887151"/>
+          </a:xfrm>
+          <a:prstGeom prst="ellipse">
+            <a:avLst/>
+          </a:prstGeom>
+          <a:solidFill>
+            <a:schemeClr val="accent1">
+              <a:lumMod val="50000"/>
+            </a:schemeClr>
+          </a:solidFill>
+          <a:ln>
+            <a:noFill/>
+          </a:ln>
+        </p:spPr>
+        <p:style>
+          <a:lnRef idx="2">
+            <a:schemeClr val="accent1">
+              <a:shade val="15000"/>
+            </a:schemeClr>
+          </a:lnRef>
+          <a:fillRef idx="1">
+            <a:schemeClr val="accent1"/>
+          </a:fillRef>
+          <a:effectRef idx="0">
+            <a:schemeClr val="accent1"/>
+          </a:effectRef>
+          <a:fontRef idx="minor">
+            <a:schemeClr val="lt1"/>
+          </a:fontRef>
+        </p:style>
+        <p:txBody>
+          <a:bodyPr rtlCol="0" anchor="ctr"/>
+          <a:lstStyle/>
+          <a:p>
+            <a:pPr algn="ctr"/>
+            <a:endParaRPr lang="zh-CN" altLang="en-US"/>
+          </a:p>
+        </p:txBody>
+      </p:sp>
+      <p:sp>
+        <p:nvSpPr>
+          <p:cNvPr id="15" name="文本框 14"/>
           <p:cNvSpPr txBox="1"/>
           <p:nvPr/>
         </p:nvSpPr>
         <p:spPr>
           <a:xfrm>
-            <a:off x="1429309" y="1908944"/>
-            <a:ext cx="4349262" cy="460375"/>
+            <a:off x="7184260" y="823006"/>
+            <a:ext cx="728286" cy="707886"/>
           </a:xfrm>
           <a:prstGeom prst="rect">
             <a:avLst/>
@@ -4346,7 +4895,178 @@
           <a:lstStyle/>
           <a:p>
             <a:r>
-              <a:rPr lang="zh-CN" altLang="en-US" sz="2400" dirty="0">
+              <a:rPr lang="en-US" altLang="zh-CN" sz="4000" dirty="0">
+                <a:solidFill>
+                  <a:schemeClr val="bg1"/>
+                </a:solidFill>
+                <a:latin typeface="黑体" panose="02010609060101010101" pitchFamily="49" charset="-122"/>
+                <a:ea typeface="黑体" panose="02010609060101010101" pitchFamily="49" charset="-122"/>
+              </a:rPr>
+              <a:t>01</a:t>
+            </a:r>
+            <a:endParaRPr lang="zh-CN" altLang="en-US" sz="4000" dirty="0">
+              <a:solidFill>
+                <a:schemeClr val="bg1"/>
+              </a:solidFill>
+              <a:latin typeface="黑体" panose="02010609060101010101" pitchFamily="49" charset="-122"/>
+              <a:ea typeface="黑体" panose="02010609060101010101" pitchFamily="49" charset="-122"/>
+            </a:endParaRPr>
+          </a:p>
+        </p:txBody>
+      </p:sp>
+      <p:sp>
+        <p:nvSpPr>
+          <p:cNvPr id="16" name="文本框 15"/>
+          <p:cNvSpPr txBox="1"/>
+          <p:nvPr/>
+        </p:nvSpPr>
+        <p:spPr>
+          <a:xfrm>
+            <a:off x="7127236" y="2322620"/>
+            <a:ext cx="737958" cy="707886"/>
+          </a:xfrm>
+          <a:prstGeom prst="rect">
+            <a:avLst/>
+          </a:prstGeom>
+          <a:noFill/>
+        </p:spPr>
+        <p:txBody>
+          <a:bodyPr wrap="square" rtlCol="0">
+            <a:spAutoFit/>
+          </a:bodyPr>
+          <a:lstStyle/>
+          <a:p>
+            <a:pPr algn="ctr"/>
+            <a:r>
+              <a:rPr lang="en-US" altLang="zh-CN" sz="4000" dirty="0">
+                <a:solidFill>
+                  <a:schemeClr val="bg1"/>
+                </a:solidFill>
+                <a:latin typeface="黑体" panose="02010609060101010101" pitchFamily="49" charset="-122"/>
+                <a:ea typeface="黑体" panose="02010609060101010101" pitchFamily="49" charset="-122"/>
+              </a:rPr>
+              <a:t>02</a:t>
+            </a:r>
+            <a:endParaRPr lang="zh-CN" altLang="en-US" sz="4000" dirty="0">
+              <a:solidFill>
+                <a:schemeClr val="bg1"/>
+              </a:solidFill>
+              <a:latin typeface="黑体" panose="02010609060101010101" pitchFamily="49" charset="-122"/>
+              <a:ea typeface="黑体" panose="02010609060101010101" pitchFamily="49" charset="-122"/>
+            </a:endParaRPr>
+          </a:p>
+        </p:txBody>
+      </p:sp>
+      <p:sp>
+        <p:nvSpPr>
+          <p:cNvPr id="17" name="文本框 16"/>
+          <p:cNvSpPr txBox="1"/>
+          <p:nvPr/>
+        </p:nvSpPr>
+        <p:spPr>
+          <a:xfrm>
+            <a:off x="7029140" y="3779941"/>
+            <a:ext cx="877634" cy="707886"/>
+          </a:xfrm>
+          <a:prstGeom prst="rect">
+            <a:avLst/>
+          </a:prstGeom>
+          <a:noFill/>
+        </p:spPr>
+        <p:txBody>
+          <a:bodyPr wrap="square" rtlCol="0">
+            <a:spAutoFit/>
+          </a:bodyPr>
+          <a:lstStyle/>
+          <a:p>
+            <a:pPr algn="ctr"/>
+            <a:r>
+              <a:rPr lang="en-US" altLang="zh-CN" sz="4000" dirty="0">
+                <a:solidFill>
+                  <a:schemeClr val="bg1"/>
+                </a:solidFill>
+                <a:latin typeface="黑体" panose="02010609060101010101" pitchFamily="49" charset="-122"/>
+                <a:ea typeface="黑体" panose="02010609060101010101" pitchFamily="49" charset="-122"/>
+              </a:rPr>
+              <a:t>03</a:t>
+            </a:r>
+            <a:endParaRPr lang="zh-CN" altLang="en-US" sz="4000" dirty="0">
+              <a:solidFill>
+                <a:schemeClr val="bg1"/>
+              </a:solidFill>
+              <a:latin typeface="黑体" panose="02010609060101010101" pitchFamily="49" charset="-122"/>
+              <a:ea typeface="黑体" panose="02010609060101010101" pitchFamily="49" charset="-122"/>
+            </a:endParaRPr>
+          </a:p>
+        </p:txBody>
+      </p:sp>
+      <p:sp>
+        <p:nvSpPr>
+          <p:cNvPr id="18" name="文本框 17"/>
+          <p:cNvSpPr txBox="1"/>
+          <p:nvPr/>
+        </p:nvSpPr>
+        <p:spPr>
+          <a:xfrm>
+            <a:off x="7030696" y="5306645"/>
+            <a:ext cx="913947" cy="707886"/>
+          </a:xfrm>
+          <a:prstGeom prst="rect">
+            <a:avLst/>
+          </a:prstGeom>
+          <a:noFill/>
+        </p:spPr>
+        <p:txBody>
+          <a:bodyPr wrap="square" rtlCol="0">
+            <a:spAutoFit/>
+          </a:bodyPr>
+          <a:lstStyle/>
+          <a:p>
+            <a:pPr algn="ctr"/>
+            <a:r>
+              <a:rPr lang="en-US" altLang="zh-CN" sz="4000" dirty="0">
+                <a:solidFill>
+                  <a:schemeClr val="bg1"/>
+                </a:solidFill>
+                <a:latin typeface="黑体" panose="02010609060101010101" pitchFamily="49" charset="-122"/>
+                <a:ea typeface="黑体" panose="02010609060101010101" pitchFamily="49" charset="-122"/>
+              </a:rPr>
+              <a:t>04</a:t>
+            </a:r>
+            <a:endParaRPr lang="zh-CN" altLang="en-US" sz="4000" dirty="0">
+              <a:solidFill>
+                <a:schemeClr val="bg1"/>
+              </a:solidFill>
+              <a:latin typeface="黑体" panose="02010609060101010101" pitchFamily="49" charset="-122"/>
+              <a:ea typeface="黑体" panose="02010609060101010101" pitchFamily="49" charset="-122"/>
+            </a:endParaRPr>
+          </a:p>
+        </p:txBody>
+      </p:sp>
+      <p:sp>
+        <p:nvSpPr>
+          <p:cNvPr id="19" name="文本框 18"/>
+          <p:cNvSpPr txBox="1"/>
+          <p:nvPr/>
+        </p:nvSpPr>
+        <p:spPr>
+          <a:xfrm>
+            <a:off x="8239011" y="812229"/>
+            <a:ext cx="4217158" cy="707886"/>
+          </a:xfrm>
+          <a:prstGeom prst="rect">
+            <a:avLst/>
+          </a:prstGeom>
+          <a:noFill/>
+        </p:spPr>
+        <p:txBody>
+          <a:bodyPr wrap="square" rtlCol="0">
+            <a:spAutoFit/>
+          </a:bodyPr>
+          <a:lstStyle/>
+          <a:p>
+            <a:r>
+              <a:rPr lang="zh-CN" altLang="en-US" sz="4000" dirty="0">
                 <a:solidFill>
                   <a:schemeClr val="accent1">
                     <a:lumMod val="50000"/>
@@ -4357,19 +5077,28 @@
               </a:rPr>
               <a:t>原始方法与问题</a:t>
             </a:r>
-          </a:p>
-        </p:txBody>
-      </p:sp>
-      <p:sp>
-        <p:nvSpPr>
-          <p:cNvPr id="43" name="文本框 42"/>
+            <a:endParaRPr lang="zh-CN" altLang="en-US" sz="4000" dirty="0">
+              <a:solidFill>
+                <a:schemeClr val="accent1">
+                  <a:lumMod val="50000"/>
+                </a:schemeClr>
+              </a:solidFill>
+              <a:latin typeface="黑体" panose="02010609060101010101" pitchFamily="49" charset="-122"/>
+              <a:ea typeface="黑体" panose="02010609060101010101" pitchFamily="49" charset="-122"/>
+            </a:endParaRPr>
+          </a:p>
+        </p:txBody>
+      </p:sp>
+      <p:sp>
+        <p:nvSpPr>
+          <p:cNvPr id="20" name="文本框 19"/>
           <p:cNvSpPr txBox="1"/>
           <p:nvPr/>
         </p:nvSpPr>
         <p:spPr>
           <a:xfrm>
-            <a:off x="1468755" y="2370455"/>
-            <a:ext cx="9497695" cy="645160"/>
+            <a:off x="8301517" y="2245280"/>
+            <a:ext cx="3411940" cy="707886"/>
           </a:xfrm>
           <a:prstGeom prst="rect">
             <a:avLst/>
@@ -4383,22 +5112,39 @@
           <a:lstStyle/>
           <a:p>
             <a:r>
-              <a:rPr lang="zh-CN" altLang="en-US" dirty="0"/>
-              <a:t>原始方法与问题</a:t>
-            </a:r>
-          </a:p>
-        </p:txBody>
-      </p:sp>
-      <p:sp>
-        <p:nvSpPr>
-          <p:cNvPr id="7" name="文本框 6"/>
+              <a:rPr lang="zh-CN" altLang="en-US" sz="4000" dirty="0">
+                <a:solidFill>
+                  <a:schemeClr val="accent1">
+                    <a:lumMod val="50000"/>
+                  </a:schemeClr>
+                </a:solidFill>
+                <a:latin typeface="黑体" panose="02010609060101010101" pitchFamily="49" charset="-122"/>
+                <a:ea typeface="黑体" panose="02010609060101010101" pitchFamily="49" charset="-122"/>
+              </a:rPr>
+              <a:t>文献调研与改进</a:t>
+            </a:r>
+            <a:endParaRPr lang="zh-CN" altLang="en-US" sz="4000" dirty="0">
+              <a:solidFill>
+                <a:schemeClr val="accent1">
+                  <a:lumMod val="50000"/>
+                </a:schemeClr>
+              </a:solidFill>
+              <a:latin typeface="黑体" panose="02010609060101010101" pitchFamily="49" charset="-122"/>
+              <a:ea typeface="黑体" panose="02010609060101010101" pitchFamily="49" charset="-122"/>
+            </a:endParaRPr>
+          </a:p>
+        </p:txBody>
+      </p:sp>
+      <p:sp>
+        <p:nvSpPr>
+          <p:cNvPr id="21" name="文本框 20"/>
           <p:cNvSpPr txBox="1"/>
           <p:nvPr/>
         </p:nvSpPr>
         <p:spPr>
           <a:xfrm>
-            <a:off x="1290320" y="1459847"/>
-            <a:ext cx="5628640" cy="584775"/>
+            <a:off x="8301517" y="3783310"/>
+            <a:ext cx="2970400" cy="707886"/>
           </a:xfrm>
           <a:prstGeom prst="rect">
             <a:avLst/>
@@ -4412,28 +5158,85 @@
           <a:lstStyle/>
           <a:p>
             <a:r>
-              <a:rPr lang="zh-CN" altLang="en-US" sz="3200" dirty="0">
+              <a:rPr lang="zh-CN" altLang="en-US" sz="4000" dirty="0">
                 <a:solidFill>
-                  <a:schemeClr val="bg1"/>
+                  <a:schemeClr val="accent1">
+                    <a:lumMod val="50000"/>
+                  </a:schemeClr>
+                </a:solidFill>
+                <a:latin typeface="黑体" panose="02010609060101010101" pitchFamily="49" charset="-122"/>
+                <a:ea typeface="黑体" panose="02010609060101010101" pitchFamily="49" charset="-122"/>
+              </a:rPr>
+              <a:t>消融指标对比</a:t>
+            </a:r>
+            <a:endParaRPr lang="zh-CN" altLang="en-US" sz="4000" dirty="0">
+              <a:solidFill>
+                <a:schemeClr val="accent1">
+                  <a:lumMod val="50000"/>
+                </a:schemeClr>
+              </a:solidFill>
+              <a:latin typeface="黑体" panose="02010609060101010101" pitchFamily="49" charset="-122"/>
+              <a:ea typeface="黑体" panose="02010609060101010101" pitchFamily="49" charset="-122"/>
+            </a:endParaRPr>
+          </a:p>
+        </p:txBody>
+      </p:sp>
+      <p:sp>
+        <p:nvSpPr>
+          <p:cNvPr id="22" name="文本框 21"/>
+          <p:cNvSpPr txBox="1"/>
+          <p:nvPr/>
+        </p:nvSpPr>
+        <p:spPr>
+          <a:xfrm>
+            <a:off x="8313835" y="5377693"/>
+            <a:ext cx="3524252" cy="707886"/>
+          </a:xfrm>
+          <a:prstGeom prst="rect">
+            <a:avLst/>
+          </a:prstGeom>
+          <a:noFill/>
+        </p:spPr>
+        <p:txBody>
+          <a:bodyPr wrap="square" rtlCol="0">
+            <a:spAutoFit/>
+          </a:bodyPr>
+          <a:lstStyle/>
+          <a:p>
+            <a:r>
+              <a:rPr lang="zh-CN" altLang="en-US" sz="4000" dirty="0">
+                <a:solidFill>
+                  <a:schemeClr val="accent1">
+                    <a:lumMod val="50000"/>
+                  </a:schemeClr>
                 </a:solidFill>
                 <a:latin typeface="黑体" panose="02010609060101010101" pitchFamily="49" charset="-122"/>
                 <a:ea typeface="黑体" panose="02010609060101010101" pitchFamily="49" charset="-122"/>
               </a:rPr>
               <a:t>结论与待解决</a:t>
             </a:r>
+            <a:endParaRPr lang="zh-CN" altLang="en-US" sz="4000" dirty="0">
+              <a:solidFill>
+                <a:schemeClr val="accent1">
+                  <a:lumMod val="50000"/>
+                </a:schemeClr>
+              </a:solidFill>
+              <a:latin typeface="黑体" panose="02010609060101010101" pitchFamily="49" charset="-122"/>
+              <a:ea typeface="黑体" panose="02010609060101010101" pitchFamily="49" charset="-122"/>
+            </a:endParaRPr>
           </a:p>
         </p:txBody>
       </p:sp>
       <p:pic>
         <p:nvPicPr>
-          <p:cNvPr id="21" name="图片 20"/>
+          <p:cNvPr id="25" name="图片 24"/>
           <p:cNvPicPr>
             <a:picLocks noChangeAspect="1"/>
           </p:cNvPicPr>
           <p:nvPr/>
         </p:nvPicPr>
         <p:blipFill>
-          <a:blip r:embed="rId2" cstate="print">
+          <a:blip r:embed="rId1" cstate="print">
             <a:extLst>
               <a:ext uri="{28A0092B-C50C-407E-A947-70E740481C1C}">
                 <a14:useLocalDpi xmlns:a14="http://schemas.microsoft.com/office/drawing/2010/main" val="0"/>
@@ -4446,294 +5249,24 @@
         </p:blipFill>
         <p:spPr>
           <a:xfrm>
-            <a:off x="5009301" y="-83132"/>
-            <a:ext cx="1429499" cy="2022049"/>
+            <a:off x="-131559" y="-849874"/>
+            <a:ext cx="4161137" cy="2942086"/>
           </a:xfrm>
           <a:prstGeom prst="rect">
             <a:avLst/>
           </a:prstGeom>
         </p:spPr>
       </p:pic>
-      <p:pic>
-        <p:nvPicPr>
-          <p:cNvPr id="22" name="图片 21"/>
-          <p:cNvPicPr>
-            <a:picLocks noChangeAspect="1"/>
-          </p:cNvPicPr>
-          <p:nvPr/>
-        </p:nvPicPr>
-        <p:blipFill>
-          <a:blip r:embed="rId3" cstate="print">
-            <a:extLst>
-              <a:ext uri="{28A0092B-C50C-407E-A947-70E740481C1C}">
-                <a14:useLocalDpi xmlns:a14="http://schemas.microsoft.com/office/drawing/2010/main" val="0"/>
-              </a:ext>
-            </a:extLst>
-          </a:blip>
-          <a:stretch>
-            <a:fillRect/>
-          </a:stretch>
-        </p:blipFill>
-        <p:spPr>
-          <a:xfrm>
-            <a:off x="4074579" y="-101986"/>
-            <a:ext cx="1218069" cy="2177058"/>
-          </a:xfrm>
-          <a:prstGeom prst="rect">
-            <a:avLst/>
-          </a:prstGeom>
-        </p:spPr>
-      </p:pic>
-      <p:sp>
-        <p:nvSpPr>
-          <p:cNvPr id="25" name="箭头: 五边形 24"/>
-          <p:cNvSpPr/>
-          <p:nvPr/>
-        </p:nvSpPr>
-        <p:spPr>
-          <a:xfrm>
-            <a:off x="0" y="478074"/>
-            <a:ext cx="7266562" cy="642025"/>
-          </a:xfrm>
-          <a:prstGeom prst="homePlate">
-            <a:avLst/>
-          </a:prstGeom>
-          <a:solidFill>
-            <a:schemeClr val="accent1">
-              <a:lumMod val="50000"/>
-            </a:schemeClr>
-          </a:solidFill>
-          <a:ln>
-            <a:noFill/>
-          </a:ln>
-          <a:effectLst>
-            <a:outerShdw blurRad="50800" dist="38100" dir="2700000" algn="tl" rotWithShape="0">
-              <a:prstClr val="black">
-                <a:alpha val="40000"/>
-              </a:prstClr>
-            </a:outerShdw>
-          </a:effectLst>
-        </p:spPr>
-        <p:style>
-          <a:lnRef idx="2">
-            <a:schemeClr val="accent1">
-              <a:shade val="15000"/>
-            </a:schemeClr>
-          </a:lnRef>
-          <a:fillRef idx="1">
-            <a:schemeClr val="accent1"/>
-          </a:fillRef>
-          <a:effectRef idx="0">
-            <a:schemeClr val="accent1"/>
-          </a:effectRef>
-          <a:fontRef idx="minor">
-            <a:schemeClr val="lt1"/>
-          </a:fontRef>
-        </p:style>
-        <p:txBody>
-          <a:bodyPr rtlCol="0" anchor="ctr"/>
-          <a:lstStyle/>
-          <a:p>
-            <a:pPr algn="ctr"/>
-            <a:endParaRPr lang="zh-CN" altLang="en-US"/>
-          </a:p>
-        </p:txBody>
-      </p:sp>
-      <p:sp>
-        <p:nvSpPr>
-          <p:cNvPr id="26" name="箭头: V 形 25"/>
-          <p:cNvSpPr/>
-          <p:nvPr/>
-        </p:nvSpPr>
-        <p:spPr>
-          <a:xfrm>
-            <a:off x="7072641" y="478073"/>
-            <a:ext cx="523925" cy="642025"/>
-          </a:xfrm>
-          <a:prstGeom prst="chevron">
-            <a:avLst>
-              <a:gd name="adj" fmla="val 62487"/>
-            </a:avLst>
-          </a:prstGeom>
-          <a:solidFill>
-            <a:schemeClr val="accent1">
-              <a:lumMod val="75000"/>
-            </a:schemeClr>
-          </a:solidFill>
-          <a:ln>
-            <a:noFill/>
-          </a:ln>
-          <a:effectLst>
-            <a:outerShdw blurRad="50800" dist="38100" dir="2700000" algn="tl" rotWithShape="0">
-              <a:prstClr val="black">
-                <a:alpha val="40000"/>
-              </a:prstClr>
-            </a:outerShdw>
-          </a:effectLst>
-        </p:spPr>
-        <p:style>
-          <a:lnRef idx="2">
-            <a:schemeClr val="accent1">
-              <a:shade val="15000"/>
-            </a:schemeClr>
-          </a:lnRef>
-          <a:fillRef idx="1">
-            <a:schemeClr val="accent1"/>
-          </a:fillRef>
-          <a:effectRef idx="0">
-            <a:schemeClr val="accent1"/>
-          </a:effectRef>
-          <a:fontRef idx="minor">
-            <a:schemeClr val="lt1"/>
-          </a:fontRef>
-        </p:style>
-        <p:txBody>
-          <a:bodyPr rtlCol="0" anchor="ctr"/>
-          <a:lstStyle/>
-          <a:p>
-            <a:pPr algn="ctr"/>
-            <a:endParaRPr lang="zh-CN" altLang="en-US" dirty="0">
-              <a:solidFill>
-                <a:schemeClr val="tx1"/>
-              </a:solidFill>
-            </a:endParaRPr>
-          </a:p>
-        </p:txBody>
-      </p:sp>
-      <p:sp>
-        <p:nvSpPr>
-          <p:cNvPr id="27" name="箭头: V 形 26"/>
-          <p:cNvSpPr/>
-          <p:nvPr/>
-        </p:nvSpPr>
-        <p:spPr>
-          <a:xfrm>
-            <a:off x="7424379" y="478073"/>
-            <a:ext cx="427941" cy="642025"/>
-          </a:xfrm>
-          <a:prstGeom prst="chevron">
-            <a:avLst>
-              <a:gd name="adj" fmla="val 76041"/>
-            </a:avLst>
-          </a:prstGeom>
-          <a:solidFill>
-            <a:schemeClr val="accent1">
-              <a:lumMod val="60000"/>
-              <a:lumOff val="40000"/>
-            </a:schemeClr>
-          </a:solidFill>
-          <a:ln>
-            <a:noFill/>
-          </a:ln>
-          <a:effectLst>
-            <a:outerShdw blurRad="50800" dist="38100" dir="2700000" algn="tl" rotWithShape="0">
-              <a:prstClr val="black">
-                <a:alpha val="40000"/>
-              </a:prstClr>
-            </a:outerShdw>
-          </a:effectLst>
-        </p:spPr>
-        <p:style>
-          <a:lnRef idx="2">
-            <a:schemeClr val="accent1">
-              <a:shade val="15000"/>
-            </a:schemeClr>
-          </a:lnRef>
-          <a:fillRef idx="1">
-            <a:schemeClr val="accent1"/>
-          </a:fillRef>
-          <a:effectRef idx="0">
-            <a:schemeClr val="accent1"/>
-          </a:effectRef>
-          <a:fontRef idx="minor">
-            <a:schemeClr val="lt1"/>
-          </a:fontRef>
-        </p:style>
-        <p:txBody>
-          <a:bodyPr rtlCol="0" anchor="ctr"/>
-          <a:lstStyle/>
-          <a:p>
-            <a:pPr algn="ctr"/>
-            <a:endParaRPr lang="zh-CN" altLang="en-US" dirty="0">
-              <a:solidFill>
-                <a:schemeClr val="tx1"/>
-              </a:solidFill>
-            </a:endParaRPr>
-          </a:p>
-        </p:txBody>
-      </p:sp>
-      <p:sp>
-        <p:nvSpPr>
-          <p:cNvPr id="28" name="箭头: V 形 27"/>
-          <p:cNvSpPr/>
-          <p:nvPr/>
-        </p:nvSpPr>
-        <p:spPr>
-          <a:xfrm>
-            <a:off x="7755773" y="478073"/>
-            <a:ext cx="373468" cy="642025"/>
-          </a:xfrm>
-          <a:prstGeom prst="chevron">
-            <a:avLst>
-              <a:gd name="adj" fmla="val 85754"/>
-            </a:avLst>
-          </a:prstGeom>
-          <a:solidFill>
-            <a:schemeClr val="accent1">
-              <a:lumMod val="40000"/>
-              <a:lumOff val="60000"/>
-            </a:schemeClr>
-          </a:solidFill>
-          <a:ln>
-            <a:noFill/>
-          </a:ln>
-          <a:effectLst>
-            <a:outerShdw blurRad="50800" dist="38100" dir="2700000" algn="tl" rotWithShape="0">
-              <a:prstClr val="black">
-                <a:alpha val="40000"/>
-              </a:prstClr>
-            </a:outerShdw>
-          </a:effectLst>
-        </p:spPr>
-        <p:style>
-          <a:lnRef idx="2">
-            <a:schemeClr val="accent1">
-              <a:shade val="15000"/>
-            </a:schemeClr>
-          </a:lnRef>
-          <a:fillRef idx="1">
-            <a:schemeClr val="accent1"/>
-          </a:fillRef>
-          <a:effectRef idx="0">
-            <a:schemeClr val="accent1"/>
-          </a:effectRef>
-          <a:fontRef idx="minor">
-            <a:schemeClr val="lt1"/>
-          </a:fontRef>
-        </p:style>
-        <p:txBody>
-          <a:bodyPr rtlCol="0" anchor="ctr"/>
-          <a:lstStyle/>
-          <a:p>
-            <a:pPr algn="ctr"/>
-            <a:endParaRPr lang="zh-CN" altLang="en-US" dirty="0">
-              <a:solidFill>
-                <a:schemeClr val="tx1"/>
-              </a:solidFill>
-            </a:endParaRPr>
-          </a:p>
-        </p:txBody>
-      </p:sp>
-      <p:sp>
-        <p:nvSpPr>
-          <p:cNvPr id="29" name="文本框 28"/>
+      <p:sp>
+        <p:nvSpPr>
+          <p:cNvPr id="27" name="文本框 26"/>
           <p:cNvSpPr txBox="1"/>
           <p:nvPr/>
         </p:nvSpPr>
         <p:spPr>
           <a:xfrm>
-            <a:off x="752997" y="461745"/>
-            <a:ext cx="5393803" cy="645160"/>
+            <a:off x="-770237" y="2461461"/>
+            <a:ext cx="6096000" cy="1446550"/>
           </a:xfrm>
           <a:prstGeom prst="rect">
             <a:avLst/>
@@ -4746,8 +5279,9 @@
           </a:bodyPr>
           <a:lstStyle/>
           <a:p>
-            <a:r>
-              <a:rPr lang="zh-CN" altLang="en-US" sz="3600" dirty="0">
+            <a:pPr algn="ctr"/>
+            <a:r>
+              <a:rPr lang="zh-CN" altLang="en-US" sz="8800" dirty="0">
                 <a:solidFill>
                   <a:schemeClr val="bg1"/>
                 </a:solidFill>
@@ -4756,75 +5290,26 @@
               </a:rPr>
               <a:t>报告目录</a:t>
             </a:r>
-          </a:p>
-        </p:txBody>
-      </p:sp>
-      <p:sp>
-        <p:nvSpPr>
-          <p:cNvPr id="31" name="直角三角形 30"/>
-          <p:cNvSpPr/>
-          <p:nvPr/>
-        </p:nvSpPr>
-        <p:spPr>
-          <a:xfrm rot="10800000">
-            <a:off x="-27021" y="1120093"/>
-            <a:ext cx="629302" cy="425719"/>
-          </a:xfrm>
-          <a:prstGeom prst="rtTriangle">
-            <a:avLst/>
-          </a:prstGeom>
-          <a:solidFill>
-            <a:schemeClr val="accent1">
-              <a:lumMod val="75000"/>
-              <a:alpha val="65000"/>
-            </a:schemeClr>
-          </a:solidFill>
-          <a:ln>
-            <a:noFill/>
-          </a:ln>
-          <a:effectLst>
-            <a:outerShdw blurRad="50800" dist="38100" dir="2700000" algn="tl" rotWithShape="0">
-              <a:prstClr val="black">
-                <a:alpha val="40000"/>
-              </a:prstClr>
-            </a:outerShdw>
-          </a:effectLst>
-        </p:spPr>
-        <p:style>
-          <a:lnRef idx="2">
-            <a:schemeClr val="accent1">
-              <a:shade val="15000"/>
-            </a:schemeClr>
-          </a:lnRef>
-          <a:fillRef idx="1">
-            <a:schemeClr val="accent1"/>
-          </a:fillRef>
-          <a:effectRef idx="0">
-            <a:schemeClr val="accent1"/>
-          </a:effectRef>
-          <a:fontRef idx="minor">
-            <a:schemeClr val="lt1"/>
-          </a:fontRef>
-        </p:style>
-        <p:txBody>
-          <a:bodyPr rtlCol="0" anchor="ctr"/>
-          <a:lstStyle/>
-          <a:p>
-            <a:pPr algn="ctr"/>
-            <a:endParaRPr lang="zh-CN" altLang="en-US"/>
-          </a:p>
-        </p:txBody>
-      </p:sp>
-      <p:sp>
-        <p:nvSpPr>
-          <p:cNvPr id="33" name="文本框 32"/>
+            <a:endParaRPr lang="zh-CN" altLang="en-US" sz="8800" dirty="0">
+              <a:solidFill>
+                <a:schemeClr val="bg1"/>
+              </a:solidFill>
+              <a:latin typeface="黑体" panose="02010609060101010101" pitchFamily="49" charset="-122"/>
+              <a:ea typeface="黑体" panose="02010609060101010101" pitchFamily="49" charset="-122"/>
+            </a:endParaRPr>
+          </a:p>
+        </p:txBody>
+      </p:sp>
+      <p:sp>
+        <p:nvSpPr>
+          <p:cNvPr id="30" name="文本框 29"/>
           <p:cNvSpPr txBox="1"/>
           <p:nvPr/>
         </p:nvSpPr>
         <p:spPr>
           <a:xfrm>
-            <a:off x="776057" y="1165950"/>
-            <a:ext cx="5544273" cy="398780"/>
+            <a:off x="1293599" y="3917903"/>
+            <a:ext cx="2046683" cy="461665"/>
           </a:xfrm>
           <a:prstGeom prst="rect">
             <a:avLst/>
@@ -4837,343 +5322,37 @@
           </a:bodyPr>
           <a:lstStyle/>
           <a:p>
-            <a:r>
-              <a:rPr lang="zh-CN" altLang="en-US" sz="2000" dirty="0">
+            <a:pPr algn="ctr"/>
+            <a:r>
+              <a:rPr lang="en-US" altLang="zh-CN" sz="2400" b="1" dirty="0">
                 <a:solidFill>
-                  <a:schemeClr val="tx1">
-                    <a:lumMod val="50000"/>
-                    <a:lumOff val="50000"/>
-                  </a:schemeClr>
+                  <a:schemeClr val="bg1"/>
                 </a:solidFill>
-                <a:latin typeface="黑体" panose="02010609060101010101" pitchFamily="49" charset="-122"/>
-                <a:ea typeface="黑体" panose="02010609060101010101" pitchFamily="49" charset="-122"/>
+                <a:latin typeface="+mj-ea"/>
+                <a:ea typeface="+mj-ea"/>
               </a:rPr>
-              <a:t>结论与待解决</a:t>
-            </a:r>
-          </a:p>
-        </p:txBody>
-      </p:sp>
-      <p:pic>
-        <p:nvPicPr>
-          <p:cNvPr id="37" name="图片 36"/>
-          <p:cNvPicPr>
-            <a:picLocks noChangeAspect="1"/>
-          </p:cNvPicPr>
-          <p:nvPr/>
-        </p:nvPicPr>
-        <p:blipFill>
-          <a:blip r:embed="rId4" cstate="print">
-            <a:extLst>
-              <a:ext uri="{28A0092B-C50C-407E-A947-70E740481C1C}">
-                <a14:useLocalDpi xmlns:a14="http://schemas.microsoft.com/office/drawing/2010/main" val="0"/>
-              </a:ext>
-            </a:extLst>
-          </a:blip>
-          <a:stretch>
-            <a:fillRect/>
-          </a:stretch>
-        </p:blipFill>
-        <p:spPr>
-          <a:xfrm>
-            <a:off x="6216145" y="309262"/>
-            <a:ext cx="891058" cy="1260416"/>
-          </a:xfrm>
-          <a:prstGeom prst="rect">
-            <a:avLst/>
-          </a:prstGeom>
-        </p:spPr>
-      </p:pic>
-      <p:pic>
-        <p:nvPicPr>
-          <p:cNvPr id="46" name="图片 45"/>
-          <p:cNvPicPr>
-            <a:picLocks noChangeAspect="1"/>
-          </p:cNvPicPr>
-          <p:nvPr/>
-        </p:nvPicPr>
-        <p:blipFill>
-          <a:blip r:embed="rId5" cstate="print">
-            <a:extLst>
-              <a:ext uri="{28A0092B-C50C-407E-A947-70E740481C1C}">
-                <a14:useLocalDpi xmlns:a14="http://schemas.microsoft.com/office/drawing/2010/main" val="0"/>
-              </a:ext>
-            </a:extLst>
-          </a:blip>
-          <a:stretch>
-            <a:fillRect/>
-          </a:stretch>
-        </p:blipFill>
-        <p:spPr>
-          <a:xfrm>
-            <a:off x="-188196" y="166310"/>
-            <a:ext cx="1057173" cy="1495387"/>
-          </a:xfrm>
-          <a:prstGeom prst="rect">
-            <a:avLst/>
-          </a:prstGeom>
-        </p:spPr>
-      </p:pic>
-      <p:pic>
-        <p:nvPicPr>
-          <p:cNvPr id="9" name="图片 8"/>
-          <p:cNvPicPr>
-            <a:picLocks noChangeAspect="1"/>
-          </p:cNvPicPr>
-          <p:nvPr/>
-        </p:nvPicPr>
-        <p:blipFill>
-          <a:blip r:embed="rId2" cstate="print">
-            <a:extLst>
-              <a:ext uri="{28A0092B-C50C-407E-A947-70E740481C1C}">
-                <a14:useLocalDpi xmlns:a14="http://schemas.microsoft.com/office/drawing/2010/main" val="0"/>
-              </a:ext>
-            </a:extLst>
-          </a:blip>
-          <a:stretch>
-            <a:fillRect/>
-          </a:stretch>
-        </p:blipFill>
-        <p:spPr>
-          <a:xfrm>
-            <a:off x="5002289" y="-86698"/>
-            <a:ext cx="1429499" cy="2022049"/>
-          </a:xfrm>
-          <a:prstGeom prst="rect">
-            <a:avLst/>
-          </a:prstGeom>
-        </p:spPr>
-      </p:pic>
-      <p:pic>
-        <p:nvPicPr>
-          <p:cNvPr id="10" name="图片 9"/>
-          <p:cNvPicPr>
-            <a:picLocks noChangeAspect="1"/>
-          </p:cNvPicPr>
-          <p:nvPr/>
-        </p:nvPicPr>
-        <p:blipFill>
-          <a:blip r:embed="rId3" cstate="print">
-            <a:extLst>
-              <a:ext uri="{28A0092B-C50C-407E-A947-70E740481C1C}">
-                <a14:useLocalDpi xmlns:a14="http://schemas.microsoft.com/office/drawing/2010/main" val="0"/>
-              </a:ext>
-            </a:extLst>
-          </a:blip>
-          <a:stretch>
-            <a:fillRect/>
-          </a:stretch>
-        </p:blipFill>
-        <p:spPr>
-          <a:xfrm>
-            <a:off x="4067567" y="-105552"/>
-            <a:ext cx="1218069" cy="2177058"/>
-          </a:xfrm>
-          <a:prstGeom prst="rect">
-            <a:avLst/>
-          </a:prstGeom>
-        </p:spPr>
-      </p:pic>
-      <p:cxnSp>
-        <p:nvCxnSpPr>
-          <p:cNvPr id="14" name="直接连接符 13"/>
-          <p:cNvCxnSpPr/>
-          <p:nvPr/>
-        </p:nvCxnSpPr>
-        <p:spPr>
-          <a:xfrm>
-            <a:off x="1170264" y="3118908"/>
-            <a:ext cx="9505950" cy="4445"/>
-          </a:xfrm>
-          <a:prstGeom prst="line">
-            <a:avLst/>
-          </a:prstGeom>
-          <a:ln w="9525">
-            <a:solidFill>
-              <a:schemeClr val="tx1">
-                <a:lumMod val="50000"/>
-                <a:lumOff val="50000"/>
-              </a:schemeClr>
-            </a:solidFill>
-            <a:prstDash val="dashDot"/>
-          </a:ln>
-        </p:spPr>
-        <p:style>
-          <a:lnRef idx="1">
-            <a:schemeClr val="accent1"/>
-          </a:lnRef>
-          <a:fillRef idx="0">
-            <a:schemeClr val="accent1"/>
-          </a:fillRef>
-          <a:effectRef idx="0">
-            <a:schemeClr val="accent1"/>
-          </a:effectRef>
-          <a:fontRef idx="minor">
-            <a:schemeClr val="tx1"/>
-          </a:fontRef>
-        </p:style>
-      </p:cxnSp>
-      <p:sp>
-        <p:nvSpPr>
-          <p:cNvPr id="18" name="椭圆 17"/>
-          <p:cNvSpPr/>
-          <p:nvPr/>
-        </p:nvSpPr>
-        <p:spPr>
-          <a:xfrm>
-            <a:off x="10676131" y="3076963"/>
-            <a:ext cx="101968" cy="101968"/>
-          </a:xfrm>
-          <a:prstGeom prst="ellipse">
-            <a:avLst/>
-          </a:prstGeom>
-          <a:solidFill>
-            <a:schemeClr val="tx1">
-              <a:lumMod val="50000"/>
-              <a:lumOff val="50000"/>
-            </a:schemeClr>
-          </a:solidFill>
-          <a:ln>
-            <a:noFill/>
-          </a:ln>
-        </p:spPr>
-        <p:style>
-          <a:lnRef idx="2">
-            <a:schemeClr val="accent1">
-              <a:shade val="15000"/>
-            </a:schemeClr>
-          </a:lnRef>
-          <a:fillRef idx="1">
-            <a:schemeClr val="accent1"/>
-          </a:fillRef>
-          <a:effectRef idx="0">
-            <a:schemeClr val="accent1"/>
-          </a:effectRef>
-          <a:fontRef idx="minor">
-            <a:schemeClr val="lt1"/>
-          </a:fontRef>
-        </p:style>
-        <p:txBody>
-          <a:bodyPr rtlCol="0" anchor="ctr"/>
-          <a:lstStyle/>
-          <a:p>
-            <a:pPr algn="ctr"/>
-            <a:endParaRPr lang="zh-CN" altLang="en-US"/>
-          </a:p>
-        </p:txBody>
-      </p:sp>
-      <p:sp>
-        <p:nvSpPr>
-          <p:cNvPr id="19" name="椭圆 18"/>
-          <p:cNvSpPr/>
-          <p:nvPr/>
-        </p:nvSpPr>
-        <p:spPr>
-          <a:xfrm>
-            <a:off x="1068296" y="3068574"/>
-            <a:ext cx="101968" cy="101968"/>
-          </a:xfrm>
-          <a:prstGeom prst="ellipse">
-            <a:avLst/>
-          </a:prstGeom>
-          <a:solidFill>
-            <a:schemeClr val="tx1">
-              <a:lumMod val="50000"/>
-              <a:lumOff val="50000"/>
-            </a:schemeClr>
-          </a:solidFill>
-          <a:ln>
-            <a:noFill/>
-          </a:ln>
-        </p:spPr>
-        <p:style>
-          <a:lnRef idx="2">
-            <a:schemeClr val="accent1">
-              <a:shade val="15000"/>
-            </a:schemeClr>
-          </a:lnRef>
-          <a:fillRef idx="1">
-            <a:schemeClr val="accent1"/>
-          </a:fillRef>
-          <a:effectRef idx="0">
-            <a:schemeClr val="accent1"/>
-          </a:effectRef>
-          <a:fontRef idx="minor">
-            <a:schemeClr val="lt1"/>
-          </a:fontRef>
-        </p:style>
-        <p:txBody>
-          <a:bodyPr rtlCol="0" anchor="ctr"/>
-          <a:lstStyle/>
-          <a:p>
-            <a:pPr algn="ctr"/>
-            <a:endParaRPr lang="zh-CN" altLang="en-US"/>
-          </a:p>
-        </p:txBody>
-      </p:sp>
-      <p:sp>
-        <p:nvSpPr>
-          <p:cNvPr id="20" name="箭头: V 形 19"/>
-          <p:cNvSpPr/>
-          <p:nvPr/>
-        </p:nvSpPr>
-        <p:spPr>
-          <a:xfrm rot="5400000">
-            <a:off x="907924" y="2298114"/>
-            <a:ext cx="357945" cy="604019"/>
-          </a:xfrm>
-          <a:prstGeom prst="chevron">
-            <a:avLst>
-              <a:gd name="adj" fmla="val 48413"/>
-            </a:avLst>
-          </a:prstGeom>
-          <a:solidFill>
-            <a:schemeClr val="accent1">
-              <a:lumMod val="50000"/>
-            </a:schemeClr>
-          </a:solidFill>
-          <a:ln>
-            <a:noFill/>
-          </a:ln>
-        </p:spPr>
-        <p:style>
-          <a:lnRef idx="2">
-            <a:schemeClr val="accent1">
-              <a:shade val="15000"/>
-            </a:schemeClr>
-          </a:lnRef>
-          <a:fillRef idx="1">
-            <a:schemeClr val="accent1"/>
-          </a:fillRef>
-          <a:effectRef idx="0">
-            <a:schemeClr val="accent1"/>
-          </a:effectRef>
-          <a:fontRef idx="minor">
-            <a:schemeClr val="lt1"/>
-          </a:fontRef>
-        </p:style>
-        <p:txBody>
-          <a:bodyPr rtlCol="0" anchor="ctr"/>
-          <a:lstStyle/>
-          <a:p>
-            <a:pPr algn="ctr"/>
-            <a:endParaRPr lang="zh-CN" altLang="en-US">
+              <a:t>CONTENTS</a:t>
+            </a:r>
+            <a:endParaRPr lang="zh-CN" altLang="en-US" sz="2400" b="1" dirty="0">
               <a:solidFill>
-                <a:schemeClr val="tx1"/>
+                <a:schemeClr val="bg1"/>
               </a:solidFill>
+              <a:latin typeface="+mj-ea"/>
+              <a:ea typeface="+mj-ea"/>
             </a:endParaRPr>
           </a:p>
         </p:txBody>
       </p:sp>
       <p:sp>
         <p:nvSpPr>
-          <p:cNvPr id="24" name="文本框 23"/>
+          <p:cNvPr id="6" name="文本框 5"/>
           <p:cNvSpPr txBox="1"/>
           <p:nvPr/>
         </p:nvSpPr>
         <p:spPr>
           <a:xfrm>
-            <a:off x="1429309" y="3512393"/>
-            <a:ext cx="4349262" cy="460375"/>
+            <a:off x="8313835" y="1454411"/>
+            <a:ext cx="3094694" cy="400110"/>
           </a:xfrm>
           <a:prstGeom prst="rect">
             <a:avLst/>
@@ -5187,213 +5366,23 @@
           <a:lstStyle/>
           <a:p>
             <a:r>
-              <a:rPr lang="zh-CN" altLang="en-US" sz="2400" dirty="0">
-                <a:solidFill>
-                  <a:schemeClr val="accent1">
-                    <a:lumMod val="50000"/>
-                  </a:schemeClr>
-                </a:solidFill>
-                <a:latin typeface="黑体" panose="02010609060101010101" pitchFamily="49" charset="-122"/>
-                <a:ea typeface="黑体" panose="02010609060101010101" pitchFamily="49" charset="-122"/>
-              </a:rPr>
-              <a:t>文献调研与改进思路</a:t>
-            </a:r>
-          </a:p>
-        </p:txBody>
-      </p:sp>
-      <p:sp>
-        <p:nvSpPr>
-          <p:cNvPr id="48" name="椭圆 47"/>
-          <p:cNvSpPr/>
-          <p:nvPr/>
-        </p:nvSpPr>
-        <p:spPr>
-          <a:xfrm>
-            <a:off x="10675496" y="4672792"/>
-            <a:ext cx="101968" cy="101968"/>
-          </a:xfrm>
-          <a:prstGeom prst="ellipse">
-            <a:avLst/>
-          </a:prstGeom>
-          <a:solidFill>
-            <a:schemeClr val="tx1">
-              <a:lumMod val="50000"/>
-              <a:lumOff val="50000"/>
-            </a:schemeClr>
-          </a:solidFill>
-          <a:ln>
-            <a:noFill/>
-          </a:ln>
-        </p:spPr>
-        <p:style>
-          <a:lnRef idx="2">
-            <a:schemeClr val="accent1">
-              <a:shade val="15000"/>
-            </a:schemeClr>
-          </a:lnRef>
-          <a:fillRef idx="1">
-            <a:schemeClr val="accent1"/>
-          </a:fillRef>
-          <a:effectRef idx="0">
-            <a:schemeClr val="accent1"/>
-          </a:effectRef>
-          <a:fontRef idx="minor">
-            <a:schemeClr val="lt1"/>
-          </a:fontRef>
-        </p:style>
-        <p:txBody>
-          <a:bodyPr rtlCol="0" anchor="ctr"/>
-          <a:lstStyle/>
-          <a:p>
-            <a:pPr algn="ctr"/>
-            <a:endParaRPr lang="zh-CN" altLang="en-US"/>
-          </a:p>
-        </p:txBody>
-      </p:sp>
-      <p:sp>
-        <p:nvSpPr>
-          <p:cNvPr id="49" name="椭圆 48"/>
-          <p:cNvSpPr/>
-          <p:nvPr/>
-        </p:nvSpPr>
-        <p:spPr>
-          <a:xfrm>
-            <a:off x="1068296" y="4672023"/>
-            <a:ext cx="101968" cy="101968"/>
-          </a:xfrm>
-          <a:prstGeom prst="ellipse">
-            <a:avLst/>
-          </a:prstGeom>
-          <a:solidFill>
-            <a:schemeClr val="tx1">
-              <a:lumMod val="50000"/>
-              <a:lumOff val="50000"/>
-            </a:schemeClr>
-          </a:solidFill>
-          <a:ln>
-            <a:noFill/>
-          </a:ln>
-        </p:spPr>
-        <p:style>
-          <a:lnRef idx="2">
-            <a:schemeClr val="accent1">
-              <a:shade val="15000"/>
-            </a:schemeClr>
-          </a:lnRef>
-          <a:fillRef idx="1">
-            <a:schemeClr val="accent1"/>
-          </a:fillRef>
-          <a:effectRef idx="0">
-            <a:schemeClr val="accent1"/>
-          </a:effectRef>
-          <a:fontRef idx="minor">
-            <a:schemeClr val="lt1"/>
-          </a:fontRef>
-        </p:style>
-        <p:txBody>
-          <a:bodyPr rtlCol="0" anchor="ctr"/>
-          <a:lstStyle/>
-          <a:p>
-            <a:pPr algn="ctr"/>
-            <a:endParaRPr lang="zh-CN" altLang="en-US"/>
-          </a:p>
-        </p:txBody>
-      </p:sp>
-      <p:sp>
-        <p:nvSpPr>
-          <p:cNvPr id="50" name="箭头: V 形 49"/>
-          <p:cNvSpPr/>
-          <p:nvPr/>
-        </p:nvSpPr>
-        <p:spPr>
-          <a:xfrm rot="5400000">
-            <a:off x="907924" y="3901563"/>
-            <a:ext cx="357945" cy="604019"/>
-          </a:xfrm>
-          <a:prstGeom prst="chevron">
-            <a:avLst>
-              <a:gd name="adj" fmla="val 48413"/>
-            </a:avLst>
-          </a:prstGeom>
-          <a:solidFill>
-            <a:schemeClr val="accent1">
-              <a:lumMod val="40000"/>
-              <a:lumOff val="60000"/>
-            </a:schemeClr>
-          </a:solidFill>
-          <a:ln>
-            <a:noFill/>
-          </a:ln>
-        </p:spPr>
-        <p:style>
-          <a:lnRef idx="2">
-            <a:schemeClr val="accent1">
-              <a:shade val="15000"/>
-            </a:schemeClr>
-          </a:lnRef>
-          <a:fillRef idx="1">
-            <a:schemeClr val="accent1"/>
-          </a:fillRef>
-          <a:effectRef idx="0">
-            <a:schemeClr val="accent1"/>
-          </a:effectRef>
-          <a:fontRef idx="minor">
-            <a:schemeClr val="lt1"/>
-          </a:fontRef>
-        </p:style>
-        <p:txBody>
-          <a:bodyPr rtlCol="0" anchor="ctr"/>
-          <a:lstStyle/>
-          <a:p>
-            <a:pPr algn="ctr"/>
-            <a:endParaRPr lang="zh-CN" altLang="en-US">
-              <a:solidFill>
-                <a:schemeClr val="tx1"/>
-              </a:solidFill>
-            </a:endParaRPr>
-          </a:p>
-        </p:txBody>
-      </p:sp>
-      <p:pic>
-        <p:nvPicPr>
-          <p:cNvPr id="5" name="图片 4"/>
-          <p:cNvPicPr>
-            <a:picLocks noChangeAspect="1"/>
-          </p:cNvPicPr>
-          <p:nvPr/>
-        </p:nvPicPr>
-        <p:blipFill>
-          <a:blip r:embed="rId6" cstate="print">
-            <a:extLst>
-              <a:ext uri="{28A0092B-C50C-407E-A947-70E740481C1C}">
-                <a14:useLocalDpi xmlns:a14="http://schemas.microsoft.com/office/drawing/2010/main" val="0"/>
-              </a:ext>
-            </a:extLst>
-          </a:blip>
-          <a:stretch>
-            <a:fillRect/>
-          </a:stretch>
-        </p:blipFill>
-        <p:spPr>
-          <a:xfrm>
-            <a:off x="8719478" y="-499744"/>
-            <a:ext cx="3460702" cy="2446851"/>
-          </a:xfrm>
-          <a:prstGeom prst="rect">
-            <a:avLst/>
-          </a:prstGeom>
-        </p:spPr>
-      </p:pic>
-      <p:sp>
-        <p:nvSpPr>
-          <p:cNvPr id="3" name="文本框 2"/>
+              <a:rPr lang="en-US" altLang="zh-CN" sz="2000" dirty="0"/>
+              <a:t>Outline</a:t>
+            </a:r>
+            <a:endParaRPr lang="zh-CN" altLang="en-US" sz="2000" dirty="0"/>
+          </a:p>
+        </p:txBody>
+      </p:sp>
+      <p:sp>
+        <p:nvSpPr>
+          <p:cNvPr id="8" name="文本框 7"/>
           <p:cNvSpPr txBox="1"/>
           <p:nvPr/>
         </p:nvSpPr>
         <p:spPr>
           <a:xfrm>
-            <a:off x="1578610" y="3873500"/>
-            <a:ext cx="9497695" cy="645160"/>
+            <a:off x="8372884" y="2874635"/>
+            <a:ext cx="3094694" cy="400110"/>
           </a:xfrm>
           <a:prstGeom prst="rect">
             <a:avLst/>
@@ -5407,24 +5396,23 @@
           <a:lstStyle/>
           <a:p>
             <a:r>
-              <a:rPr lang="zh-CN" altLang="en-US" dirty="0">
-                <a:sym typeface="+mn-ea"/>
-              </a:rPr>
-              <a:t>文献调研与改进思路</a:t>
-            </a:r>
-          </a:p>
-        </p:txBody>
-      </p:sp>
-      <p:sp>
-        <p:nvSpPr>
-          <p:cNvPr id="8" name="文本框 7"/>
+              <a:rPr lang="en-US" altLang="zh-CN" sz="2000" dirty="0"/>
+              <a:t>Outline</a:t>
+            </a:r>
+            <a:endParaRPr lang="zh-CN" altLang="en-US" sz="2000" dirty="0"/>
+          </a:p>
+        </p:txBody>
+      </p:sp>
+      <p:sp>
+        <p:nvSpPr>
+          <p:cNvPr id="9" name="文本框 8"/>
           <p:cNvSpPr txBox="1"/>
           <p:nvPr/>
         </p:nvSpPr>
         <p:spPr>
           <a:xfrm>
-            <a:off x="1429309" y="4988694"/>
-            <a:ext cx="4349262" cy="460375"/>
+            <a:off x="8460140" y="4487827"/>
+            <a:ext cx="3094694" cy="400110"/>
           </a:xfrm>
           <a:prstGeom prst="rect">
             <a:avLst/>
@@ -5438,30 +5426,23 @@
           <a:lstStyle/>
           <a:p>
             <a:r>
-              <a:rPr lang="zh-CN" altLang="en-US" sz="2400" dirty="0">
-                <a:solidFill>
-                  <a:schemeClr val="accent1">
-                    <a:lumMod val="50000"/>
-                  </a:schemeClr>
-                </a:solidFill>
-                <a:latin typeface="黑体" panose="02010609060101010101" pitchFamily="49" charset="-122"/>
-                <a:ea typeface="黑体" panose="02010609060101010101" pitchFamily="49" charset="-122"/>
-              </a:rPr>
-              <a:t>消融指标对比</a:t>
-            </a:r>
-          </a:p>
-        </p:txBody>
-      </p:sp>
-      <p:sp>
-        <p:nvSpPr>
-          <p:cNvPr id="11" name="文本框 10"/>
+              <a:rPr lang="en-US" altLang="zh-CN" sz="2000" dirty="0"/>
+              <a:t>Outline</a:t>
+            </a:r>
+            <a:endParaRPr lang="zh-CN" altLang="en-US" sz="2000" dirty="0"/>
+          </a:p>
+        </p:txBody>
+      </p:sp>
+      <p:sp>
+        <p:nvSpPr>
+          <p:cNvPr id="10" name="文本框 9"/>
           <p:cNvSpPr txBox="1"/>
           <p:nvPr/>
         </p:nvSpPr>
         <p:spPr>
           <a:xfrm>
-            <a:off x="1468755" y="5450205"/>
-            <a:ext cx="9497695" cy="368300"/>
+            <a:off x="8438732" y="6020516"/>
+            <a:ext cx="3094694" cy="400110"/>
           </a:xfrm>
           <a:prstGeom prst="rect">
             <a:avLst/>
@@ -5475,242 +5456,13 @@
           <a:lstStyle/>
           <a:p>
             <a:r>
-              <a:rPr lang="zh-CN" altLang="en-US" dirty="0"/>
-              <a:t>消融指标对比</a:t>
-            </a:r>
-          </a:p>
-        </p:txBody>
-      </p:sp>
-      <p:cxnSp>
-        <p:nvCxnSpPr>
-          <p:cNvPr id="12" name="直接连接符 11"/>
-          <p:cNvCxnSpPr/>
-          <p:nvPr/>
-        </p:nvCxnSpPr>
-        <p:spPr>
-          <a:xfrm>
-            <a:off x="1170264" y="6198658"/>
-            <a:ext cx="9505950" cy="4445"/>
-          </a:xfrm>
-          <a:prstGeom prst="line">
-            <a:avLst/>
-          </a:prstGeom>
-          <a:ln w="9525">
-            <a:solidFill>
-              <a:schemeClr val="tx1">
-                <a:lumMod val="50000"/>
-                <a:lumOff val="50000"/>
-              </a:schemeClr>
-            </a:solidFill>
-            <a:prstDash val="dashDot"/>
-          </a:ln>
-        </p:spPr>
-        <p:style>
-          <a:lnRef idx="1">
-            <a:schemeClr val="accent1"/>
-          </a:lnRef>
-          <a:fillRef idx="0">
-            <a:schemeClr val="accent1"/>
-          </a:fillRef>
-          <a:effectRef idx="0">
-            <a:schemeClr val="accent1"/>
-          </a:effectRef>
-          <a:fontRef idx="minor">
-            <a:schemeClr val="tx1"/>
-          </a:fontRef>
-        </p:style>
-      </p:cxnSp>
-      <p:sp>
-        <p:nvSpPr>
-          <p:cNvPr id="13" name="椭圆 12"/>
-          <p:cNvSpPr/>
-          <p:nvPr/>
-        </p:nvSpPr>
-        <p:spPr>
-          <a:xfrm>
-            <a:off x="10676131" y="6156713"/>
-            <a:ext cx="101968" cy="101968"/>
-          </a:xfrm>
-          <a:prstGeom prst="ellipse">
-            <a:avLst/>
-          </a:prstGeom>
-          <a:solidFill>
-            <a:schemeClr val="tx1">
-              <a:lumMod val="50000"/>
-              <a:lumOff val="50000"/>
-            </a:schemeClr>
-          </a:solidFill>
-          <a:ln>
-            <a:noFill/>
-          </a:ln>
-        </p:spPr>
-        <p:style>
-          <a:lnRef idx="2">
-            <a:schemeClr val="accent1">
-              <a:shade val="15000"/>
-            </a:schemeClr>
-          </a:lnRef>
-          <a:fillRef idx="1">
-            <a:schemeClr val="accent1"/>
-          </a:fillRef>
-          <a:effectRef idx="0">
-            <a:schemeClr val="accent1"/>
-          </a:effectRef>
-          <a:fontRef idx="minor">
-            <a:schemeClr val="lt1"/>
-          </a:fontRef>
-        </p:style>
-        <p:txBody>
-          <a:bodyPr rtlCol="0" anchor="ctr"/>
-          <a:lstStyle/>
-          <a:p>
-            <a:pPr algn="ctr"/>
-            <a:endParaRPr lang="zh-CN" altLang="en-US"/>
-          </a:p>
-        </p:txBody>
-      </p:sp>
-      <p:sp>
-        <p:nvSpPr>
-          <p:cNvPr id="15" name="椭圆 14"/>
-          <p:cNvSpPr/>
-          <p:nvPr/>
-        </p:nvSpPr>
-        <p:spPr>
-          <a:xfrm>
-            <a:off x="1068296" y="6148324"/>
-            <a:ext cx="101968" cy="101968"/>
-          </a:xfrm>
-          <a:prstGeom prst="ellipse">
-            <a:avLst/>
-          </a:prstGeom>
-          <a:solidFill>
-            <a:schemeClr val="tx1">
-              <a:lumMod val="50000"/>
-              <a:lumOff val="50000"/>
-            </a:schemeClr>
-          </a:solidFill>
-          <a:ln>
-            <a:noFill/>
-          </a:ln>
-        </p:spPr>
-        <p:style>
-          <a:lnRef idx="2">
-            <a:schemeClr val="accent1">
-              <a:shade val="15000"/>
-            </a:schemeClr>
-          </a:lnRef>
-          <a:fillRef idx="1">
-            <a:schemeClr val="accent1"/>
-          </a:fillRef>
-          <a:effectRef idx="0">
-            <a:schemeClr val="accent1"/>
-          </a:effectRef>
-          <a:fontRef idx="minor">
-            <a:schemeClr val="lt1"/>
-          </a:fontRef>
-        </p:style>
-        <p:txBody>
-          <a:bodyPr rtlCol="0" anchor="ctr"/>
-          <a:lstStyle/>
-          <a:p>
-            <a:pPr algn="ctr"/>
-            <a:endParaRPr lang="zh-CN" altLang="en-US"/>
-          </a:p>
-        </p:txBody>
-      </p:sp>
-      <p:sp>
-        <p:nvSpPr>
-          <p:cNvPr id="16" name="箭头: V 形 19"/>
-          <p:cNvSpPr/>
-          <p:nvPr/>
-        </p:nvSpPr>
-        <p:spPr>
-          <a:xfrm rot="5400000">
-            <a:off x="907924" y="5377864"/>
-            <a:ext cx="357945" cy="604019"/>
-          </a:xfrm>
-          <a:prstGeom prst="chevron">
-            <a:avLst>
-              <a:gd name="adj" fmla="val 48413"/>
-            </a:avLst>
-          </a:prstGeom>
-          <a:solidFill>
-            <a:schemeClr val="accent1">
-              <a:lumMod val="50000"/>
-            </a:schemeClr>
-          </a:solidFill>
-          <a:ln>
-            <a:noFill/>
-          </a:ln>
-        </p:spPr>
-        <p:style>
-          <a:lnRef idx="2">
-            <a:schemeClr val="accent1">
-              <a:shade val="15000"/>
-            </a:schemeClr>
-          </a:lnRef>
-          <a:fillRef idx="1">
-            <a:schemeClr val="accent1"/>
-          </a:fillRef>
-          <a:effectRef idx="0">
-            <a:schemeClr val="accent1"/>
-          </a:effectRef>
-          <a:fontRef idx="minor">
-            <a:schemeClr val="lt1"/>
-          </a:fontRef>
-        </p:style>
-        <p:txBody>
-          <a:bodyPr rtlCol="0" anchor="ctr"/>
-          <a:lstStyle/>
-          <a:p>
-            <a:pPr algn="ctr"/>
-            <a:endParaRPr lang="zh-CN" altLang="en-US">
-              <a:solidFill>
-                <a:schemeClr val="tx1"/>
-              </a:solidFill>
-            </a:endParaRPr>
-          </a:p>
-        </p:txBody>
-      </p:sp>
-      <p:cxnSp>
-        <p:nvCxnSpPr>
-          <p:cNvPr id="4" name="直接连接符 3"/>
-          <p:cNvCxnSpPr/>
-          <p:nvPr/>
-        </p:nvCxnSpPr>
-        <p:spPr>
-          <a:xfrm>
-            <a:off x="1169629" y="4733713"/>
-            <a:ext cx="9505950" cy="4445"/>
-          </a:xfrm>
-          <a:prstGeom prst="line">
-            <a:avLst/>
-          </a:prstGeom>
-          <a:ln w="9525">
-            <a:solidFill>
-              <a:schemeClr val="tx1">
-                <a:lumMod val="50000"/>
-                <a:lumOff val="50000"/>
-              </a:schemeClr>
-            </a:solidFill>
-            <a:prstDash val="dashDot"/>
-          </a:ln>
-        </p:spPr>
-        <p:style>
-          <a:lnRef idx="1">
-            <a:schemeClr val="accent1"/>
-          </a:lnRef>
-          <a:fillRef idx="0">
-            <a:schemeClr val="accent1"/>
-          </a:fillRef>
-          <a:effectRef idx="0">
-            <a:schemeClr val="accent1"/>
-          </a:effectRef>
-          <a:fontRef idx="minor">
-            <a:schemeClr val="tx1"/>
-          </a:fontRef>
-        </p:style>
-      </p:cxnSp>
+              <a:rPr lang="en-US" altLang="zh-CN" sz="2000" dirty="0"/>
+              <a:t>Outline</a:t>
+            </a:r>
+            <a:endParaRPr lang="zh-CN" altLang="en-US" sz="2000" dirty="0"/>
+          </a:p>
+        </p:txBody>
+      </p:sp>
     </p:spTree>
   </p:cSld>
   <p:clrMapOvr>
@@ -6249,7 +6001,7 @@
                 <a:latin typeface="黑体" panose="02010609060101010101" pitchFamily="49" charset="-122"/>
                 <a:ea typeface="黑体" panose="02010609060101010101" pitchFamily="49" charset="-122"/>
               </a:rPr>
-              <a:t>原始流程与实现</a:t>
+              <a:t>原始流程与问题</a:t>
             </a:r>
             <a:endParaRPr lang="zh-CN" altLang="en-US" sz="3200" dirty="0">
               <a:solidFill>
@@ -7135,7 +6887,7 @@
 </p:sld>
 </file>
 
-<file path=ppt/slides/slide8.xml><?xml version="1.0" encoding="utf-8"?>
+<file path=ppt/slides/slide5.xml><?xml version="1.0" encoding="utf-8"?>
 <p:sld xmlns:a="http://schemas.openxmlformats.org/drawingml/2006/main" xmlns:r="http://schemas.openxmlformats.org/officeDocument/2006/relationships" xmlns:p="http://schemas.openxmlformats.org/presentationml/2006/main">
   <p:cSld>
     <p:spTree>
@@ -7154,7 +6906,7 @@
       </p:grpSpPr>
       <p:pic>
         <p:nvPicPr>
-          <p:cNvPr id="3" name="图片 2"/>
+          <p:cNvPr id="32" name="图片 31"/>
           <p:cNvPicPr>
             <a:picLocks noChangeAspect="1"/>
           </p:cNvPicPr>
@@ -7162,7 +6914,7 @@
         </p:nvPicPr>
         <p:blipFill>
           <a:blip r:embed="rId1" cstate="print">
-            <a:alphaModFix amt="35000"/>
+            <a:alphaModFix amt="40000"/>
             <a:extLst>
               <a:ext uri="{28A0092B-C50C-407E-A947-70E740481C1C}">
                 <a14:useLocalDpi xmlns:a14="http://schemas.microsoft.com/office/drawing/2010/main" val="0"/>
@@ -7174,32 +6926,272 @@
           </a:stretch>
         </p:blipFill>
         <p:spPr>
-          <a:xfrm rot="-120000">
-            <a:off x="-1670205" y="368258"/>
-            <a:ext cx="6806817" cy="9628353"/>
+          <a:xfrm>
+            <a:off x="3919012" y="3329946"/>
+            <a:ext cx="3594059" cy="5083854"/>
           </a:xfrm>
           <a:prstGeom prst="rect">
             <a:avLst/>
           </a:prstGeom>
         </p:spPr>
       </p:pic>
-      <p:sp>
-        <p:nvSpPr>
-          <p:cNvPr id="4" name="椭圆 3"/>
+      <p:pic>
+        <p:nvPicPr>
+          <p:cNvPr id="30" name="图片 29"/>
+          <p:cNvPicPr>
+            <a:picLocks noChangeAspect="1"/>
+          </p:cNvPicPr>
+          <p:nvPr/>
+        </p:nvPicPr>
+        <p:blipFill>
+          <a:blip r:embed="rId2" cstate="print">
+            <a:alphaModFix amt="40000"/>
+            <a:extLst>
+              <a:ext uri="{28A0092B-C50C-407E-A947-70E740481C1C}">
+                <a14:useLocalDpi xmlns:a14="http://schemas.microsoft.com/office/drawing/2010/main" val="0"/>
+              </a:ext>
+            </a:extLst>
+          </a:blip>
+          <a:stretch>
+            <a:fillRect/>
+          </a:stretch>
+        </p:blipFill>
+        <p:spPr>
+          <a:xfrm>
+            <a:off x="-1559452" y="-1430341"/>
+            <a:ext cx="7773942" cy="10996367"/>
+          </a:xfrm>
+          <a:prstGeom prst="rect">
+            <a:avLst/>
+          </a:prstGeom>
+        </p:spPr>
+      </p:pic>
+      <p:cxnSp>
+        <p:nvCxnSpPr>
+          <p:cNvPr id="7" name="直接连接符 6"/>
+          <p:cNvCxnSpPr/>
+          <p:nvPr/>
+        </p:nvCxnSpPr>
+        <p:spPr>
+          <a:xfrm>
+            <a:off x="6096000" y="2101840"/>
+            <a:ext cx="0" cy="5462752"/>
+          </a:xfrm>
+          <a:prstGeom prst="line">
+            <a:avLst/>
+          </a:prstGeom>
+          <a:ln w="19050">
+            <a:solidFill>
+              <a:schemeClr val="accent1">
+                <a:lumMod val="50000"/>
+              </a:schemeClr>
+            </a:solidFill>
+          </a:ln>
+        </p:spPr>
+        <p:style>
+          <a:lnRef idx="1">
+            <a:schemeClr val="accent1"/>
+          </a:lnRef>
+          <a:fillRef idx="0">
+            <a:schemeClr val="accent1"/>
+          </a:fillRef>
+          <a:effectRef idx="0">
+            <a:schemeClr val="accent1"/>
+          </a:effectRef>
+          <a:fontRef idx="minor">
+            <a:schemeClr val="tx1"/>
+          </a:fontRef>
+        </p:style>
+      </p:cxnSp>
+      <p:sp>
+        <p:nvSpPr>
+          <p:cNvPr id="9" name="椭圆 8"/>
           <p:cNvSpPr/>
-          <p:nvPr>
-            <p:custDataLst>
-              <p:tags r:id="rId2"/>
-            </p:custDataLst>
-          </p:nvPr>
-        </p:nvSpPr>
-        <p:spPr>
-          <a:xfrm>
-            <a:off x="2015600" y="2617505"/>
-            <a:ext cx="586619" cy="586619"/>
+          <p:nvPr/>
+        </p:nvSpPr>
+        <p:spPr>
+          <a:xfrm>
+            <a:off x="5938345" y="3657372"/>
+            <a:ext cx="315310" cy="315310"/>
           </a:xfrm>
           <a:prstGeom prst="ellipse">
             <a:avLst/>
+          </a:prstGeom>
+          <a:solidFill>
+            <a:schemeClr val="accent1">
+              <a:lumMod val="50000"/>
+            </a:schemeClr>
+          </a:solidFill>
+          <a:ln>
+            <a:noFill/>
+          </a:ln>
+        </p:spPr>
+        <p:style>
+          <a:lnRef idx="2">
+            <a:schemeClr val="accent1">
+              <a:shade val="15000"/>
+            </a:schemeClr>
+          </a:lnRef>
+          <a:fillRef idx="1">
+            <a:schemeClr val="accent1"/>
+          </a:fillRef>
+          <a:effectRef idx="0">
+            <a:schemeClr val="accent1"/>
+          </a:effectRef>
+          <a:fontRef idx="minor">
+            <a:schemeClr val="lt1"/>
+          </a:fontRef>
+        </p:style>
+        <p:txBody>
+          <a:bodyPr rtlCol="0" anchor="ctr"/>
+          <a:lstStyle/>
+          <a:p>
+            <a:pPr algn="ctr"/>
+            <a:endParaRPr lang="zh-CN" altLang="en-US" dirty="0"/>
+          </a:p>
+        </p:txBody>
+      </p:sp>
+      <p:sp>
+        <p:nvSpPr>
+          <p:cNvPr id="10" name="椭圆 9"/>
+          <p:cNvSpPr/>
+          <p:nvPr/>
+        </p:nvSpPr>
+        <p:spPr>
+          <a:xfrm>
+            <a:off x="5938345" y="5212904"/>
+            <a:ext cx="315310" cy="315310"/>
+          </a:xfrm>
+          <a:prstGeom prst="ellipse">
+            <a:avLst/>
+          </a:prstGeom>
+          <a:solidFill>
+            <a:schemeClr val="accent1">
+              <a:lumMod val="50000"/>
+            </a:schemeClr>
+          </a:solidFill>
+          <a:ln>
+            <a:noFill/>
+          </a:ln>
+        </p:spPr>
+        <p:style>
+          <a:lnRef idx="2">
+            <a:schemeClr val="accent1">
+              <a:shade val="15000"/>
+            </a:schemeClr>
+          </a:lnRef>
+          <a:fillRef idx="1">
+            <a:schemeClr val="accent1"/>
+          </a:fillRef>
+          <a:effectRef idx="0">
+            <a:schemeClr val="accent1"/>
+          </a:effectRef>
+          <a:fontRef idx="minor">
+            <a:schemeClr val="lt1"/>
+          </a:fontRef>
+        </p:style>
+        <p:txBody>
+          <a:bodyPr rtlCol="0" anchor="ctr"/>
+          <a:lstStyle/>
+          <a:p>
+            <a:pPr algn="ctr"/>
+            <a:endParaRPr lang="zh-CN" altLang="en-US" dirty="0"/>
+          </a:p>
+        </p:txBody>
+      </p:sp>
+      <p:sp>
+        <p:nvSpPr>
+          <p:cNvPr id="13" name="矩形: 圆角 12"/>
+          <p:cNvSpPr/>
+          <p:nvPr/>
+        </p:nvSpPr>
+        <p:spPr>
+          <a:xfrm>
+            <a:off x="809299" y="3150248"/>
+            <a:ext cx="4666591" cy="1418896"/>
+          </a:xfrm>
+          <a:prstGeom prst="roundRect">
+            <a:avLst>
+              <a:gd name="adj" fmla="val 33704"/>
+            </a:avLst>
+          </a:prstGeom>
+          <a:solidFill>
+            <a:schemeClr val="accent1">
+              <a:lumMod val="50000"/>
+            </a:schemeClr>
+          </a:solidFill>
+          <a:ln>
+            <a:noFill/>
+          </a:ln>
+          <a:effectLst>
+            <a:outerShdw blurRad="50800" dist="38100" dir="2700000" algn="tl" rotWithShape="0">
+              <a:prstClr val="black">
+                <a:alpha val="40000"/>
+              </a:prstClr>
+            </a:outerShdw>
+          </a:effectLst>
+        </p:spPr>
+        <p:style>
+          <a:lnRef idx="2">
+            <a:schemeClr val="accent1">
+              <a:shade val="15000"/>
+            </a:schemeClr>
+          </a:lnRef>
+          <a:fillRef idx="1">
+            <a:schemeClr val="accent1"/>
+          </a:fillRef>
+          <a:effectRef idx="0">
+            <a:schemeClr val="accent1"/>
+          </a:effectRef>
+          <a:fontRef idx="minor">
+            <a:schemeClr val="lt1"/>
+          </a:fontRef>
+        </p:style>
+        <p:txBody>
+          <a:bodyPr rtlCol="0" anchor="ctr"/>
+          <a:lstStyle/>
+          <a:p>
+            <a:r>
+              <a:rPr lang="zh-CN" altLang="en-US" dirty="0">
+                <a:solidFill>
+                  <a:schemeClr val="bg1"/>
+                </a:solidFill>
+                <a:latin typeface="+mn-ea"/>
+              </a:rPr>
+              <a:t>基线方法：AGC+滑动平均；SNR 11.97 dB</a:t>
+            </a:r>
+            <a:endParaRPr lang="zh-CN" altLang="en-US" dirty="0">
+              <a:solidFill>
+                <a:schemeClr val="bg1"/>
+              </a:solidFill>
+              <a:latin typeface="+mn-ea"/>
+            </a:endParaRPr>
+          </a:p>
+          <a:p>
+            <a:endParaRPr lang="zh-CN" altLang="en-US" dirty="0">
+              <a:solidFill>
+                <a:schemeClr val="bg1"/>
+              </a:solidFill>
+              <a:latin typeface="+mn-ea"/>
+            </a:endParaRPr>
+          </a:p>
+        </p:txBody>
+      </p:sp>
+      <p:sp>
+        <p:nvSpPr>
+          <p:cNvPr id="14" name="矩形: 圆角 13"/>
+          <p:cNvSpPr/>
+          <p:nvPr/>
+        </p:nvSpPr>
+        <p:spPr>
+          <a:xfrm>
+            <a:off x="6716110" y="1731352"/>
+            <a:ext cx="4666591" cy="1418896"/>
+          </a:xfrm>
+          <a:prstGeom prst="roundRect">
+            <a:avLst>
+              <a:gd name="adj" fmla="val 33704"/>
+            </a:avLst>
           </a:prstGeom>
           <a:solidFill>
             <a:schemeClr val="accent1">
@@ -7238,81 +7230,34 @@
           <a:bodyPr rtlCol="0" anchor="ctr"/>
           <a:lstStyle/>
           <a:p>
-            <a:pPr algn="ctr"/>
+            <a:r>
+              <a:rPr lang="zh-CN" altLang="en-US" dirty="0">
+                <a:solidFill>
+                  <a:schemeClr val="tx1"/>
+                </a:solidFill>
+                <a:latin typeface="+mn-ea"/>
+              </a:rPr>
+              <a:t>改进A：SVD低秩；rank=1；SNR 11.64 dB；0.65s</a:t>
+            </a:r>
             <a:endParaRPr lang="zh-CN" altLang="en-US" dirty="0"/>
           </a:p>
         </p:txBody>
       </p:sp>
       <p:sp>
         <p:nvSpPr>
-          <p:cNvPr id="6" name="等腰三角形 5"/>
+          <p:cNvPr id="15" name="矩形: 圆角 14"/>
           <p:cNvSpPr/>
-          <p:nvPr>
-            <p:custDataLst>
-              <p:tags r:id="rId3"/>
-            </p:custDataLst>
-          </p:nvPr>
-        </p:nvSpPr>
-        <p:spPr>
-          <a:xfrm rot="16200000">
-            <a:off x="2055596" y="2692609"/>
-            <a:ext cx="1679864" cy="436414"/>
-          </a:xfrm>
-          <a:prstGeom prst="triangle">
-            <a:avLst/>
-          </a:prstGeom>
-          <a:solidFill>
-            <a:schemeClr val="accent1">
-              <a:lumMod val="40000"/>
-              <a:lumOff val="60000"/>
-            </a:schemeClr>
-          </a:solidFill>
-          <a:ln>
-            <a:noFill/>
-          </a:ln>
-        </p:spPr>
-        <p:style>
-          <a:lnRef idx="2">
-            <a:schemeClr val="accent1">
-              <a:shade val="15000"/>
-            </a:schemeClr>
-          </a:lnRef>
-          <a:fillRef idx="1">
-            <a:schemeClr val="accent1"/>
-          </a:fillRef>
-          <a:effectRef idx="0">
-            <a:schemeClr val="accent1"/>
-          </a:effectRef>
-          <a:fontRef idx="minor">
-            <a:schemeClr val="lt1"/>
-          </a:fontRef>
-        </p:style>
-        <p:txBody>
-          <a:bodyPr rtlCol="0" anchor="ctr"/>
-          <a:lstStyle/>
-          <a:p>
-            <a:pPr algn="ctr"/>
-            <a:endParaRPr lang="zh-CN" altLang="en-US"/>
-          </a:p>
-        </p:txBody>
-      </p:sp>
-      <p:sp>
-        <p:nvSpPr>
-          <p:cNvPr id="7" name="矩形 6"/>
-          <p:cNvSpPr/>
-          <p:nvPr>
-            <p:custDataLst>
-              <p:tags r:id="rId4"/>
-            </p:custDataLst>
-          </p:nvPr>
-        </p:nvSpPr>
-        <p:spPr>
-          <a:xfrm>
-            <a:off x="3113735" y="2070886"/>
-            <a:ext cx="3203862" cy="1679864"/>
-          </a:xfrm>
-          <a:prstGeom prst="rect">
-            <a:avLst/>
+          <p:nvPr/>
+        </p:nvSpPr>
+        <p:spPr>
+          <a:xfrm>
+            <a:off x="6716110" y="4833216"/>
+            <a:ext cx="4666591" cy="1418896"/>
+          </a:xfrm>
+          <a:prstGeom prst="roundRect">
+            <a:avLst>
+              <a:gd name="adj" fmla="val 33704"/>
+            </a:avLst>
           </a:prstGeom>
           <a:solidFill>
             <a:schemeClr val="accent1">
@@ -7351,27 +7296,79 @@
           <a:bodyPr rtlCol="0" anchor="ctr"/>
           <a:lstStyle/>
           <a:p>
+            <a:r>
+              <a:rPr lang="zh-CN" altLang="en-US" dirty="0">
+                <a:solidFill>
+                  <a:schemeClr val="tx1"/>
+                </a:solidFill>
+                <a:latin typeface="+mn-ea"/>
+              </a:rPr>
+              <a:t>改进B：AGC增益上限；window=301，cap=10；SNR 8.33 dB</a:t>
+            </a:r>
+            <a:endParaRPr lang="zh-CN" altLang="en-US" dirty="0"/>
+          </a:p>
+        </p:txBody>
+      </p:sp>
+      <p:sp>
+        <p:nvSpPr>
+          <p:cNvPr id="35" name="椭圆 34"/>
+          <p:cNvSpPr/>
+          <p:nvPr/>
+        </p:nvSpPr>
+        <p:spPr>
+          <a:xfrm>
+            <a:off x="5933091" y="2102286"/>
+            <a:ext cx="315310" cy="315310"/>
+          </a:xfrm>
+          <a:prstGeom prst="ellipse">
+            <a:avLst/>
+          </a:prstGeom>
+          <a:solidFill>
+            <a:schemeClr val="accent1">
+              <a:lumMod val="50000"/>
+            </a:schemeClr>
+          </a:solidFill>
+          <a:ln>
+            <a:noFill/>
+          </a:ln>
+        </p:spPr>
+        <p:style>
+          <a:lnRef idx="2">
+            <a:schemeClr val="accent1">
+              <a:shade val="15000"/>
+            </a:schemeClr>
+          </a:lnRef>
+          <a:fillRef idx="1">
+            <a:schemeClr val="accent1"/>
+          </a:fillRef>
+          <a:effectRef idx="0">
+            <a:schemeClr val="accent1"/>
+          </a:effectRef>
+          <a:fontRef idx="minor">
+            <a:schemeClr val="lt1"/>
+          </a:fontRef>
+        </p:style>
+        <p:txBody>
+          <a:bodyPr rtlCol="0" anchor="ctr"/>
+          <a:lstStyle/>
+          <a:p>
             <a:pPr algn="ctr"/>
-            <a:endParaRPr lang="zh-CN" altLang="en-US"/>
-          </a:p>
-        </p:txBody>
-      </p:sp>
-      <p:sp>
-        <p:nvSpPr>
-          <p:cNvPr id="8" name="椭圆 7"/>
+            <a:endParaRPr lang="zh-CN" altLang="en-US" dirty="0"/>
+          </a:p>
+        </p:txBody>
+      </p:sp>
+      <p:sp>
+        <p:nvSpPr>
+          <p:cNvPr id="42" name="箭头: 五边形 41"/>
           <p:cNvSpPr/>
-          <p:nvPr>
-            <p:custDataLst>
-              <p:tags r:id="rId5"/>
-            </p:custDataLst>
-          </p:nvPr>
-        </p:nvSpPr>
-        <p:spPr>
-          <a:xfrm>
-            <a:off x="7031106" y="2617503"/>
-            <a:ext cx="586619" cy="586619"/>
-          </a:xfrm>
-          <a:prstGeom prst="ellipse">
+          <p:nvPr/>
+        </p:nvSpPr>
+        <p:spPr>
+          <a:xfrm>
+            <a:off x="0" y="478074"/>
+            <a:ext cx="7266562" cy="642025"/>
+          </a:xfrm>
+          <a:prstGeom prst="homePlate">
             <a:avLst/>
           </a:prstGeom>
           <a:solidFill>
@@ -7411,83 +7408,29 @@
           <a:lstStyle/>
           <a:p>
             <a:pPr algn="ctr"/>
-            <a:endParaRPr lang="zh-CN" altLang="en-US" dirty="0"/>
-          </a:p>
-        </p:txBody>
-      </p:sp>
-      <p:sp>
-        <p:nvSpPr>
-          <p:cNvPr id="9" name="等腰三角形 8"/>
+            <a:endParaRPr lang="zh-CN" altLang="en-US"/>
+          </a:p>
+        </p:txBody>
+      </p:sp>
+      <p:sp>
+        <p:nvSpPr>
+          <p:cNvPr id="43" name="箭头: V 形 42"/>
           <p:cNvSpPr/>
-          <p:nvPr>
-            <p:custDataLst>
-              <p:tags r:id="rId6"/>
-            </p:custDataLst>
-          </p:nvPr>
-        </p:nvSpPr>
-        <p:spPr>
-          <a:xfrm rot="16200000">
-            <a:off x="7071102" y="2692607"/>
-            <a:ext cx="1679864" cy="436414"/>
-          </a:xfrm>
-          <a:prstGeom prst="triangle">
-            <a:avLst/>
+          <p:nvPr/>
+        </p:nvSpPr>
+        <p:spPr>
+          <a:xfrm>
+            <a:off x="7072641" y="478073"/>
+            <a:ext cx="523925" cy="642025"/>
+          </a:xfrm>
+          <a:prstGeom prst="chevron">
+            <a:avLst>
+              <a:gd name="adj" fmla="val 62487"/>
+            </a:avLst>
           </a:prstGeom>
           <a:solidFill>
             <a:schemeClr val="accent1">
-              <a:lumMod val="50000"/>
-            </a:schemeClr>
-          </a:solidFill>
-          <a:ln>
-            <a:noFill/>
-          </a:ln>
-        </p:spPr>
-        <p:style>
-          <a:lnRef idx="2">
-            <a:schemeClr val="accent1">
-              <a:shade val="15000"/>
-            </a:schemeClr>
-          </a:lnRef>
-          <a:fillRef idx="1">
-            <a:schemeClr val="accent1"/>
-          </a:fillRef>
-          <a:effectRef idx="0">
-            <a:schemeClr val="accent1"/>
-          </a:effectRef>
-          <a:fontRef idx="minor">
-            <a:schemeClr val="lt1"/>
-          </a:fontRef>
-        </p:style>
-        <p:txBody>
-          <a:bodyPr rtlCol="0" anchor="ctr"/>
-          <a:lstStyle/>
-          <a:p>
-            <a:pPr algn="ctr"/>
-            <a:endParaRPr lang="zh-CN" altLang="en-US"/>
-          </a:p>
-        </p:txBody>
-      </p:sp>
-      <p:sp>
-        <p:nvSpPr>
-          <p:cNvPr id="10" name="矩形 9"/>
-          <p:cNvSpPr/>
-          <p:nvPr>
-            <p:custDataLst>
-              <p:tags r:id="rId7"/>
-            </p:custDataLst>
-          </p:nvPr>
-        </p:nvSpPr>
-        <p:spPr>
-          <a:xfrm>
-            <a:off x="8129241" y="2070884"/>
-            <a:ext cx="3203862" cy="1679864"/>
-          </a:xfrm>
-          <a:prstGeom prst="rect">
-            <a:avLst/>
-          </a:prstGeom>
-          <a:solidFill>
-            <a:schemeClr val="accent1">
-              <a:lumMod val="50000"/>
+              <a:lumMod val="75000"/>
             </a:schemeClr>
           </a:solidFill>
           <a:ln>
@@ -7522,31 +7465,34 @@
           <a:lstStyle/>
           <a:p>
             <a:pPr algn="ctr"/>
-            <a:endParaRPr lang="zh-CN" altLang="en-US" dirty="0"/>
-          </a:p>
-        </p:txBody>
-      </p:sp>
-      <p:sp>
-        <p:nvSpPr>
-          <p:cNvPr id="11" name="椭圆 10"/>
+            <a:endParaRPr lang="zh-CN" altLang="en-US" dirty="0">
+              <a:solidFill>
+                <a:schemeClr val="tx1"/>
+              </a:solidFill>
+            </a:endParaRPr>
+          </a:p>
+        </p:txBody>
+      </p:sp>
+      <p:sp>
+        <p:nvSpPr>
+          <p:cNvPr id="44" name="箭头: V 形 43"/>
           <p:cNvSpPr/>
-          <p:nvPr>
-            <p:custDataLst>
-              <p:tags r:id="rId8"/>
-            </p:custDataLst>
-          </p:nvPr>
-        </p:nvSpPr>
-        <p:spPr>
-          <a:xfrm>
-            <a:off x="2015600" y="4884455"/>
-            <a:ext cx="586619" cy="586619"/>
-          </a:xfrm>
-          <a:prstGeom prst="ellipse">
-            <a:avLst/>
+          <p:nvPr/>
+        </p:nvSpPr>
+        <p:spPr>
+          <a:xfrm>
+            <a:off x="7424379" y="478073"/>
+            <a:ext cx="427941" cy="642025"/>
+          </a:xfrm>
+          <a:prstGeom prst="chevron">
+            <a:avLst>
+              <a:gd name="adj" fmla="val 76041"/>
+            </a:avLst>
           </a:prstGeom>
           <a:solidFill>
             <a:schemeClr val="accent1">
-              <a:lumMod val="50000"/>
+              <a:lumMod val="60000"/>
+              <a:lumOff val="40000"/>
             </a:schemeClr>
           </a:solidFill>
           <a:ln>
@@ -7581,138 +7527,29 @@
           <a:lstStyle/>
           <a:p>
             <a:pPr algn="ctr"/>
-            <a:endParaRPr lang="zh-CN" altLang="en-US" dirty="0"/>
-          </a:p>
-        </p:txBody>
-      </p:sp>
-      <p:sp>
-        <p:nvSpPr>
-          <p:cNvPr id="12" name="等腰三角形 11"/>
+            <a:endParaRPr lang="zh-CN" altLang="en-US" dirty="0">
+              <a:solidFill>
+                <a:schemeClr val="tx1"/>
+              </a:solidFill>
+            </a:endParaRPr>
+          </a:p>
+        </p:txBody>
+      </p:sp>
+      <p:sp>
+        <p:nvSpPr>
+          <p:cNvPr id="45" name="箭头: V 形 44"/>
           <p:cNvSpPr/>
-          <p:nvPr>
-            <p:custDataLst>
-              <p:tags r:id="rId9"/>
-            </p:custDataLst>
-          </p:nvPr>
-        </p:nvSpPr>
-        <p:spPr>
-          <a:xfrm rot="16200000">
-            <a:off x="2055596" y="4959559"/>
-            <a:ext cx="1679864" cy="436414"/>
-          </a:xfrm>
-          <a:prstGeom prst="triangle">
-            <a:avLst/>
-          </a:prstGeom>
-          <a:solidFill>
-            <a:schemeClr val="accent1">
-              <a:lumMod val="50000"/>
-            </a:schemeClr>
-          </a:solidFill>
-          <a:ln>
-            <a:noFill/>
-          </a:ln>
-        </p:spPr>
-        <p:style>
-          <a:lnRef idx="2">
-            <a:schemeClr val="accent1">
-              <a:shade val="15000"/>
-            </a:schemeClr>
-          </a:lnRef>
-          <a:fillRef idx="1">
-            <a:schemeClr val="accent1"/>
-          </a:fillRef>
-          <a:effectRef idx="0">
-            <a:schemeClr val="accent1"/>
-          </a:effectRef>
-          <a:fontRef idx="minor">
-            <a:schemeClr val="lt1"/>
-          </a:fontRef>
-        </p:style>
-        <p:txBody>
-          <a:bodyPr rtlCol="0" anchor="ctr"/>
-          <a:lstStyle/>
-          <a:p>
-            <a:pPr algn="ctr"/>
-            <a:endParaRPr lang="zh-CN" altLang="en-US"/>
-          </a:p>
-        </p:txBody>
-      </p:sp>
-      <p:sp>
-        <p:nvSpPr>
-          <p:cNvPr id="13" name="矩形 12"/>
-          <p:cNvSpPr/>
-          <p:nvPr>
-            <p:custDataLst>
-              <p:tags r:id="rId10"/>
-            </p:custDataLst>
-          </p:nvPr>
-        </p:nvSpPr>
-        <p:spPr>
-          <a:xfrm>
-            <a:off x="3113735" y="4337836"/>
-            <a:ext cx="3203862" cy="1679864"/>
-          </a:xfrm>
-          <a:prstGeom prst="rect">
-            <a:avLst/>
-          </a:prstGeom>
-          <a:solidFill>
-            <a:schemeClr val="accent1">
-              <a:lumMod val="50000"/>
-            </a:schemeClr>
-          </a:solidFill>
-          <a:ln>
-            <a:noFill/>
-          </a:ln>
-          <a:effectLst>
-            <a:outerShdw blurRad="50800" dist="38100" dir="2700000" algn="tl" rotWithShape="0">
-              <a:prstClr val="black">
-                <a:alpha val="40000"/>
-              </a:prstClr>
-            </a:outerShdw>
-          </a:effectLst>
-        </p:spPr>
-        <p:style>
-          <a:lnRef idx="2">
-            <a:schemeClr val="accent1">
-              <a:shade val="15000"/>
-            </a:schemeClr>
-          </a:lnRef>
-          <a:fillRef idx="1">
-            <a:schemeClr val="accent1"/>
-          </a:fillRef>
-          <a:effectRef idx="0">
-            <a:schemeClr val="accent1"/>
-          </a:effectRef>
-          <a:fontRef idx="minor">
-            <a:schemeClr val="lt1"/>
-          </a:fontRef>
-        </p:style>
-        <p:txBody>
-          <a:bodyPr rtlCol="0" anchor="ctr"/>
-          <a:lstStyle/>
-          <a:p>
-            <a:pPr algn="ctr"/>
-            <a:endParaRPr lang="zh-CN" altLang="en-US"/>
-          </a:p>
-        </p:txBody>
-      </p:sp>
-      <p:sp>
-        <p:nvSpPr>
-          <p:cNvPr id="14" name="椭圆 13"/>
-          <p:cNvSpPr/>
-          <p:nvPr>
-            <p:custDataLst>
-              <p:tags r:id="rId11"/>
-            </p:custDataLst>
-          </p:nvPr>
-        </p:nvSpPr>
-        <p:spPr>
-          <a:xfrm>
-            <a:off x="7031106" y="4884453"/>
-            <a:ext cx="586619" cy="586619"/>
-          </a:xfrm>
-          <a:prstGeom prst="ellipse">
-            <a:avLst/>
+          <p:nvPr/>
+        </p:nvSpPr>
+        <p:spPr>
+          <a:xfrm>
+            <a:off x="7755773" y="478073"/>
+            <a:ext cx="373468" cy="642025"/>
+          </a:xfrm>
+          <a:prstGeom prst="chevron">
+            <a:avLst>
+              <a:gd name="adj" fmla="val 85754"/>
+            </a:avLst>
           </a:prstGeom>
           <a:solidFill>
             <a:schemeClr val="accent1">
@@ -7752,553 +7589,24 @@
           <a:lstStyle/>
           <a:p>
             <a:pPr algn="ctr"/>
-            <a:endParaRPr lang="zh-CN" altLang="en-US" dirty="0"/>
-          </a:p>
-        </p:txBody>
-      </p:sp>
-      <p:sp>
-        <p:nvSpPr>
-          <p:cNvPr id="15" name="等腰三角形 14"/>
-          <p:cNvSpPr/>
-          <p:nvPr>
-            <p:custDataLst>
-              <p:tags r:id="rId12"/>
-            </p:custDataLst>
-          </p:nvPr>
-        </p:nvSpPr>
-        <p:spPr>
-          <a:xfrm rot="16200000">
-            <a:off x="7071102" y="4959557"/>
-            <a:ext cx="1679864" cy="436414"/>
-          </a:xfrm>
-          <a:prstGeom prst="triangle">
-            <a:avLst/>
-          </a:prstGeom>
-          <a:solidFill>
-            <a:schemeClr val="accent1">
-              <a:lumMod val="40000"/>
-              <a:lumOff val="60000"/>
-            </a:schemeClr>
-          </a:solidFill>
-          <a:ln>
-            <a:noFill/>
-          </a:ln>
-        </p:spPr>
-        <p:style>
-          <a:lnRef idx="2">
-            <a:schemeClr val="accent1">
-              <a:shade val="15000"/>
-            </a:schemeClr>
-          </a:lnRef>
-          <a:fillRef idx="1">
-            <a:schemeClr val="accent1"/>
-          </a:fillRef>
-          <a:effectRef idx="0">
-            <a:schemeClr val="accent1"/>
-          </a:effectRef>
-          <a:fontRef idx="minor">
-            <a:schemeClr val="lt1"/>
-          </a:fontRef>
-        </p:style>
-        <p:txBody>
-          <a:bodyPr rtlCol="0" anchor="ctr"/>
-          <a:lstStyle/>
-          <a:p>
-            <a:pPr algn="ctr"/>
-            <a:endParaRPr lang="zh-CN" altLang="en-US"/>
-          </a:p>
-        </p:txBody>
-      </p:sp>
-      <p:sp>
-        <p:nvSpPr>
-          <p:cNvPr id="16" name="矩形 15"/>
-          <p:cNvSpPr/>
-          <p:nvPr>
-            <p:custDataLst>
-              <p:tags r:id="rId13"/>
-            </p:custDataLst>
-          </p:nvPr>
-        </p:nvSpPr>
-        <p:spPr>
-          <a:xfrm>
-            <a:off x="8129241" y="4334024"/>
-            <a:ext cx="3203862" cy="1679864"/>
-          </a:xfrm>
-          <a:prstGeom prst="rect">
-            <a:avLst/>
-          </a:prstGeom>
-          <a:solidFill>
-            <a:schemeClr val="accent1">
-              <a:lumMod val="40000"/>
-              <a:lumOff val="60000"/>
-            </a:schemeClr>
-          </a:solidFill>
-          <a:ln>
-            <a:noFill/>
-          </a:ln>
-          <a:effectLst>
-            <a:outerShdw blurRad="50800" dist="38100" dir="2700000" algn="tl" rotWithShape="0">
-              <a:prstClr val="black">
-                <a:alpha val="40000"/>
-              </a:prstClr>
-            </a:outerShdw>
-          </a:effectLst>
-        </p:spPr>
-        <p:style>
-          <a:lnRef idx="2">
-            <a:schemeClr val="accent1">
-              <a:shade val="15000"/>
-            </a:schemeClr>
-          </a:lnRef>
-          <a:fillRef idx="1">
-            <a:schemeClr val="accent1"/>
-          </a:fillRef>
-          <a:effectRef idx="0">
-            <a:schemeClr val="accent1"/>
-          </a:effectRef>
-          <a:fontRef idx="minor">
-            <a:schemeClr val="lt1"/>
-          </a:fontRef>
-        </p:style>
-        <p:txBody>
-          <a:bodyPr rtlCol="0" anchor="ctr"/>
-          <a:lstStyle/>
-          <a:p>
-            <a:pPr algn="ctr"/>
-            <a:endParaRPr lang="zh-CN" altLang="en-US"/>
-          </a:p>
-        </p:txBody>
-      </p:sp>
-      <p:sp>
-        <p:nvSpPr>
-          <p:cNvPr id="21" name="文本框 20"/>
-          <p:cNvSpPr txBox="1"/>
-          <p:nvPr>
-            <p:custDataLst>
-              <p:tags r:id="rId14"/>
-            </p:custDataLst>
-          </p:nvPr>
-        </p:nvSpPr>
-        <p:spPr>
-          <a:xfrm>
-            <a:off x="3113735" y="2099233"/>
-            <a:ext cx="3203862" cy="461665"/>
-          </a:xfrm>
-          <a:prstGeom prst="rect">
-            <a:avLst/>
-          </a:prstGeom>
-          <a:noFill/>
-        </p:spPr>
-        <p:txBody>
-          <a:bodyPr wrap="square" rtlCol="0">
-            <a:spAutoFit/>
-          </a:bodyPr>
-          <a:lstStyle/>
-          <a:p>
-            <a:r>
-              <a:rPr lang="zh-CN" altLang="en-US" sz="2400" dirty="0">
-                <a:solidFill>
-                  <a:schemeClr val="tx1"/>
-                </a:solidFill>
-                <a:latin typeface="黑体" panose="02010609060101010101" pitchFamily="49" charset="-122"/>
-                <a:ea typeface="黑体" panose="02010609060101010101" pitchFamily="49" charset="-122"/>
-              </a:rPr>
-              <a:t>改进A：SVD低秩</a:t>
-            </a:r>
-            <a:endParaRPr lang="zh-CN" altLang="en-US" sz="2400" dirty="0">
-              <a:solidFill>
-                <a:schemeClr val="tx1"/>
-              </a:solidFill>
-              <a:latin typeface="黑体" panose="02010609060101010101" pitchFamily="49" charset="-122"/>
-              <a:ea typeface="黑体" panose="02010609060101010101" pitchFamily="49" charset="-122"/>
-            </a:endParaRPr>
-          </a:p>
-        </p:txBody>
-      </p:sp>
-      <p:sp>
-        <p:nvSpPr>
-          <p:cNvPr id="22" name="文本框 21"/>
-          <p:cNvSpPr txBox="1"/>
-          <p:nvPr>
-            <p:custDataLst>
-              <p:tags r:id="rId15"/>
-            </p:custDataLst>
-          </p:nvPr>
-        </p:nvSpPr>
-        <p:spPr>
-          <a:xfrm>
-            <a:off x="3113735" y="2617503"/>
-            <a:ext cx="3203862" cy="368300"/>
-          </a:xfrm>
-          <a:prstGeom prst="rect">
-            <a:avLst/>
-          </a:prstGeom>
-          <a:noFill/>
-        </p:spPr>
-        <p:txBody>
-          <a:bodyPr wrap="square" rtlCol="0">
-            <a:spAutoFit/>
-          </a:bodyPr>
-          <a:lstStyle/>
-          <a:p>
-            <a:r>
-              <a:rPr lang="zh-CN" altLang="en-US" dirty="0">
-                <a:solidFill>
-                  <a:schemeClr val="tx1"/>
-                </a:solidFill>
-                <a:latin typeface="+mn-ea"/>
-              </a:rPr>
-              <a:t>rank=1；SNR 11.64 dB；0.65s</a:t>
-            </a:r>
             <a:endParaRPr lang="zh-CN" altLang="en-US" dirty="0">
               <a:solidFill>
                 <a:schemeClr val="tx1"/>
               </a:solidFill>
-              <a:latin typeface="+mn-ea"/>
             </a:endParaRPr>
           </a:p>
         </p:txBody>
       </p:sp>
-      <p:pic>
-        <p:nvPicPr>
-          <p:cNvPr id="24" name="图形 23" descr="头上的大脑 纯色填充"/>
-          <p:cNvPicPr>
-            <a:picLocks noChangeAspect="1"/>
-          </p:cNvPicPr>
-          <p:nvPr>
-            <p:custDataLst>
-              <p:tags r:id="rId16"/>
-            </p:custDataLst>
-          </p:nvPr>
-        </p:nvPicPr>
-        <p:blipFill>
-          <a:blip r:embed="rId17">
-            <a:extLst>
-              <a:ext uri="{28A0092B-C50C-407E-A947-70E740481C1C}">
-                <a14:useLocalDpi xmlns:a14="http://schemas.microsoft.com/office/drawing/2010/main" val="0"/>
-              </a:ext>
-              <a:ext uri="{96DAC541-7B7A-43D3-8B79-37D633B846F1}">
-                <asvg:svgBlip xmlns:asvg="http://schemas.microsoft.com/office/drawing/2016/SVG/main" r:embed="rId18"/>
-              </a:ext>
-            </a:extLst>
-          </a:blip>
-          <a:stretch>
-            <a:fillRect/>
-          </a:stretch>
-        </p:blipFill>
-        <p:spPr>
-          <a:xfrm>
-            <a:off x="2062224" y="2666912"/>
-            <a:ext cx="491672" cy="491672"/>
-          </a:xfrm>
-          <a:prstGeom prst="rect">
-            <a:avLst/>
-          </a:prstGeom>
-        </p:spPr>
-      </p:pic>
-      <p:pic>
-        <p:nvPicPr>
-          <p:cNvPr id="26" name="图形 25" descr="拼图 纯色填充"/>
-          <p:cNvPicPr>
-            <a:picLocks noChangeAspect="1"/>
-          </p:cNvPicPr>
-          <p:nvPr>
-            <p:custDataLst>
-              <p:tags r:id="rId19"/>
-            </p:custDataLst>
-          </p:nvPr>
-        </p:nvPicPr>
-        <p:blipFill>
-          <a:blip r:embed="rId20">
-            <a:extLst>
-              <a:ext uri="{28A0092B-C50C-407E-A947-70E740481C1C}">
-                <a14:useLocalDpi xmlns:a14="http://schemas.microsoft.com/office/drawing/2010/main" val="0"/>
-              </a:ext>
-              <a:ext uri="{96DAC541-7B7A-43D3-8B79-37D633B846F1}">
-                <asvg:svgBlip xmlns:asvg="http://schemas.microsoft.com/office/drawing/2016/SVG/main" r:embed="rId21"/>
-              </a:ext>
-            </a:extLst>
-          </a:blip>
-          <a:stretch>
-            <a:fillRect/>
-          </a:stretch>
-        </p:blipFill>
-        <p:spPr>
-          <a:xfrm>
-            <a:off x="7058774" y="2640465"/>
-            <a:ext cx="540693" cy="540693"/>
-          </a:xfrm>
-          <a:prstGeom prst="rect">
-            <a:avLst/>
-          </a:prstGeom>
-        </p:spPr>
-      </p:pic>
-      <p:pic>
-        <p:nvPicPr>
-          <p:cNvPr id="28" name="图形 27" descr="灯泡和齿轮 纯色填充"/>
-          <p:cNvPicPr>
-            <a:picLocks noChangeAspect="1"/>
-          </p:cNvPicPr>
-          <p:nvPr>
-            <p:custDataLst>
-              <p:tags r:id="rId22"/>
-            </p:custDataLst>
-          </p:nvPr>
-        </p:nvPicPr>
-        <p:blipFill>
-          <a:blip r:embed="rId23">
-            <a:extLst>
-              <a:ext uri="{28A0092B-C50C-407E-A947-70E740481C1C}">
-                <a14:useLocalDpi xmlns:a14="http://schemas.microsoft.com/office/drawing/2010/main" val="0"/>
-              </a:ext>
-              <a:ext uri="{96DAC541-7B7A-43D3-8B79-37D633B846F1}">
-                <asvg:svgBlip xmlns:asvg="http://schemas.microsoft.com/office/drawing/2016/SVG/main" r:embed="rId24"/>
-              </a:ext>
-            </a:extLst>
-          </a:blip>
-          <a:stretch>
-            <a:fillRect/>
-          </a:stretch>
-        </p:blipFill>
-        <p:spPr>
-          <a:xfrm>
-            <a:off x="2062060" y="4931844"/>
-            <a:ext cx="491836" cy="491836"/>
-          </a:xfrm>
-          <a:prstGeom prst="rect">
-            <a:avLst/>
-          </a:prstGeom>
-        </p:spPr>
-      </p:pic>
-      <p:pic>
-        <p:nvPicPr>
-          <p:cNvPr id="30" name="图形 29" descr="社交网络 纯色填充"/>
-          <p:cNvPicPr>
-            <a:picLocks noChangeAspect="1"/>
-          </p:cNvPicPr>
-          <p:nvPr>
-            <p:custDataLst>
-              <p:tags r:id="rId25"/>
-            </p:custDataLst>
-          </p:nvPr>
-        </p:nvPicPr>
-        <p:blipFill>
-          <a:blip r:embed="rId26">
-            <a:extLst>
-              <a:ext uri="{28A0092B-C50C-407E-A947-70E740481C1C}">
-                <a14:useLocalDpi xmlns:a14="http://schemas.microsoft.com/office/drawing/2010/main" val="0"/>
-              </a:ext>
-              <a:ext uri="{96DAC541-7B7A-43D3-8B79-37D633B846F1}">
-                <asvg:svgBlip xmlns:asvg="http://schemas.microsoft.com/office/drawing/2016/SVG/main" r:embed="rId27"/>
-              </a:ext>
-            </a:extLst>
-          </a:blip>
-          <a:stretch>
-            <a:fillRect/>
-          </a:stretch>
-        </p:blipFill>
-        <p:spPr>
-          <a:xfrm>
-            <a:off x="7072630" y="4920173"/>
-            <a:ext cx="515178" cy="515178"/>
-          </a:xfrm>
-          <a:prstGeom prst="rect">
-            <a:avLst/>
-          </a:prstGeom>
-        </p:spPr>
-      </p:pic>
-      <p:sp>
-        <p:nvSpPr>
-          <p:cNvPr id="32" name="文本框 31"/>
+      <p:sp>
+        <p:nvSpPr>
+          <p:cNvPr id="46" name="文本框 45"/>
           <p:cNvSpPr txBox="1"/>
-          <p:nvPr>
-            <p:custDataLst>
-              <p:tags r:id="rId28"/>
-            </p:custDataLst>
-          </p:nvPr>
-        </p:nvSpPr>
-        <p:spPr>
-          <a:xfrm>
-            <a:off x="8129241" y="2070879"/>
-            <a:ext cx="3267771" cy="461665"/>
-          </a:xfrm>
-          <a:prstGeom prst="rect">
-            <a:avLst/>
-          </a:prstGeom>
-          <a:noFill/>
-        </p:spPr>
-        <p:txBody>
-          <a:bodyPr wrap="square">
-            <a:spAutoFit/>
-          </a:bodyPr>
-          <a:lstStyle/>
-          <a:p>
-            <a:r>
-              <a:rPr lang="zh-CN" altLang="en-US" sz="2400" dirty="0">
-                <a:solidFill>
-                  <a:schemeClr val="bg1"/>
-                </a:solidFill>
-                <a:latin typeface="黑体" panose="02010609060101010101" pitchFamily="49" charset="-122"/>
-                <a:ea typeface="黑体" panose="02010609060101010101" pitchFamily="49" charset="-122"/>
-              </a:rPr>
-              <a:t>改进B：AGC增益上限</a:t>
-            </a:r>
-            <a:endParaRPr lang="zh-CN" altLang="en-US" sz="2400" dirty="0">
-              <a:solidFill>
-                <a:schemeClr val="bg1"/>
-              </a:solidFill>
-              <a:latin typeface="黑体" panose="02010609060101010101" pitchFamily="49" charset="-122"/>
-              <a:ea typeface="黑体" panose="02010609060101010101" pitchFamily="49" charset="-122"/>
-            </a:endParaRPr>
-          </a:p>
-        </p:txBody>
-      </p:sp>
-      <p:sp>
-        <p:nvSpPr>
-          <p:cNvPr id="34" name="文本框 33"/>
-          <p:cNvSpPr txBox="1"/>
-          <p:nvPr>
-            <p:custDataLst>
-              <p:tags r:id="rId29"/>
-            </p:custDataLst>
-          </p:nvPr>
-        </p:nvSpPr>
-        <p:spPr>
-          <a:xfrm>
-            <a:off x="8130980" y="2617503"/>
-            <a:ext cx="3202123" cy="368300"/>
-          </a:xfrm>
-          <a:prstGeom prst="rect">
-            <a:avLst/>
-          </a:prstGeom>
-          <a:noFill/>
-        </p:spPr>
-        <p:txBody>
-          <a:bodyPr wrap="square">
-            <a:spAutoFit/>
-          </a:bodyPr>
-          <a:lstStyle/>
-          <a:p>
-            <a:r>
-              <a:rPr lang="zh-CN" altLang="en-US" dirty="0">
-                <a:solidFill>
-                  <a:schemeClr val="bg1"/>
-                </a:solidFill>
-                <a:latin typeface="+mn-ea"/>
-              </a:rPr>
-              <a:t>window=301，cap=10；SNR 8.33 dB</a:t>
-            </a:r>
-            <a:endParaRPr lang="zh-CN" altLang="en-US" dirty="0">
-              <a:solidFill>
-                <a:schemeClr val="bg1"/>
-              </a:solidFill>
-              <a:latin typeface="+mn-ea"/>
-            </a:endParaRPr>
-          </a:p>
-        </p:txBody>
-      </p:sp>
-      <p:sp>
-        <p:nvSpPr>
-          <p:cNvPr id="36" name="文本框 35"/>
-          <p:cNvSpPr txBox="1"/>
-          <p:nvPr>
-            <p:custDataLst>
-              <p:tags r:id="rId30"/>
-            </p:custDataLst>
-          </p:nvPr>
-        </p:nvSpPr>
-        <p:spPr>
-          <a:xfrm>
-            <a:off x="3072420" y="4884453"/>
-            <a:ext cx="3203862" cy="368300"/>
-          </a:xfrm>
-          <a:prstGeom prst="rect">
-            <a:avLst/>
-          </a:prstGeom>
-          <a:noFill/>
-        </p:spPr>
-        <p:txBody>
-          <a:bodyPr wrap="square">
-            <a:spAutoFit/>
-          </a:bodyPr>
-          <a:lstStyle/>
-          <a:p>
-            <a:r>
-              <a:rPr lang="zh-CN" altLang="en-US" dirty="0">
-                <a:solidFill>
-                  <a:schemeClr val="bg1"/>
-                </a:solidFill>
-                <a:latin typeface="+mn-ea"/>
-              </a:rPr>
-              <a:t>AGC+滑动平均；SNR 11.97 dB</a:t>
-            </a:r>
-            <a:endParaRPr lang="zh-CN" altLang="en-US" dirty="0">
-              <a:solidFill>
-                <a:schemeClr val="bg1"/>
-              </a:solidFill>
-              <a:latin typeface="+mn-ea"/>
-            </a:endParaRPr>
-          </a:p>
-        </p:txBody>
-      </p:sp>
-      <p:sp>
-        <p:nvSpPr>
-          <p:cNvPr id="38" name="文本框 37"/>
-          <p:cNvSpPr txBox="1"/>
-          <p:nvPr>
-            <p:custDataLst>
-              <p:tags r:id="rId31"/>
-            </p:custDataLst>
-          </p:nvPr>
-        </p:nvSpPr>
-        <p:spPr>
-          <a:xfrm>
-            <a:off x="8129241" y="4900757"/>
-            <a:ext cx="3203862" cy="368300"/>
-          </a:xfrm>
-          <a:prstGeom prst="rect">
-            <a:avLst/>
-          </a:prstGeom>
-          <a:noFill/>
-        </p:spPr>
-        <p:txBody>
-          <a:bodyPr wrap="square">
-            <a:spAutoFit/>
-          </a:bodyPr>
-          <a:lstStyle/>
-          <a:p>
-            <a:r>
-              <a:rPr lang="zh-CN" altLang="en-US" dirty="0">
-                <a:solidFill>
-                  <a:schemeClr val="tx1"/>
-                </a:solidFill>
-                <a:latin typeface="+mn-ea"/>
-              </a:rPr>
-              <a:t>SVD接近基线且更快；AGC需调参</a:t>
-            </a:r>
-            <a:endParaRPr lang="zh-CN" altLang="en-US" dirty="0">
-              <a:solidFill>
-                <a:schemeClr val="tx1"/>
-              </a:solidFill>
-              <a:latin typeface="+mn-ea"/>
-            </a:endParaRPr>
-          </a:p>
-        </p:txBody>
-      </p:sp>
-      <p:sp>
-        <p:nvSpPr>
-          <p:cNvPr id="39" name="文本框 38"/>
-          <p:cNvSpPr txBox="1"/>
-          <p:nvPr>
-            <p:custDataLst>
-              <p:tags r:id="rId32"/>
-            </p:custDataLst>
-          </p:nvPr>
-        </p:nvSpPr>
-        <p:spPr>
-          <a:xfrm>
-            <a:off x="3113735" y="4334278"/>
-            <a:ext cx="3203862" cy="461665"/>
+          <p:nvPr/>
+        </p:nvSpPr>
+        <p:spPr>
+          <a:xfrm>
+            <a:off x="752997" y="461745"/>
+            <a:ext cx="5393803" cy="646331"/>
           </a:xfrm>
           <a:prstGeom prst="rect">
             <a:avLst/>
@@ -8312,95 +7620,7 @@
           <a:lstStyle/>
           <a:p>
             <a:r>
-              <a:rPr lang="zh-CN" altLang="en-US" sz="2400" dirty="0">
-                <a:solidFill>
-                  <a:schemeClr val="bg1"/>
-                </a:solidFill>
-                <a:latin typeface="黑体" panose="02010609060101010101" pitchFamily="49" charset="-122"/>
-                <a:ea typeface="黑体" panose="02010609060101010101" pitchFamily="49" charset="-122"/>
-              </a:rPr>
-              <a:t>基线方法</a:t>
-            </a:r>
-            <a:endParaRPr lang="zh-CN" altLang="en-US" sz="2400" dirty="0">
-              <a:solidFill>
-                <a:schemeClr val="bg1"/>
-              </a:solidFill>
-              <a:latin typeface="黑体" panose="02010609060101010101" pitchFamily="49" charset="-122"/>
-              <a:ea typeface="黑体" panose="02010609060101010101" pitchFamily="49" charset="-122"/>
-            </a:endParaRPr>
-          </a:p>
-        </p:txBody>
-      </p:sp>
-      <p:sp>
-        <p:nvSpPr>
-          <p:cNvPr id="40" name="文本框 39"/>
-          <p:cNvSpPr txBox="1"/>
-          <p:nvPr>
-            <p:custDataLst>
-              <p:tags r:id="rId33"/>
-            </p:custDataLst>
-          </p:nvPr>
-        </p:nvSpPr>
-        <p:spPr>
-          <a:xfrm>
-            <a:off x="8129241" y="4337829"/>
-            <a:ext cx="3203862" cy="461665"/>
-          </a:xfrm>
-          <a:prstGeom prst="rect">
-            <a:avLst/>
-          </a:prstGeom>
-          <a:noFill/>
-        </p:spPr>
-        <p:txBody>
-          <a:bodyPr wrap="square" rtlCol="0">
-            <a:spAutoFit/>
-          </a:bodyPr>
-          <a:lstStyle/>
-          <a:p>
-            <a:r>
-              <a:rPr lang="zh-CN" altLang="en-US" sz="2400" dirty="0">
-                <a:solidFill>
-                  <a:schemeClr val="tx1"/>
-                </a:solidFill>
-                <a:latin typeface="黑体" panose="02010609060101010101" pitchFamily="49" charset="-122"/>
-                <a:ea typeface="黑体" panose="02010609060101010101" pitchFamily="49" charset="-122"/>
-              </a:rPr>
-              <a:t>结论</a:t>
-            </a:r>
-            <a:endParaRPr lang="zh-CN" altLang="en-US" sz="2400" dirty="0">
-              <a:solidFill>
-                <a:schemeClr val="tx1"/>
-              </a:solidFill>
-              <a:latin typeface="黑体" panose="02010609060101010101" pitchFamily="49" charset="-122"/>
-              <a:ea typeface="黑体" panose="02010609060101010101" pitchFamily="49" charset="-122"/>
-            </a:endParaRPr>
-          </a:p>
-        </p:txBody>
-      </p:sp>
-      <p:sp>
-        <p:nvSpPr>
-          <p:cNvPr id="5" name="文本框 4"/>
-          <p:cNvSpPr txBox="1"/>
-          <p:nvPr/>
-        </p:nvSpPr>
-        <p:spPr>
-          <a:xfrm>
-            <a:off x="1290320" y="1459847"/>
-            <a:ext cx="5628640" cy="584775"/>
-          </a:xfrm>
-          <a:prstGeom prst="rect">
-            <a:avLst/>
-          </a:prstGeom>
-          <a:noFill/>
-        </p:spPr>
-        <p:txBody>
-          <a:bodyPr wrap="square" rtlCol="0">
-            <a:spAutoFit/>
-          </a:bodyPr>
-          <a:lstStyle/>
-          <a:p>
-            <a:r>
-              <a:rPr lang="zh-CN" altLang="en-US" sz="3200" dirty="0">
+              <a:rPr lang="zh-CN" altLang="en-US" sz="3600" dirty="0">
                 <a:solidFill>
                   <a:schemeClr val="bg1"/>
                 </a:solidFill>
@@ -8409,364 +7629,6 @@
               </a:rPr>
               <a:t>改进方法与结果</a:t>
             </a:r>
-            <a:endParaRPr lang="zh-CN" altLang="en-US" sz="3200" dirty="0">
-              <a:solidFill>
-                <a:schemeClr val="bg1"/>
-              </a:solidFill>
-              <a:latin typeface="黑体" panose="02010609060101010101" pitchFamily="49" charset="-122"/>
-              <a:ea typeface="黑体" panose="02010609060101010101" pitchFamily="49" charset="-122"/>
-            </a:endParaRPr>
-          </a:p>
-        </p:txBody>
-      </p:sp>
-      <p:sp>
-        <p:nvSpPr>
-          <p:cNvPr id="17" name="矩形 16"/>
-          <p:cNvSpPr/>
-          <p:nvPr/>
-        </p:nvSpPr>
-        <p:spPr>
-          <a:xfrm>
-            <a:off x="1229360" y="1013506"/>
-            <a:ext cx="81280" cy="1168400"/>
-          </a:xfrm>
-          <a:prstGeom prst="rect">
-            <a:avLst/>
-          </a:prstGeom>
-          <a:solidFill>
-            <a:schemeClr val="bg1"/>
-          </a:solidFill>
-          <a:ln>
-            <a:noFill/>
-          </a:ln>
-        </p:spPr>
-        <p:style>
-          <a:lnRef idx="2">
-            <a:schemeClr val="accent1">
-              <a:shade val="15000"/>
-            </a:schemeClr>
-          </a:lnRef>
-          <a:fillRef idx="1">
-            <a:schemeClr val="accent1"/>
-          </a:fillRef>
-          <a:effectRef idx="0">
-            <a:schemeClr val="accent1"/>
-          </a:effectRef>
-          <a:fontRef idx="minor">
-            <a:schemeClr val="lt1"/>
-          </a:fontRef>
-        </p:style>
-        <p:txBody>
-          <a:bodyPr rtlCol="0" anchor="ctr"/>
-          <a:lstStyle/>
-          <a:p>
-            <a:pPr algn="ctr"/>
-            <a:endParaRPr lang="zh-CN" altLang="en-US"/>
-          </a:p>
-        </p:txBody>
-      </p:sp>
-      <p:pic>
-        <p:nvPicPr>
-          <p:cNvPr id="37" name="图片 36"/>
-          <p:cNvPicPr>
-            <a:picLocks noChangeAspect="1"/>
-          </p:cNvPicPr>
-          <p:nvPr/>
-        </p:nvPicPr>
-        <p:blipFill>
-          <a:blip r:embed="rId34" cstate="print">
-            <a:extLst>
-              <a:ext uri="{28A0092B-C50C-407E-A947-70E740481C1C}">
-                <a14:useLocalDpi xmlns:a14="http://schemas.microsoft.com/office/drawing/2010/main" val="0"/>
-              </a:ext>
-            </a:extLst>
-          </a:blip>
-          <a:stretch>
-            <a:fillRect/>
-          </a:stretch>
-        </p:blipFill>
-        <p:spPr>
-          <a:xfrm>
-            <a:off x="4074579" y="-101986"/>
-            <a:ext cx="1218069" cy="2177058"/>
-          </a:xfrm>
-          <a:prstGeom prst="rect">
-            <a:avLst/>
-          </a:prstGeom>
-        </p:spPr>
-      </p:pic>
-      <p:sp>
-        <p:nvSpPr>
-          <p:cNvPr id="47" name="箭头: 五边形 46"/>
-          <p:cNvSpPr/>
-          <p:nvPr/>
-        </p:nvSpPr>
-        <p:spPr>
-          <a:xfrm>
-            <a:off x="0" y="478074"/>
-            <a:ext cx="7266562" cy="642025"/>
-          </a:xfrm>
-          <a:prstGeom prst="homePlate">
-            <a:avLst/>
-          </a:prstGeom>
-          <a:solidFill>
-            <a:schemeClr val="accent1">
-              <a:lumMod val="50000"/>
-            </a:schemeClr>
-          </a:solidFill>
-          <a:ln>
-            <a:noFill/>
-          </a:ln>
-          <a:effectLst>
-            <a:outerShdw blurRad="50800" dist="38100" dir="2700000" algn="tl" rotWithShape="0">
-              <a:prstClr val="black">
-                <a:alpha val="40000"/>
-              </a:prstClr>
-            </a:outerShdw>
-          </a:effectLst>
-        </p:spPr>
-        <p:style>
-          <a:lnRef idx="2">
-            <a:schemeClr val="accent1">
-              <a:shade val="15000"/>
-            </a:schemeClr>
-          </a:lnRef>
-          <a:fillRef idx="1">
-            <a:schemeClr val="accent1"/>
-          </a:fillRef>
-          <a:effectRef idx="0">
-            <a:schemeClr val="accent1"/>
-          </a:effectRef>
-          <a:fontRef idx="minor">
-            <a:schemeClr val="lt1"/>
-          </a:fontRef>
-        </p:style>
-        <p:txBody>
-          <a:bodyPr rtlCol="0" anchor="ctr"/>
-          <a:lstStyle/>
-          <a:p>
-            <a:pPr algn="ctr"/>
-            <a:endParaRPr lang="zh-CN" altLang="en-US"/>
-          </a:p>
-        </p:txBody>
-      </p:sp>
-      <p:sp>
-        <p:nvSpPr>
-          <p:cNvPr id="48" name="箭头: V 形 47"/>
-          <p:cNvSpPr/>
-          <p:nvPr/>
-        </p:nvSpPr>
-        <p:spPr>
-          <a:xfrm>
-            <a:off x="7072641" y="478073"/>
-            <a:ext cx="523925" cy="642025"/>
-          </a:xfrm>
-          <a:prstGeom prst="chevron">
-            <a:avLst>
-              <a:gd name="adj" fmla="val 62487"/>
-            </a:avLst>
-          </a:prstGeom>
-          <a:solidFill>
-            <a:schemeClr val="accent1">
-              <a:lumMod val="75000"/>
-            </a:schemeClr>
-          </a:solidFill>
-          <a:ln>
-            <a:noFill/>
-          </a:ln>
-          <a:effectLst>
-            <a:outerShdw blurRad="50800" dist="38100" dir="2700000" algn="tl" rotWithShape="0">
-              <a:prstClr val="black">
-                <a:alpha val="40000"/>
-              </a:prstClr>
-            </a:outerShdw>
-          </a:effectLst>
-        </p:spPr>
-        <p:style>
-          <a:lnRef idx="2">
-            <a:schemeClr val="accent1">
-              <a:shade val="15000"/>
-            </a:schemeClr>
-          </a:lnRef>
-          <a:fillRef idx="1">
-            <a:schemeClr val="accent1"/>
-          </a:fillRef>
-          <a:effectRef idx="0">
-            <a:schemeClr val="accent1"/>
-          </a:effectRef>
-          <a:fontRef idx="minor">
-            <a:schemeClr val="lt1"/>
-          </a:fontRef>
-        </p:style>
-        <p:txBody>
-          <a:bodyPr rtlCol="0" anchor="ctr"/>
-          <a:lstStyle/>
-          <a:p>
-            <a:pPr algn="ctr"/>
-            <a:endParaRPr lang="zh-CN" altLang="en-US" dirty="0">
-              <a:solidFill>
-                <a:schemeClr val="tx1"/>
-              </a:solidFill>
-            </a:endParaRPr>
-          </a:p>
-        </p:txBody>
-      </p:sp>
-      <p:sp>
-        <p:nvSpPr>
-          <p:cNvPr id="49" name="箭头: V 形 48"/>
-          <p:cNvSpPr/>
-          <p:nvPr/>
-        </p:nvSpPr>
-        <p:spPr>
-          <a:xfrm>
-            <a:off x="7424379" y="478073"/>
-            <a:ext cx="427941" cy="642025"/>
-          </a:xfrm>
-          <a:prstGeom prst="chevron">
-            <a:avLst>
-              <a:gd name="adj" fmla="val 76041"/>
-            </a:avLst>
-          </a:prstGeom>
-          <a:solidFill>
-            <a:schemeClr val="accent1">
-              <a:lumMod val="60000"/>
-              <a:lumOff val="40000"/>
-            </a:schemeClr>
-          </a:solidFill>
-          <a:ln>
-            <a:noFill/>
-          </a:ln>
-          <a:effectLst>
-            <a:outerShdw blurRad="50800" dist="38100" dir="2700000" algn="tl" rotWithShape="0">
-              <a:prstClr val="black">
-                <a:alpha val="40000"/>
-              </a:prstClr>
-            </a:outerShdw>
-          </a:effectLst>
-        </p:spPr>
-        <p:style>
-          <a:lnRef idx="2">
-            <a:schemeClr val="accent1">
-              <a:shade val="15000"/>
-            </a:schemeClr>
-          </a:lnRef>
-          <a:fillRef idx="1">
-            <a:schemeClr val="accent1"/>
-          </a:fillRef>
-          <a:effectRef idx="0">
-            <a:schemeClr val="accent1"/>
-          </a:effectRef>
-          <a:fontRef idx="minor">
-            <a:schemeClr val="lt1"/>
-          </a:fontRef>
-        </p:style>
-        <p:txBody>
-          <a:bodyPr rtlCol="0" anchor="ctr"/>
-          <a:lstStyle/>
-          <a:p>
-            <a:pPr algn="ctr"/>
-            <a:endParaRPr lang="zh-CN" altLang="en-US" dirty="0">
-              <a:solidFill>
-                <a:schemeClr val="tx1"/>
-              </a:solidFill>
-            </a:endParaRPr>
-          </a:p>
-        </p:txBody>
-      </p:sp>
-      <p:sp>
-        <p:nvSpPr>
-          <p:cNvPr id="50" name="箭头: V 形 49"/>
-          <p:cNvSpPr/>
-          <p:nvPr/>
-        </p:nvSpPr>
-        <p:spPr>
-          <a:xfrm>
-            <a:off x="7755773" y="478073"/>
-            <a:ext cx="373468" cy="642025"/>
-          </a:xfrm>
-          <a:prstGeom prst="chevron">
-            <a:avLst>
-              <a:gd name="adj" fmla="val 85754"/>
-            </a:avLst>
-          </a:prstGeom>
-          <a:solidFill>
-            <a:schemeClr val="accent1">
-              <a:lumMod val="40000"/>
-              <a:lumOff val="60000"/>
-            </a:schemeClr>
-          </a:solidFill>
-          <a:ln>
-            <a:noFill/>
-          </a:ln>
-          <a:effectLst>
-            <a:outerShdw blurRad="50800" dist="38100" dir="2700000" algn="tl" rotWithShape="0">
-              <a:prstClr val="black">
-                <a:alpha val="40000"/>
-              </a:prstClr>
-            </a:outerShdw>
-          </a:effectLst>
-        </p:spPr>
-        <p:style>
-          <a:lnRef idx="2">
-            <a:schemeClr val="accent1">
-              <a:shade val="15000"/>
-            </a:schemeClr>
-          </a:lnRef>
-          <a:fillRef idx="1">
-            <a:schemeClr val="accent1"/>
-          </a:fillRef>
-          <a:effectRef idx="0">
-            <a:schemeClr val="accent1"/>
-          </a:effectRef>
-          <a:fontRef idx="minor">
-            <a:schemeClr val="lt1"/>
-          </a:fontRef>
-        </p:style>
-        <p:txBody>
-          <a:bodyPr rtlCol="0" anchor="ctr"/>
-          <a:lstStyle/>
-          <a:p>
-            <a:pPr algn="ctr"/>
-            <a:endParaRPr lang="zh-CN" altLang="en-US" dirty="0">
-              <a:solidFill>
-                <a:schemeClr val="tx1"/>
-              </a:solidFill>
-            </a:endParaRPr>
-          </a:p>
-        </p:txBody>
-      </p:sp>
-      <p:sp>
-        <p:nvSpPr>
-          <p:cNvPr id="51" name="文本框 50"/>
-          <p:cNvSpPr txBox="1"/>
-          <p:nvPr/>
-        </p:nvSpPr>
-        <p:spPr>
-          <a:xfrm>
-            <a:off x="752997" y="461745"/>
-            <a:ext cx="5393803" cy="646331"/>
-          </a:xfrm>
-          <a:prstGeom prst="rect">
-            <a:avLst/>
-          </a:prstGeom>
-          <a:noFill/>
-        </p:spPr>
-        <p:txBody>
-          <a:bodyPr wrap="square" rtlCol="0">
-            <a:spAutoFit/>
-          </a:bodyPr>
-          <a:lstStyle/>
-          <a:p>
-            <a:r>
-              <a:rPr lang="zh-CN" altLang="en-US" sz="3600" dirty="0">
-                <a:solidFill>
-                  <a:schemeClr val="bg1"/>
-                </a:solidFill>
-                <a:latin typeface="黑体" panose="02010609060101010101" pitchFamily="49" charset="-122"/>
-                <a:ea typeface="黑体" panose="02010609060101010101" pitchFamily="49" charset="-122"/>
-              </a:rPr>
-              <a:t>性能对比结论</a:t>
-            </a:r>
             <a:endParaRPr lang="zh-CN" altLang="en-US" sz="3600" dirty="0">
               <a:solidFill>
                 <a:schemeClr val="bg1"/>
@@ -8779,7 +7641,7 @@
       </p:sp>
       <p:sp>
         <p:nvSpPr>
-          <p:cNvPr id="52" name="直角三角形 51"/>
+          <p:cNvPr id="47" name="直角三角形 46"/>
           <p:cNvSpPr/>
           <p:nvPr/>
         </p:nvSpPr>
@@ -8835,7 +7697,7 @@
       </p:sp>
       <p:sp>
         <p:nvSpPr>
-          <p:cNvPr id="53" name="文本框 52"/>
+          <p:cNvPr id="48" name="文本框 47"/>
           <p:cNvSpPr txBox="1"/>
           <p:nvPr/>
         </p:nvSpPr>
@@ -8866,7 +7728,7 @@
                 <a:latin typeface="黑体" panose="02010609060101010101" pitchFamily="49" charset="-122"/>
                 <a:ea typeface="黑体" panose="02010609060101010101" pitchFamily="49" charset="-122"/>
               </a:rPr>
-              <a:t>SVD接近基线且更快；AGC需调参</a:t>
+              <a:t>结论：SVD接近基线且更快；AGC需调参</a:t>
             </a:r>
             <a:endParaRPr lang="zh-CN" altLang="en-US" sz="2000" dirty="0">
               <a:solidFill>
@@ -8883,14 +7745,14 @@
       </p:sp>
       <p:pic>
         <p:nvPicPr>
-          <p:cNvPr id="54" name="图片 53"/>
+          <p:cNvPr id="49" name="图片 48"/>
           <p:cNvPicPr>
             <a:picLocks noChangeAspect="1"/>
           </p:cNvPicPr>
           <p:nvPr/>
         </p:nvPicPr>
         <p:blipFill>
-          <a:blip r:embed="rId35" cstate="print">
+          <a:blip r:embed="rId3" cstate="print">
             <a:extLst>
               <a:ext uri="{28A0092B-C50C-407E-A947-70E740481C1C}">
                 <a14:useLocalDpi xmlns:a14="http://schemas.microsoft.com/office/drawing/2010/main" val="0"/>
@@ -8903,7 +7765,7 @@
         </p:blipFill>
         <p:spPr>
           <a:xfrm>
-            <a:off x="6216145" y="309262"/>
+            <a:off x="6216145" y="390907"/>
             <a:ext cx="891058" cy="1260416"/>
           </a:xfrm>
           <a:prstGeom prst="rect">
@@ -8913,14 +7775,14 @@
       </p:pic>
       <p:pic>
         <p:nvPicPr>
-          <p:cNvPr id="55" name="图片 54"/>
+          <p:cNvPr id="50" name="图片 49"/>
           <p:cNvPicPr>
             <a:picLocks noChangeAspect="1"/>
           </p:cNvPicPr>
           <p:nvPr/>
         </p:nvPicPr>
         <p:blipFill>
-          <a:blip r:embed="rId36" cstate="print">
+          <a:blip r:embed="rId4" cstate="print">
             <a:extLst>
               <a:ext uri="{28A0092B-C50C-407E-A947-70E740481C1C}">
                 <a14:useLocalDpi xmlns:a14="http://schemas.microsoft.com/office/drawing/2010/main" val="0"/>
@@ -8943,14 +7805,14 @@
       </p:pic>
       <p:pic>
         <p:nvPicPr>
-          <p:cNvPr id="18" name="图片 17"/>
+          <p:cNvPr id="4" name="图片 3"/>
           <p:cNvPicPr>
             <a:picLocks noChangeAspect="1"/>
           </p:cNvPicPr>
           <p:nvPr/>
         </p:nvPicPr>
         <p:blipFill>
-          <a:blip r:embed="rId37" cstate="print">
+          <a:blip r:embed="rId5" cstate="print">
             <a:extLst>
               <a:ext uri="{28A0092B-C50C-407E-A947-70E740481C1C}">
                 <a14:useLocalDpi xmlns:a14="http://schemas.microsoft.com/office/drawing/2010/main" val="0"/>
@@ -8963,7 +7825,7 @@
         </p:blipFill>
         <p:spPr>
           <a:xfrm>
-            <a:off x="5015058" y="-94640"/>
+            <a:off x="5009301" y="-83132"/>
             <a:ext cx="1429499" cy="2022049"/>
           </a:xfrm>
           <a:prstGeom prst="rect">
@@ -8973,14 +7835,14 @@
       </p:pic>
       <p:pic>
         <p:nvPicPr>
-          <p:cNvPr id="19" name="图片 18"/>
+          <p:cNvPr id="5" name="图片 4"/>
           <p:cNvPicPr>
             <a:picLocks noChangeAspect="1"/>
           </p:cNvPicPr>
           <p:nvPr/>
         </p:nvPicPr>
         <p:blipFill>
-          <a:blip r:embed="rId34" cstate="print">
+          <a:blip r:embed="rId6" cstate="print">
             <a:extLst>
               <a:ext uri="{28A0092B-C50C-407E-A947-70E740481C1C}">
                 <a14:useLocalDpi xmlns:a14="http://schemas.microsoft.com/office/drawing/2010/main" val="0"/>
@@ -8993,7 +7855,7 @@
         </p:blipFill>
         <p:spPr>
           <a:xfrm>
-            <a:off x="4080336" y="-104868"/>
+            <a:off x="4074579" y="-101986"/>
             <a:ext cx="1218069" cy="2177058"/>
           </a:xfrm>
           <a:prstGeom prst="rect">
@@ -9010,7 +7872,7 @@
           <p:nvPr/>
         </p:nvPicPr>
         <p:blipFill>
-          <a:blip r:embed="rId38" cstate="print">
+          <a:blip r:embed="rId7" cstate="print">
             <a:extLst>
               <a:ext uri="{28A0092B-C50C-407E-A947-70E740481C1C}">
                 <a14:useLocalDpi xmlns:a14="http://schemas.microsoft.com/office/drawing/2010/main" val="0"/>
@@ -9039,154 +7901,10 @@
 </p:sld>
 </file>
 
-<file path=ppt/tags/tag1.xml><?xml version="1.0" encoding="utf-8"?>
-<p:tagLst xmlns:p="http://schemas.openxmlformats.org/presentationml/2006/main">
-  <p:tag name="KSO_WM_DIAGRAM_VIRTUALLY_FRAME" val="{&quot;height&quot;:326.1533070866142,&quot;left&quot;:100.62377952755905,&quot;top&quot;:147.68133858267714,&quot;width&quot;:796.7787401574802}"/>
-</p:tagLst>
-</file>
-
-<file path=ppt/tags/tag10.xml><?xml version="1.0" encoding="utf-8"?>
-<p:tagLst xmlns:p="http://schemas.openxmlformats.org/presentationml/2006/main">
-  <p:tag name="KSO_WM_DIAGRAM_VIRTUALLY_FRAME" val="{&quot;height&quot;:326.1533070866142,&quot;left&quot;:100.62377952755905,&quot;top&quot;:147.68133858267714,&quot;width&quot;:796.7787401574802}"/>
-</p:tagLst>
-</file>
-
-<file path=ppt/tags/tag11.xml><?xml version="1.0" encoding="utf-8"?>
-<p:tagLst xmlns:p="http://schemas.openxmlformats.org/presentationml/2006/main">
-  <p:tag name="KSO_WM_DIAGRAM_VIRTUALLY_FRAME" val="{&quot;height&quot;:326.1533070866142,&quot;left&quot;:100.62377952755905,&quot;top&quot;:147.68133858267714,&quot;width&quot;:796.7787401574802}"/>
-</p:tagLst>
-</file>
-
-<file path=ppt/tags/tag12.xml><?xml version="1.0" encoding="utf-8"?>
-<p:tagLst xmlns:p="http://schemas.openxmlformats.org/presentationml/2006/main">
-  <p:tag name="KSO_WM_DIAGRAM_VIRTUALLY_FRAME" val="{&quot;height&quot;:326.1533070866142,&quot;left&quot;:100.62377952755905,&quot;top&quot;:147.68133858267714,&quot;width&quot;:796.7787401574802}"/>
-</p:tagLst>
-</file>
-
-<file path=ppt/tags/tag13.xml><?xml version="1.0" encoding="utf-8"?>
-<p:tagLst xmlns:p="http://schemas.openxmlformats.org/presentationml/2006/main">
-  <p:tag name="KSO_WM_DIAGRAM_VIRTUALLY_FRAME" val="{&quot;height&quot;:326.1533070866142,&quot;left&quot;:100.62377952755905,&quot;top&quot;:147.68133858267714,&quot;width&quot;:796.7787401574802}"/>
-</p:tagLst>
-</file>
-
-<file path=ppt/tags/tag14.xml><?xml version="1.0" encoding="utf-8"?>
-<p:tagLst xmlns:p="http://schemas.openxmlformats.org/presentationml/2006/main">
-  <p:tag name="KSO_WM_DIAGRAM_VIRTUALLY_FRAME" val="{&quot;height&quot;:326.1533070866142,&quot;left&quot;:100.62377952755905,&quot;top&quot;:147.68133858267714,&quot;width&quot;:796.7787401574802}"/>
-</p:tagLst>
-</file>
-
-<file path=ppt/tags/tag15.xml><?xml version="1.0" encoding="utf-8"?>
-<p:tagLst xmlns:p="http://schemas.openxmlformats.org/presentationml/2006/main">
-  <p:tag name="KSO_WM_DIAGRAM_VIRTUALLY_FRAME" val="{&quot;height&quot;:326.1533070866142,&quot;left&quot;:100.62377952755905,&quot;top&quot;:147.68133858267714,&quot;width&quot;:796.7787401574802}"/>
-</p:tagLst>
-</file>
-
-<file path=ppt/tags/tag16.xml><?xml version="1.0" encoding="utf-8"?>
-<p:tagLst xmlns:p="http://schemas.openxmlformats.org/presentationml/2006/main">
-  <p:tag name="KSO_WM_DIAGRAM_VIRTUALLY_FRAME" val="{&quot;height&quot;:326.1533070866142,&quot;left&quot;:100.62377952755905,&quot;top&quot;:147.68133858267714,&quot;width&quot;:796.7787401574802}"/>
-</p:tagLst>
-</file>
-
-<file path=ppt/tags/tag17.xml><?xml version="1.0" encoding="utf-8"?>
-<p:tagLst xmlns:p="http://schemas.openxmlformats.org/presentationml/2006/main">
-  <p:tag name="KSO_WM_DIAGRAM_VIRTUALLY_FRAME" val="{&quot;height&quot;:326.1533070866142,&quot;left&quot;:100.62377952755905,&quot;top&quot;:147.68133858267714,&quot;width&quot;:796.7787401574802}"/>
-</p:tagLst>
-</file>
-
-<file path=ppt/tags/tag18.xml><?xml version="1.0" encoding="utf-8"?>
-<p:tagLst xmlns:p="http://schemas.openxmlformats.org/presentationml/2006/main">
-  <p:tag name="KSO_WM_DIAGRAM_VIRTUALLY_FRAME" val="{&quot;height&quot;:326.1533070866142,&quot;left&quot;:100.62377952755905,&quot;top&quot;:147.68133858267714,&quot;width&quot;:796.7787401574802}"/>
-</p:tagLst>
-</file>
-
-<file path=ppt/tags/tag19.xml><?xml version="1.0" encoding="utf-8"?>
-<p:tagLst xmlns:p="http://schemas.openxmlformats.org/presentationml/2006/main">
-  <p:tag name="KSO_WM_DIAGRAM_VIRTUALLY_FRAME" val="{&quot;height&quot;:326.1533070866142,&quot;left&quot;:100.62377952755905,&quot;top&quot;:147.68133858267714,&quot;width&quot;:796.7787401574802}"/>
-</p:tagLst>
-</file>
-
-<file path=ppt/tags/tag2.xml><?xml version="1.0" encoding="utf-8"?>
-<p:tagLst xmlns:p="http://schemas.openxmlformats.org/presentationml/2006/main">
-  <p:tag name="KSO_WM_DIAGRAM_VIRTUALLY_FRAME" val="{&quot;height&quot;:326.1533070866142,&quot;left&quot;:100.62377952755905,&quot;top&quot;:147.68133858267714,&quot;width&quot;:796.7787401574802}"/>
-</p:tagLst>
-</file>
-
-<file path=ppt/tags/tag20.xml><?xml version="1.0" encoding="utf-8"?>
-<p:tagLst xmlns:p="http://schemas.openxmlformats.org/presentationml/2006/main">
-  <p:tag name="KSO_WM_DIAGRAM_VIRTUALLY_FRAME" val="{&quot;height&quot;:326.1533070866142,&quot;left&quot;:100.62377952755905,&quot;top&quot;:147.68133858267714,&quot;width&quot;:796.7787401574802}"/>
-</p:tagLst>
-</file>
-
-<file path=ppt/tags/tag21.xml><?xml version="1.0" encoding="utf-8"?>
-<p:tagLst xmlns:p="http://schemas.openxmlformats.org/presentationml/2006/main">
-  <p:tag name="KSO_WM_DIAGRAM_VIRTUALLY_FRAME" val="{&quot;height&quot;:326.1533070866142,&quot;left&quot;:100.62377952755905,&quot;top&quot;:147.68133858267714,&quot;width&quot;:796.7787401574802}"/>
-</p:tagLst>
-</file>
-
-<file path=ppt/tags/tag22.xml><?xml version="1.0" encoding="utf-8"?>
-<p:tagLst xmlns:p="http://schemas.openxmlformats.org/presentationml/2006/main">
-  <p:tag name="KSO_WM_DIAGRAM_VIRTUALLY_FRAME" val="{&quot;height&quot;:326.1533070866142,&quot;left&quot;:100.62377952755905,&quot;top&quot;:147.68133858267714,&quot;width&quot;:796.7787401574802}"/>
-</p:tagLst>
-</file>
-
-<file path=ppt/tags/tag23.xml><?xml version="1.0" encoding="utf-8"?>
-<p:tagLst xmlns:p="http://schemas.openxmlformats.org/presentationml/2006/main">
-  <p:tag name="KSO_WM_DIAGRAM_VIRTUALLY_FRAME" val="{&quot;height&quot;:326.1533070866142,&quot;left&quot;:100.62377952755905,&quot;top&quot;:147.68133858267714,&quot;width&quot;:796.7787401574802}"/>
-</p:tagLst>
-</file>
-
-<file path=ppt/tags/tag24.xml><?xml version="1.0" encoding="utf-8"?>
-<p:tagLst xmlns:p="http://schemas.openxmlformats.org/presentationml/2006/main">
-  <p:tag name="KSO_WM_DIAGRAM_VIRTUALLY_FRAME" val="{&quot;height&quot;:326.1533070866142,&quot;left&quot;:100.62377952755905,&quot;top&quot;:147.68133858267714,&quot;width&quot;:796.7787401574802}"/>
-</p:tagLst>
-</file>
-
 <file path=ppt/tags/tag25.xml><?xml version="1.0" encoding="utf-8"?>
 <p:tagLst xmlns:p="http://schemas.openxmlformats.org/presentationml/2006/main">
   <p:tag name="COMMONDATA" val="eyJoZGlkIjoiY2I1OGY1YTNlMjQ3ZmI2ZGJjYWRlMmY0NmVmYTEzMTUifQ=="/>
   <p:tag name="commondata" val="eyJoZGlkIjoiODViY2JkMjU3NGYzZTEwMzZmMGFkZWViYmNkYWU3NDIifQ=="/>
-</p:tagLst>
-</file>
-
-<file path=ppt/tags/tag3.xml><?xml version="1.0" encoding="utf-8"?>
-<p:tagLst xmlns:p="http://schemas.openxmlformats.org/presentationml/2006/main">
-  <p:tag name="KSO_WM_DIAGRAM_VIRTUALLY_FRAME" val="{&quot;height&quot;:326.1533070866142,&quot;left&quot;:100.62377952755905,&quot;top&quot;:147.68133858267714,&quot;width&quot;:796.7787401574802}"/>
-</p:tagLst>
-</file>
-
-<file path=ppt/tags/tag4.xml><?xml version="1.0" encoding="utf-8"?>
-<p:tagLst xmlns:p="http://schemas.openxmlformats.org/presentationml/2006/main">
-  <p:tag name="KSO_WM_DIAGRAM_VIRTUALLY_FRAME" val="{&quot;height&quot;:326.1533070866142,&quot;left&quot;:100.62377952755905,&quot;top&quot;:147.68133858267714,&quot;width&quot;:796.7787401574802}"/>
-</p:tagLst>
-</file>
-
-<file path=ppt/tags/tag5.xml><?xml version="1.0" encoding="utf-8"?>
-<p:tagLst xmlns:p="http://schemas.openxmlformats.org/presentationml/2006/main">
-  <p:tag name="KSO_WM_DIAGRAM_VIRTUALLY_FRAME" val="{&quot;height&quot;:326.1533070866142,&quot;left&quot;:100.62377952755905,&quot;top&quot;:147.68133858267714,&quot;width&quot;:796.7787401574802}"/>
-</p:tagLst>
-</file>
-
-<file path=ppt/tags/tag6.xml><?xml version="1.0" encoding="utf-8"?>
-<p:tagLst xmlns:p="http://schemas.openxmlformats.org/presentationml/2006/main">
-  <p:tag name="KSO_WM_DIAGRAM_VIRTUALLY_FRAME" val="{&quot;height&quot;:326.1533070866142,&quot;left&quot;:100.62377952755905,&quot;top&quot;:147.68133858267714,&quot;width&quot;:796.7787401574802}"/>
-</p:tagLst>
-</file>
-
-<file path=ppt/tags/tag7.xml><?xml version="1.0" encoding="utf-8"?>
-<p:tagLst xmlns:p="http://schemas.openxmlformats.org/presentationml/2006/main">
-  <p:tag name="KSO_WM_DIAGRAM_VIRTUALLY_FRAME" val="{&quot;height&quot;:326.1533070866142,&quot;left&quot;:100.62377952755905,&quot;top&quot;:147.68133858267714,&quot;width&quot;:796.7787401574802}"/>
-</p:tagLst>
-</file>
-
-<file path=ppt/tags/tag8.xml><?xml version="1.0" encoding="utf-8"?>
-<p:tagLst xmlns:p="http://schemas.openxmlformats.org/presentationml/2006/main">
-  <p:tag name="KSO_WM_DIAGRAM_VIRTUALLY_FRAME" val="{&quot;height&quot;:326.1533070866142,&quot;left&quot;:100.62377952755905,&quot;top&quot;:147.68133858267714,&quot;width&quot;:796.7787401574802}"/>
-</p:tagLst>
-</file>
-
-<file path=ppt/tags/tag9.xml><?xml version="1.0" encoding="utf-8"?>
-<p:tagLst xmlns:p="http://schemas.openxmlformats.org/presentationml/2006/main">
-  <p:tag name="KSO_WM_DIAGRAM_VIRTUALLY_FRAME" val="{&quot;height&quot;:326.1533070866142,&quot;left&quot;:100.62377952755905,&quot;top&quot;:147.68133858267714,&quot;width&quot;:796.7787401574802}"/>
 </p:tagLst>
 </file>
 

</xml_diff>